<commit_message>
[DE-2182]: Added 3D MLOps intro documentation and 3D Data Viewers. Also added documentation for the AGTG algorithm.
</commit_message>
<xml_diff>
--- a/images_with_layers.pptx
+++ b/images_with_layers.pptx
@@ -5,12 +5,13 @@
     <p:sldMasterId id="2147483648" r:id="rId1"/>
   </p:sldMasterIdLst>
   <p:notesMasterIdLst>
-    <p:notesMasterId r:id="rId5"/>
+    <p:notesMasterId r:id="rId6"/>
   </p:notesMasterIdLst>
   <p:sldIdLst>
     <p:sldId id="256" r:id="rId2"/>
     <p:sldId id="257" r:id="rId3"/>
     <p:sldId id="259" r:id="rId4"/>
+    <p:sldId id="260" r:id="rId5"/>
   </p:sldIdLst>
   <p:sldSz cx="12192000" cy="6858000"/>
   <p:notesSz cx="6858000" cy="9144000"/>
@@ -117,9 +118,13 @@
             <p14:sldId id="256"/>
             <p14:sldId id="257"/>
             <p14:sldId id="259"/>
+            <p14:sldId id="260"/>
           </p14:sldIdLst>
         </p14:section>
       </p14:sectionLst>
+    </p:ext>
+    <p:ext uri="{EFAFB233-063F-42B5-8137-9DF3F51BA10A}">
+      <p15:sldGuideLst xmlns:p15="http://schemas.microsoft.com/office/powerpoint/2012/main"/>
     </p:ext>
   </p:extLst>
 </p:presentation>
@@ -617,7 +622,7 @@
           <a:p>
             <a:fld id="{E487E608-D9C6-4B3C-A9A4-BEAD08ECA06D}" type="datetimeFigureOut">
               <a:rPr lang="en-US" smtClean="0"/>
-              <a:t>9/15/2025</a:t>
+              <a:t>9/16/2025</a:t>
             </a:fld>
             <a:endParaRPr lang="en-US"/>
           </a:p>
@@ -1483,7 +1488,7 @@
           <a:p>
             <a:fld id="{D241CDF3-A1FB-4215-9C3B-B36887AAFAD2}" type="datetimeFigureOut">
               <a:rPr lang="en-US" smtClean="0"/>
-              <a:t>9/15/2025</a:t>
+              <a:t>9/16/2025</a:t>
             </a:fld>
             <a:endParaRPr lang="en-US"/>
           </a:p>
@@ -1681,7 +1686,7 @@
           <a:p>
             <a:fld id="{D241CDF3-A1FB-4215-9C3B-B36887AAFAD2}" type="datetimeFigureOut">
               <a:rPr lang="en-US" smtClean="0"/>
-              <a:t>9/15/2025</a:t>
+              <a:t>9/16/2025</a:t>
             </a:fld>
             <a:endParaRPr lang="en-US"/>
           </a:p>
@@ -1889,7 +1894,7 @@
           <a:p>
             <a:fld id="{D241CDF3-A1FB-4215-9C3B-B36887AAFAD2}" type="datetimeFigureOut">
               <a:rPr lang="en-US" smtClean="0"/>
-              <a:t>9/15/2025</a:t>
+              <a:t>9/16/2025</a:t>
             </a:fld>
             <a:endParaRPr lang="en-US"/>
           </a:p>
@@ -2087,7 +2092,7 @@
           <a:p>
             <a:fld id="{D241CDF3-A1FB-4215-9C3B-B36887AAFAD2}" type="datetimeFigureOut">
               <a:rPr lang="en-US" smtClean="0"/>
-              <a:t>9/15/2025</a:t>
+              <a:t>9/16/2025</a:t>
             </a:fld>
             <a:endParaRPr lang="en-US"/>
           </a:p>
@@ -2362,7 +2367,7 @@
           <a:p>
             <a:fld id="{D241CDF3-A1FB-4215-9C3B-B36887AAFAD2}" type="datetimeFigureOut">
               <a:rPr lang="en-US" smtClean="0"/>
-              <a:t>9/15/2025</a:t>
+              <a:t>9/16/2025</a:t>
             </a:fld>
             <a:endParaRPr lang="en-US"/>
           </a:p>
@@ -2627,7 +2632,7 @@
           <a:p>
             <a:fld id="{D241CDF3-A1FB-4215-9C3B-B36887AAFAD2}" type="datetimeFigureOut">
               <a:rPr lang="en-US" smtClean="0"/>
-              <a:t>9/15/2025</a:t>
+              <a:t>9/16/2025</a:t>
             </a:fld>
             <a:endParaRPr lang="en-US"/>
           </a:p>
@@ -3039,7 +3044,7 @@
           <a:p>
             <a:fld id="{D241CDF3-A1FB-4215-9C3B-B36887AAFAD2}" type="datetimeFigureOut">
               <a:rPr lang="en-US" smtClean="0"/>
-              <a:t>9/15/2025</a:t>
+              <a:t>9/16/2025</a:t>
             </a:fld>
             <a:endParaRPr lang="en-US"/>
           </a:p>
@@ -3180,7 +3185,7 @@
           <a:p>
             <a:fld id="{D241CDF3-A1FB-4215-9C3B-B36887AAFAD2}" type="datetimeFigureOut">
               <a:rPr lang="en-US" smtClean="0"/>
-              <a:t>9/15/2025</a:t>
+              <a:t>9/16/2025</a:t>
             </a:fld>
             <a:endParaRPr lang="en-US"/>
           </a:p>
@@ -3293,7 +3298,7 @@
           <a:p>
             <a:fld id="{D241CDF3-A1FB-4215-9C3B-B36887AAFAD2}" type="datetimeFigureOut">
               <a:rPr lang="en-US" smtClean="0"/>
-              <a:t>9/15/2025</a:t>
+              <a:t>9/16/2025</a:t>
             </a:fld>
             <a:endParaRPr lang="en-US"/>
           </a:p>
@@ -3604,7 +3609,7 @@
           <a:p>
             <a:fld id="{D241CDF3-A1FB-4215-9C3B-B36887AAFAD2}" type="datetimeFigureOut">
               <a:rPr lang="en-US" smtClean="0"/>
-              <a:t>9/15/2025</a:t>
+              <a:t>9/16/2025</a:t>
             </a:fld>
             <a:endParaRPr lang="en-US"/>
           </a:p>
@@ -3892,7 +3897,7 @@
           <a:p>
             <a:fld id="{D241CDF3-A1FB-4215-9C3B-B36887AAFAD2}" type="datetimeFigureOut">
               <a:rPr lang="en-US" smtClean="0"/>
-              <a:t>9/15/2025</a:t>
+              <a:t>9/16/2025</a:t>
             </a:fld>
             <a:endParaRPr lang="en-US"/>
           </a:p>
@@ -4133,7 +4138,7 @@
           <a:p>
             <a:fld id="{D241CDF3-A1FB-4215-9C3B-B36887AAFAD2}" type="datetimeFigureOut">
               <a:rPr lang="en-US" smtClean="0"/>
-              <a:t>9/15/2025</a:t>
+              <a:t>9/16/2025</a:t>
             </a:fld>
             <a:endParaRPr lang="en-US"/>
           </a:p>
@@ -6239,6 +6244,488 @@
     <p:extLst>
       <p:ext uri="{BB962C8B-B14F-4D97-AF65-F5344CB8AC3E}">
         <p14:creationId xmlns:p14="http://schemas.microsoft.com/office/powerpoint/2010/main" val="1838129098"/>
+      </p:ext>
+    </p:extLst>
+  </p:cSld>
+  <p:clrMapOvr>
+    <a:masterClrMapping/>
+  </p:clrMapOvr>
+</p:sld>
+</file>
+
+<file path=ppt/slides/slide4.xml><?xml version="1.0" encoding="utf-8"?>
+<p:sld xmlns:a="http://schemas.openxmlformats.org/drawingml/2006/main" xmlns:r="http://schemas.openxmlformats.org/officeDocument/2006/relationships" xmlns:p="http://schemas.openxmlformats.org/presentationml/2006/main">
+  <p:cSld>
+    <p:spTree>
+      <p:nvGrpSpPr>
+        <p:cNvPr id="1" name=""/>
+        <p:cNvGrpSpPr/>
+        <p:nvPr/>
+      </p:nvGrpSpPr>
+      <p:grpSpPr>
+        <a:xfrm>
+          <a:off x="0" y="0"/>
+          <a:ext cx="0" cy="0"/>
+          <a:chOff x="0" y="0"/>
+          <a:chExt cx="0" cy="0"/>
+        </a:xfrm>
+      </p:grpSpPr>
+      <p:pic>
+        <p:nvPicPr>
+          <p:cNvPr id="5" name="Picture 4">
+            <a:extLst>
+              <a:ext uri="{FF2B5EF4-FFF2-40B4-BE49-F238E27FC236}">
+                <a16:creationId xmlns:a16="http://schemas.microsoft.com/office/drawing/2014/main" id="{08CDB1DE-94D6-D866-9238-5CD12107B803}"/>
+              </a:ext>
+            </a:extLst>
+          </p:cNvPr>
+          <p:cNvPicPr>
+            <a:picLocks noChangeAspect="1"/>
+          </p:cNvPicPr>
+          <p:nvPr/>
+        </p:nvPicPr>
+        <p:blipFill>
+          <a:blip r:embed="rId2"/>
+          <a:stretch>
+            <a:fillRect/>
+          </a:stretch>
+        </p:blipFill>
+        <p:spPr>
+          <a:xfrm>
+            <a:off x="4693737" y="0"/>
+            <a:ext cx="2804526" cy="6858000"/>
+          </a:xfrm>
+          <a:prstGeom prst="rect">
+            <a:avLst/>
+          </a:prstGeom>
+        </p:spPr>
+      </p:pic>
+      <p:sp>
+        <p:nvSpPr>
+          <p:cNvPr id="6" name="TextBox 5">
+            <a:extLst>
+              <a:ext uri="{FF2B5EF4-FFF2-40B4-BE49-F238E27FC236}">
+                <a16:creationId xmlns:a16="http://schemas.microsoft.com/office/drawing/2014/main" id="{4C2336B3-D2FD-E5AA-C4B9-A28F097B6112}"/>
+              </a:ext>
+            </a:extLst>
+          </p:cNvPr>
+          <p:cNvSpPr txBox="1"/>
+          <p:nvPr/>
+        </p:nvSpPr>
+        <p:spPr>
+          <a:xfrm>
+            <a:off x="4385639" y="2830286"/>
+            <a:ext cx="308098" cy="369332"/>
+          </a:xfrm>
+          <a:prstGeom prst="rect">
+            <a:avLst/>
+          </a:prstGeom>
+          <a:noFill/>
+        </p:spPr>
+        <p:txBody>
+          <a:bodyPr wrap="none" rtlCol="0">
+            <a:spAutoFit/>
+          </a:bodyPr>
+          <a:lstStyle/>
+          <a:p>
+            <a:r>
+              <a:rPr lang="en-US" dirty="0">
+                <a:solidFill>
+                  <a:srgbClr val="FF0000"/>
+                </a:solidFill>
+              </a:rPr>
+              <a:t>1</a:t>
+            </a:r>
+          </a:p>
+        </p:txBody>
+      </p:sp>
+      <p:sp>
+        <p:nvSpPr>
+          <p:cNvPr id="7" name="Rectangle 6">
+            <a:extLst>
+              <a:ext uri="{FF2B5EF4-FFF2-40B4-BE49-F238E27FC236}">
+                <a16:creationId xmlns:a16="http://schemas.microsoft.com/office/drawing/2014/main" id="{241A92DB-5AB1-7703-5285-5C63D5BA07F1}"/>
+              </a:ext>
+            </a:extLst>
+          </p:cNvPr>
+          <p:cNvSpPr/>
+          <p:nvPr/>
+        </p:nvSpPr>
+        <p:spPr>
+          <a:xfrm>
+            <a:off x="4693737" y="2830286"/>
+            <a:ext cx="2804526" cy="362857"/>
+          </a:xfrm>
+          <a:prstGeom prst="rect">
+            <a:avLst/>
+          </a:prstGeom>
+          <a:noFill/>
+          <a:ln w="38100">
+            <a:solidFill>
+              <a:srgbClr val="FF0000"/>
+            </a:solidFill>
+          </a:ln>
+        </p:spPr>
+        <p:style>
+          <a:lnRef idx="2">
+            <a:schemeClr val="accent1">
+              <a:shade val="15000"/>
+            </a:schemeClr>
+          </a:lnRef>
+          <a:fillRef idx="1">
+            <a:schemeClr val="accent1"/>
+          </a:fillRef>
+          <a:effectRef idx="0">
+            <a:schemeClr val="accent1"/>
+          </a:effectRef>
+          <a:fontRef idx="minor">
+            <a:schemeClr val="lt1"/>
+          </a:fontRef>
+        </p:style>
+        <p:txBody>
+          <a:bodyPr rtlCol="0" anchor="ctr"/>
+          <a:lstStyle/>
+          <a:p>
+            <a:pPr algn="ctr"/>
+            <a:endParaRPr lang="en-US">
+              <a:ln w="0"/>
+              <a:solidFill>
+                <a:schemeClr val="tx1"/>
+              </a:solidFill>
+              <a:effectLst>
+                <a:outerShdw blurRad="38100" dist="19050" dir="2700000" algn="tl" rotWithShape="0">
+                  <a:schemeClr val="dk1">
+                    <a:alpha val="40000"/>
+                  </a:schemeClr>
+                </a:outerShdw>
+              </a:effectLst>
+            </a:endParaRPr>
+          </a:p>
+        </p:txBody>
+      </p:sp>
+      <p:sp>
+        <p:nvSpPr>
+          <p:cNvPr id="8" name="Rectangle 7">
+            <a:extLst>
+              <a:ext uri="{FF2B5EF4-FFF2-40B4-BE49-F238E27FC236}">
+                <a16:creationId xmlns:a16="http://schemas.microsoft.com/office/drawing/2014/main" id="{8E6F0C0F-5D4E-B0C9-801B-32CAF110D070}"/>
+              </a:ext>
+            </a:extLst>
+          </p:cNvPr>
+          <p:cNvSpPr/>
+          <p:nvPr/>
+        </p:nvSpPr>
+        <p:spPr>
+          <a:xfrm>
+            <a:off x="4693737" y="3991428"/>
+            <a:ext cx="2804526" cy="362857"/>
+          </a:xfrm>
+          <a:prstGeom prst="rect">
+            <a:avLst/>
+          </a:prstGeom>
+          <a:noFill/>
+          <a:ln w="38100">
+            <a:solidFill>
+              <a:srgbClr val="FF0000"/>
+            </a:solidFill>
+          </a:ln>
+        </p:spPr>
+        <p:style>
+          <a:lnRef idx="2">
+            <a:schemeClr val="accent1">
+              <a:shade val="15000"/>
+            </a:schemeClr>
+          </a:lnRef>
+          <a:fillRef idx="1">
+            <a:schemeClr val="accent1"/>
+          </a:fillRef>
+          <a:effectRef idx="0">
+            <a:schemeClr val="accent1"/>
+          </a:effectRef>
+          <a:fontRef idx="minor">
+            <a:schemeClr val="lt1"/>
+          </a:fontRef>
+        </p:style>
+        <p:txBody>
+          <a:bodyPr rtlCol="0" anchor="ctr"/>
+          <a:lstStyle/>
+          <a:p>
+            <a:pPr algn="ctr"/>
+            <a:endParaRPr lang="en-US">
+              <a:ln w="0"/>
+              <a:solidFill>
+                <a:schemeClr val="tx1"/>
+              </a:solidFill>
+              <a:effectLst>
+                <a:outerShdw blurRad="38100" dist="19050" dir="2700000" algn="tl" rotWithShape="0">
+                  <a:schemeClr val="dk1">
+                    <a:alpha val="40000"/>
+                  </a:schemeClr>
+                </a:outerShdw>
+              </a:effectLst>
+            </a:endParaRPr>
+          </a:p>
+        </p:txBody>
+      </p:sp>
+      <p:sp>
+        <p:nvSpPr>
+          <p:cNvPr id="9" name="Rectangle 8">
+            <a:extLst>
+              <a:ext uri="{FF2B5EF4-FFF2-40B4-BE49-F238E27FC236}">
+                <a16:creationId xmlns:a16="http://schemas.microsoft.com/office/drawing/2014/main" id="{55DD43E3-001F-C246-5AD9-4A9DE88CA6AA}"/>
+              </a:ext>
+            </a:extLst>
+          </p:cNvPr>
+          <p:cNvSpPr/>
+          <p:nvPr/>
+        </p:nvSpPr>
+        <p:spPr>
+          <a:xfrm>
+            <a:off x="4693737" y="4550230"/>
+            <a:ext cx="2804526" cy="362857"/>
+          </a:xfrm>
+          <a:prstGeom prst="rect">
+            <a:avLst/>
+          </a:prstGeom>
+          <a:noFill/>
+          <a:ln w="38100">
+            <a:solidFill>
+              <a:srgbClr val="FF0000"/>
+            </a:solidFill>
+          </a:ln>
+        </p:spPr>
+        <p:style>
+          <a:lnRef idx="2">
+            <a:schemeClr val="accent1">
+              <a:shade val="15000"/>
+            </a:schemeClr>
+          </a:lnRef>
+          <a:fillRef idx="1">
+            <a:schemeClr val="accent1"/>
+          </a:fillRef>
+          <a:effectRef idx="0">
+            <a:schemeClr val="accent1"/>
+          </a:effectRef>
+          <a:fontRef idx="minor">
+            <a:schemeClr val="lt1"/>
+          </a:fontRef>
+        </p:style>
+        <p:txBody>
+          <a:bodyPr rtlCol="0" anchor="ctr"/>
+          <a:lstStyle/>
+          <a:p>
+            <a:pPr algn="ctr"/>
+            <a:endParaRPr lang="en-US">
+              <a:ln w="0"/>
+              <a:solidFill>
+                <a:schemeClr val="tx1"/>
+              </a:solidFill>
+              <a:effectLst>
+                <a:outerShdw blurRad="38100" dist="19050" dir="2700000" algn="tl" rotWithShape="0">
+                  <a:schemeClr val="dk1">
+                    <a:alpha val="40000"/>
+                  </a:schemeClr>
+                </a:outerShdw>
+              </a:effectLst>
+            </a:endParaRPr>
+          </a:p>
+        </p:txBody>
+      </p:sp>
+      <p:sp>
+        <p:nvSpPr>
+          <p:cNvPr id="10" name="Rectangle 9">
+            <a:extLst>
+              <a:ext uri="{FF2B5EF4-FFF2-40B4-BE49-F238E27FC236}">
+                <a16:creationId xmlns:a16="http://schemas.microsoft.com/office/drawing/2014/main" id="{495B6F51-0B07-0B59-1DC5-50DAA14F2E82}"/>
+              </a:ext>
+            </a:extLst>
+          </p:cNvPr>
+          <p:cNvSpPr/>
+          <p:nvPr/>
+        </p:nvSpPr>
+        <p:spPr>
+          <a:xfrm>
+            <a:off x="4693737" y="5109032"/>
+            <a:ext cx="2804526" cy="362857"/>
+          </a:xfrm>
+          <a:prstGeom prst="rect">
+            <a:avLst/>
+          </a:prstGeom>
+          <a:noFill/>
+          <a:ln w="38100">
+            <a:solidFill>
+              <a:srgbClr val="FF0000"/>
+            </a:solidFill>
+          </a:ln>
+        </p:spPr>
+        <p:style>
+          <a:lnRef idx="2">
+            <a:schemeClr val="accent1">
+              <a:shade val="15000"/>
+            </a:schemeClr>
+          </a:lnRef>
+          <a:fillRef idx="1">
+            <a:schemeClr val="accent1"/>
+          </a:fillRef>
+          <a:effectRef idx="0">
+            <a:schemeClr val="accent1"/>
+          </a:effectRef>
+          <a:fontRef idx="minor">
+            <a:schemeClr val="lt1"/>
+          </a:fontRef>
+        </p:style>
+        <p:txBody>
+          <a:bodyPr rtlCol="0" anchor="ctr"/>
+          <a:lstStyle/>
+          <a:p>
+            <a:pPr algn="ctr"/>
+            <a:endParaRPr lang="en-US">
+              <a:ln w="0"/>
+              <a:solidFill>
+                <a:schemeClr val="tx1"/>
+              </a:solidFill>
+              <a:effectLst>
+                <a:outerShdw blurRad="38100" dist="19050" dir="2700000" algn="tl" rotWithShape="0">
+                  <a:schemeClr val="dk1">
+                    <a:alpha val="40000"/>
+                  </a:schemeClr>
+                </a:outerShdw>
+              </a:effectLst>
+            </a:endParaRPr>
+          </a:p>
+        </p:txBody>
+      </p:sp>
+      <p:sp>
+        <p:nvSpPr>
+          <p:cNvPr id="12" name="TextBox 11">
+            <a:extLst>
+              <a:ext uri="{FF2B5EF4-FFF2-40B4-BE49-F238E27FC236}">
+                <a16:creationId xmlns:a16="http://schemas.microsoft.com/office/drawing/2014/main" id="{CD7D68FD-AE43-BDD7-ED5A-234645335C58}"/>
+              </a:ext>
+            </a:extLst>
+          </p:cNvPr>
+          <p:cNvSpPr txBox="1"/>
+          <p:nvPr/>
+        </p:nvSpPr>
+        <p:spPr>
+          <a:xfrm>
+            <a:off x="4385639" y="3984953"/>
+            <a:ext cx="308098" cy="369332"/>
+          </a:xfrm>
+          <a:prstGeom prst="rect">
+            <a:avLst/>
+          </a:prstGeom>
+          <a:noFill/>
+        </p:spPr>
+        <p:txBody>
+          <a:bodyPr wrap="none" rtlCol="0">
+            <a:spAutoFit/>
+          </a:bodyPr>
+          <a:lstStyle/>
+          <a:p>
+            <a:r>
+              <a:rPr lang="en-CA" dirty="0">
+                <a:solidFill>
+                  <a:srgbClr val="FF0000"/>
+                </a:solidFill>
+              </a:rPr>
+              <a:t>2</a:t>
+            </a:r>
+            <a:endParaRPr lang="en-US" dirty="0">
+              <a:solidFill>
+                <a:srgbClr val="FF0000"/>
+              </a:solidFill>
+            </a:endParaRPr>
+          </a:p>
+        </p:txBody>
+      </p:sp>
+      <p:sp>
+        <p:nvSpPr>
+          <p:cNvPr id="13" name="TextBox 12">
+            <a:extLst>
+              <a:ext uri="{FF2B5EF4-FFF2-40B4-BE49-F238E27FC236}">
+                <a16:creationId xmlns:a16="http://schemas.microsoft.com/office/drawing/2014/main" id="{DA8C9A3F-6F1A-08BD-E751-BBE6C250C608}"/>
+              </a:ext>
+            </a:extLst>
+          </p:cNvPr>
+          <p:cNvSpPr txBox="1"/>
+          <p:nvPr/>
+        </p:nvSpPr>
+        <p:spPr>
+          <a:xfrm>
+            <a:off x="4385639" y="4546992"/>
+            <a:ext cx="308098" cy="369332"/>
+          </a:xfrm>
+          <a:prstGeom prst="rect">
+            <a:avLst/>
+          </a:prstGeom>
+          <a:noFill/>
+        </p:spPr>
+        <p:txBody>
+          <a:bodyPr wrap="none" rtlCol="0">
+            <a:spAutoFit/>
+          </a:bodyPr>
+          <a:lstStyle/>
+          <a:p>
+            <a:r>
+              <a:rPr lang="en-US" dirty="0">
+                <a:solidFill>
+                  <a:srgbClr val="FF0000"/>
+                </a:solidFill>
+              </a:rPr>
+              <a:t>3</a:t>
+            </a:r>
+          </a:p>
+        </p:txBody>
+      </p:sp>
+      <p:sp>
+        <p:nvSpPr>
+          <p:cNvPr id="14" name="TextBox 13">
+            <a:extLst>
+              <a:ext uri="{FF2B5EF4-FFF2-40B4-BE49-F238E27FC236}">
+                <a16:creationId xmlns:a16="http://schemas.microsoft.com/office/drawing/2014/main" id="{C145E54B-8DD3-7459-0822-D57905D55D04}"/>
+              </a:ext>
+            </a:extLst>
+          </p:cNvPr>
+          <p:cNvSpPr txBox="1"/>
+          <p:nvPr/>
+        </p:nvSpPr>
+        <p:spPr>
+          <a:xfrm>
+            <a:off x="4385639" y="5114220"/>
+            <a:ext cx="308098" cy="369332"/>
+          </a:xfrm>
+          <a:prstGeom prst="rect">
+            <a:avLst/>
+          </a:prstGeom>
+          <a:noFill/>
+        </p:spPr>
+        <p:txBody>
+          <a:bodyPr wrap="none" rtlCol="0">
+            <a:spAutoFit/>
+          </a:bodyPr>
+          <a:lstStyle/>
+          <a:p>
+            <a:r>
+              <a:rPr lang="en-CA" dirty="0">
+                <a:solidFill>
+                  <a:srgbClr val="FF0000"/>
+                </a:solidFill>
+              </a:rPr>
+              <a:t>4</a:t>
+            </a:r>
+            <a:endParaRPr lang="en-US" dirty="0">
+              <a:solidFill>
+                <a:srgbClr val="FF0000"/>
+              </a:solidFill>
+            </a:endParaRPr>
+          </a:p>
+        </p:txBody>
+      </p:sp>
+    </p:spTree>
+    <p:extLst>
+      <p:ext uri="{BB962C8B-B14F-4D97-AF65-F5344CB8AC3E}">
+        <p14:creationId xmlns:p14="http://schemas.microsoft.com/office/powerpoint/2010/main" val="2371670190"/>
       </p:ext>
     </p:extLst>
   </p:cSld>

</xml_diff>

<commit_message>
* Minor Playing Card fix * Updates for image holder PP
</commit_message>
<xml_diff>
--- a/images_with_layers.pptx
+++ b/images_with_layers.pptx
@@ -5,13 +5,15 @@
     <p:sldMasterId id="2147483648" r:id="rId1"/>
   </p:sldMasterIdLst>
   <p:notesMasterIdLst>
-    <p:notesMasterId r:id="rId6"/>
+    <p:notesMasterId r:id="rId8"/>
   </p:notesMasterIdLst>
   <p:sldIdLst>
-    <p:sldId id="256" r:id="rId2"/>
-    <p:sldId id="257" r:id="rId3"/>
-    <p:sldId id="259" r:id="rId4"/>
-    <p:sldId id="260" r:id="rId5"/>
+    <p:sldId id="261" r:id="rId2"/>
+    <p:sldId id="256" r:id="rId3"/>
+    <p:sldId id="257" r:id="rId4"/>
+    <p:sldId id="259" r:id="rId5"/>
+    <p:sldId id="262" r:id="rId6"/>
+    <p:sldId id="260" r:id="rId7"/>
   </p:sldIdLst>
   <p:sldSz cx="12192000" cy="6858000"/>
   <p:notesSz cx="6858000" cy="9144000"/>
@@ -115,9 +117,15 @@
       <p14:sectionLst xmlns:p14="http://schemas.microsoft.com/office/powerpoint/2010/main">
         <p14:section name="Home Page and Variants" id="{9EE3B63E-DA1C-47B6-82D6-E79847A08A80}">
           <p14:sldIdLst>
+            <p14:sldId id="261"/>
             <p14:sldId id="256"/>
             <p14:sldId id="257"/>
             <p14:sldId id="259"/>
+          </p14:sldIdLst>
+        </p14:section>
+        <p14:section name="Dataset Gallery" id="{69866AF7-968C-4F26-9ECA-AA64F6FFB6E8}">
+          <p14:sldIdLst>
+            <p14:sldId id="262"/>
             <p14:sldId id="260"/>
           </p14:sldIdLst>
         </p14:section>
@@ -622,7 +630,7 @@
           <a:p>
             <a:fld id="{E487E608-D9C6-4B3C-A9A4-BEAD08ECA06D}" type="datetimeFigureOut">
               <a:rPr lang="en-US" smtClean="0"/>
-              <a:t>9/16/2025</a:t>
+              <a:t>9/19/2025</a:t>
             </a:fld>
             <a:endParaRPr lang="en-US"/>
           </a:p>
@@ -952,29 +960,6 @@
             </a:pPr>
             <a:r>
               <a:rPr lang="en-US" dirty="0"/>
-              <a:t>Unmarked:  /docs/studio/assets/user/home-page.png</a:t>
-            </a:r>
-          </a:p>
-          <a:p>
-            <a:pPr marL="0" marR="0" lvl="0" indent="0" algn="l" defTabSz="914400" rtl="0" eaLnBrk="1" fontAlgn="auto" latinLnBrk="0" hangingPunct="1">
-              <a:lnSpc>
-                <a:spcPct val="100000"/>
-              </a:lnSpc>
-              <a:spcBef>
-                <a:spcPts val="0"/>
-              </a:spcBef>
-              <a:spcAft>
-                <a:spcPts val="0"/>
-              </a:spcAft>
-              <a:buClrTx/>
-              <a:buSzTx/>
-              <a:buFontTx/>
-              <a:buNone/>
-              <a:tabLst/>
-              <a:defRPr/>
-            </a:pPr>
-            <a:r>
-              <a:rPr lang="en-US" dirty="0"/>
               <a:t>Marked:  /docs/studio/assets/user/home-page-breakdown.png</a:t>
             </a:r>
           </a:p>
@@ -1020,7 +1005,7 @@
           <a:p>
             <a:fld id="{874397DF-5812-45E4-B5F0-BF2AEB9BFE48}" type="slidenum">
               <a:rPr lang="en-US" smtClean="0"/>
-              <a:t>1</a:t>
+              <a:t>2</a:t>
             </a:fld>
             <a:endParaRPr lang="en-US"/>
           </a:p>
@@ -1171,7 +1156,7 @@
           <a:p>
             <a:fld id="{874397DF-5812-45E4-B5F0-BF2AEB9BFE48}" type="slidenum">
               <a:rPr lang="en-US" smtClean="0"/>
-              <a:t>2</a:t>
+              <a:t>3</a:t>
             </a:fld>
             <a:endParaRPr lang="en-US"/>
           </a:p>
@@ -1322,7 +1307,7 @@
           <a:p>
             <a:fld id="{874397DF-5812-45E4-B5F0-BF2AEB9BFE48}" type="slidenum">
               <a:rPr lang="en-US" smtClean="0"/>
-              <a:t>3</a:t>
+              <a:t>4</a:t>
             </a:fld>
             <a:endParaRPr lang="en-US"/>
           </a:p>
@@ -1332,6 +1317,106 @@
     <p:extLst>
       <p:ext uri="{BB962C8B-B14F-4D97-AF65-F5344CB8AC3E}">
         <p14:creationId xmlns:p14="http://schemas.microsoft.com/office/powerpoint/2010/main" val="3074423555"/>
+      </p:ext>
+    </p:extLst>
+  </p:cSld>
+  <p:clrMapOvr>
+    <a:masterClrMapping/>
+  </p:clrMapOvr>
+</p:notes>
+</file>
+
+<file path=ppt/notesSlides/notesSlide4.xml><?xml version="1.0" encoding="utf-8"?>
+<p:notes xmlns:a="http://schemas.openxmlformats.org/drawingml/2006/main" xmlns:r="http://schemas.openxmlformats.org/officeDocument/2006/relationships" xmlns:p="http://schemas.openxmlformats.org/presentationml/2006/main">
+  <p:cSld>
+    <p:spTree>
+      <p:nvGrpSpPr>
+        <p:cNvPr id="1" name=""/>
+        <p:cNvGrpSpPr/>
+        <p:nvPr/>
+      </p:nvGrpSpPr>
+      <p:grpSpPr>
+        <a:xfrm>
+          <a:off x="0" y="0"/>
+          <a:ext cx="0" cy="0"/>
+          <a:chOff x="0" y="0"/>
+          <a:chExt cx="0" cy="0"/>
+        </a:xfrm>
+      </p:grpSpPr>
+      <p:sp>
+        <p:nvSpPr>
+          <p:cNvPr id="2" name="Slide Image Placeholder 1"/>
+          <p:cNvSpPr>
+            <a:spLocks noGrp="1" noRot="1" noChangeAspect="1"/>
+          </p:cNvSpPr>
+          <p:nvPr>
+            <p:ph type="sldImg"/>
+          </p:nvPr>
+        </p:nvSpPr>
+        <p:spPr/>
+      </p:sp>
+      <p:sp>
+        <p:nvSpPr>
+          <p:cNvPr id="3" name="Notes Placeholder 2"/>
+          <p:cNvSpPr>
+            <a:spLocks noGrp="1"/>
+          </p:cNvSpPr>
+          <p:nvPr>
+            <p:ph type="body" idx="1"/>
+          </p:nvPr>
+        </p:nvSpPr>
+        <p:spPr/>
+        <p:txBody>
+          <a:bodyPr/>
+          <a:lstStyle/>
+          <a:p>
+            <a:r>
+              <a:rPr lang="en-US" dirty="0"/>
+              <a:t>Marked:  </a:t>
+            </a:r>
+            <a:r>
+              <a:rPr lang="en-US" sz="1200" b="0" i="0" kern="1200" dirty="0">
+                <a:solidFill>
+                  <a:schemeClr val="tx1"/>
+                </a:solidFill>
+                <a:effectLst/>
+                <a:latin typeface="+mn-lt"/>
+                <a:ea typeface="+mn-ea"/>
+                <a:cs typeface="+mn-cs"/>
+              </a:rPr>
+              <a:t>docs/3D/assets/3d_viewers.jpg</a:t>
+            </a:r>
+            <a:endParaRPr lang="en-US" dirty="0"/>
+          </a:p>
+        </p:txBody>
+      </p:sp>
+      <p:sp>
+        <p:nvSpPr>
+          <p:cNvPr id="4" name="Slide Number Placeholder 3"/>
+          <p:cNvSpPr>
+            <a:spLocks noGrp="1"/>
+          </p:cNvSpPr>
+          <p:nvPr>
+            <p:ph type="sldNum" sz="quarter" idx="5"/>
+          </p:nvPr>
+        </p:nvSpPr>
+        <p:spPr/>
+        <p:txBody>
+          <a:bodyPr/>
+          <a:lstStyle/>
+          <a:p>
+            <a:fld id="{874397DF-5812-45E4-B5F0-BF2AEB9BFE48}" type="slidenum">
+              <a:rPr lang="en-US" smtClean="0"/>
+              <a:t>6</a:t>
+            </a:fld>
+            <a:endParaRPr lang="en-US"/>
+          </a:p>
+        </p:txBody>
+      </p:sp>
+    </p:spTree>
+    <p:extLst>
+      <p:ext uri="{BB962C8B-B14F-4D97-AF65-F5344CB8AC3E}">
+        <p14:creationId xmlns:p14="http://schemas.microsoft.com/office/powerpoint/2010/main" val="302560666"/>
       </p:ext>
     </p:extLst>
   </p:cSld>
@@ -1488,7 +1573,7 @@
           <a:p>
             <a:fld id="{D241CDF3-A1FB-4215-9C3B-B36887AAFAD2}" type="datetimeFigureOut">
               <a:rPr lang="en-US" smtClean="0"/>
-              <a:t>9/16/2025</a:t>
+              <a:t>9/19/2025</a:t>
             </a:fld>
             <a:endParaRPr lang="en-US"/>
           </a:p>
@@ -1686,7 +1771,7 @@
           <a:p>
             <a:fld id="{D241CDF3-A1FB-4215-9C3B-B36887AAFAD2}" type="datetimeFigureOut">
               <a:rPr lang="en-US" smtClean="0"/>
-              <a:t>9/16/2025</a:t>
+              <a:t>9/19/2025</a:t>
             </a:fld>
             <a:endParaRPr lang="en-US"/>
           </a:p>
@@ -1894,7 +1979,7 @@
           <a:p>
             <a:fld id="{D241CDF3-A1FB-4215-9C3B-B36887AAFAD2}" type="datetimeFigureOut">
               <a:rPr lang="en-US" smtClean="0"/>
-              <a:t>9/16/2025</a:t>
+              <a:t>9/19/2025</a:t>
             </a:fld>
             <a:endParaRPr lang="en-US"/>
           </a:p>
@@ -2092,7 +2177,7 @@
           <a:p>
             <a:fld id="{D241CDF3-A1FB-4215-9C3B-B36887AAFAD2}" type="datetimeFigureOut">
               <a:rPr lang="en-US" smtClean="0"/>
-              <a:t>9/16/2025</a:t>
+              <a:t>9/19/2025</a:t>
             </a:fld>
             <a:endParaRPr lang="en-US"/>
           </a:p>
@@ -2367,7 +2452,7 @@
           <a:p>
             <a:fld id="{D241CDF3-A1FB-4215-9C3B-B36887AAFAD2}" type="datetimeFigureOut">
               <a:rPr lang="en-US" smtClean="0"/>
-              <a:t>9/16/2025</a:t>
+              <a:t>9/19/2025</a:t>
             </a:fld>
             <a:endParaRPr lang="en-US"/>
           </a:p>
@@ -2632,7 +2717,7 @@
           <a:p>
             <a:fld id="{D241CDF3-A1FB-4215-9C3B-B36887AAFAD2}" type="datetimeFigureOut">
               <a:rPr lang="en-US" smtClean="0"/>
-              <a:t>9/16/2025</a:t>
+              <a:t>9/19/2025</a:t>
             </a:fld>
             <a:endParaRPr lang="en-US"/>
           </a:p>
@@ -3044,7 +3129,7 @@
           <a:p>
             <a:fld id="{D241CDF3-A1FB-4215-9C3B-B36887AAFAD2}" type="datetimeFigureOut">
               <a:rPr lang="en-US" smtClean="0"/>
-              <a:t>9/16/2025</a:t>
+              <a:t>9/19/2025</a:t>
             </a:fld>
             <a:endParaRPr lang="en-US"/>
           </a:p>
@@ -3185,7 +3270,7 @@
           <a:p>
             <a:fld id="{D241CDF3-A1FB-4215-9C3B-B36887AAFAD2}" type="datetimeFigureOut">
               <a:rPr lang="en-US" smtClean="0"/>
-              <a:t>9/16/2025</a:t>
+              <a:t>9/19/2025</a:t>
             </a:fld>
             <a:endParaRPr lang="en-US"/>
           </a:p>
@@ -3298,7 +3383,7 @@
           <a:p>
             <a:fld id="{D241CDF3-A1FB-4215-9C3B-B36887AAFAD2}" type="datetimeFigureOut">
               <a:rPr lang="en-US" smtClean="0"/>
-              <a:t>9/16/2025</a:t>
+              <a:t>9/19/2025</a:t>
             </a:fld>
             <a:endParaRPr lang="en-US"/>
           </a:p>
@@ -3609,7 +3694,7 @@
           <a:p>
             <a:fld id="{D241CDF3-A1FB-4215-9C3B-B36887AAFAD2}" type="datetimeFigureOut">
               <a:rPr lang="en-US" smtClean="0"/>
-              <a:t>9/16/2025</a:t>
+              <a:t>9/19/2025</a:t>
             </a:fld>
             <a:endParaRPr lang="en-US"/>
           </a:p>
@@ -3897,7 +3982,7 @@
           <a:p>
             <a:fld id="{D241CDF3-A1FB-4215-9C3B-B36887AAFAD2}" type="datetimeFigureOut">
               <a:rPr lang="en-US" smtClean="0"/>
-              <a:t>9/16/2025</a:t>
+              <a:t>9/19/2025</a:t>
             </a:fld>
             <a:endParaRPr lang="en-US"/>
           </a:p>
@@ -4138,7 +4223,7 @@
           <a:p>
             <a:fld id="{D241CDF3-A1FB-4215-9C3B-B36887AAFAD2}" type="datetimeFigureOut">
               <a:rPr lang="en-US" smtClean="0"/>
-              <a:t>9/16/2025</a:t>
+              <a:t>9/19/2025</a:t>
             </a:fld>
             <a:endParaRPr lang="en-US"/>
           </a:p>
@@ -4555,6 +4640,104 @@
           <a:chExt cx="0" cy="0"/>
         </a:xfrm>
       </p:grpSpPr>
+      <p:sp>
+        <p:nvSpPr>
+          <p:cNvPr id="2" name="Title 1">
+            <a:extLst>
+              <a:ext uri="{FF2B5EF4-FFF2-40B4-BE49-F238E27FC236}">
+                <a16:creationId xmlns:a16="http://schemas.microsoft.com/office/drawing/2014/main" id="{16BDF30B-6797-CA80-5FF9-1A95CBDF6F67}"/>
+              </a:ext>
+            </a:extLst>
+          </p:cNvPr>
+          <p:cNvSpPr>
+            <a:spLocks noGrp="1"/>
+          </p:cNvSpPr>
+          <p:nvPr>
+            <p:ph type="title"/>
+          </p:nvPr>
+        </p:nvSpPr>
+        <p:spPr/>
+        <p:txBody>
+          <a:bodyPr/>
+          <a:lstStyle/>
+          <a:p>
+            <a:r>
+              <a:rPr lang="en-US" dirty="0"/>
+              <a:t>Home Page Image</a:t>
+            </a:r>
+          </a:p>
+        </p:txBody>
+      </p:sp>
+      <p:sp>
+        <p:nvSpPr>
+          <p:cNvPr id="3" name="Content Placeholder 2">
+            <a:extLst>
+              <a:ext uri="{FF2B5EF4-FFF2-40B4-BE49-F238E27FC236}">
+                <a16:creationId xmlns:a16="http://schemas.microsoft.com/office/drawing/2014/main" id="{39B1F5AD-648D-9504-BDB3-13C31619395B}"/>
+              </a:ext>
+            </a:extLst>
+          </p:cNvPr>
+          <p:cNvSpPr>
+            <a:spLocks noGrp="1"/>
+          </p:cNvSpPr>
+          <p:nvPr>
+            <p:ph idx="1"/>
+          </p:nvPr>
+        </p:nvSpPr>
+        <p:spPr/>
+        <p:txBody>
+          <a:bodyPr/>
+          <a:lstStyle/>
+          <a:p>
+            <a:r>
+              <a:rPr lang="en-US" dirty="0"/>
+              <a:t>Unmarked:  /docs/studio/assets/user/home-page.png</a:t>
+            </a:r>
+          </a:p>
+          <a:p>
+            <a:r>
+              <a:rPr lang="en-US" dirty="0"/>
+              <a:t>1005 x 660 pixels</a:t>
+            </a:r>
+          </a:p>
+          <a:p>
+            <a:r>
+              <a:rPr lang="en-US" dirty="0"/>
+              <a:t>3 variants</a:t>
+            </a:r>
+          </a:p>
+        </p:txBody>
+      </p:sp>
+    </p:spTree>
+    <p:extLst>
+      <p:ext uri="{BB962C8B-B14F-4D97-AF65-F5344CB8AC3E}">
+        <p14:creationId xmlns:p14="http://schemas.microsoft.com/office/powerpoint/2010/main" val="732937030"/>
+      </p:ext>
+    </p:extLst>
+  </p:cSld>
+  <p:clrMapOvr>
+    <a:masterClrMapping/>
+  </p:clrMapOvr>
+</p:sld>
+</file>
+
+<file path=ppt/slides/slide2.xml><?xml version="1.0" encoding="utf-8"?>
+<p:sld xmlns:a="http://schemas.openxmlformats.org/drawingml/2006/main" xmlns:r="http://schemas.openxmlformats.org/officeDocument/2006/relationships" xmlns:p="http://schemas.openxmlformats.org/presentationml/2006/main">
+  <p:cSld>
+    <p:spTree>
+      <p:nvGrpSpPr>
+        <p:cNvPr id="1" name=""/>
+        <p:cNvGrpSpPr/>
+        <p:nvPr/>
+      </p:nvGrpSpPr>
+      <p:grpSpPr>
+        <a:xfrm>
+          <a:off x="0" y="0"/>
+          <a:ext cx="0" cy="0"/>
+          <a:chOff x="0" y="0"/>
+          <a:chExt cx="0" cy="0"/>
+        </a:xfrm>
+      </p:grpSpPr>
       <p:pic>
         <p:nvPicPr>
           <p:cNvPr id="5" name="Picture 4">
@@ -5221,7 +5404,7 @@
 </p:sld>
 </file>
 
-<file path=ppt/slides/slide2.xml><?xml version="1.0" encoding="utf-8"?>
+<file path=ppt/slides/slide3.xml><?xml version="1.0" encoding="utf-8"?>
 <p:sld xmlns:a="http://schemas.openxmlformats.org/drawingml/2006/main" xmlns:r="http://schemas.openxmlformats.org/officeDocument/2006/relationships" xmlns:p="http://schemas.openxmlformats.org/presentationml/2006/main">
   <p:cSld>
     <p:spTree>
@@ -5356,7 +5539,7 @@
 </p:sld>
 </file>
 
-<file path=ppt/slides/slide3.xml><?xml version="1.0" encoding="utf-8"?>
+<file path=ppt/slides/slide4.xml><?xml version="1.0" encoding="utf-8"?>
 <p:sld xmlns:a="http://schemas.openxmlformats.org/drawingml/2006/main" xmlns:r="http://schemas.openxmlformats.org/officeDocument/2006/relationships" xmlns:p="http://schemas.openxmlformats.org/presentationml/2006/main">
   <p:cSld>
     <p:spTree>
@@ -5674,15 +5857,15 @@
               </a:ext>
             </a:extLst>
           </a:blip>
-          <a:srcRect t="-72" b="94976"/>
+          <a:srcRect t="-72" b="95205"/>
           <a:stretch>
             <a:fillRect/>
           </a:stretch>
         </p:blipFill>
         <p:spPr>
           <a:xfrm>
-            <a:off x="1309019" y="290074"/>
-            <a:ext cx="9573961" cy="320400"/>
+            <a:off x="1296000" y="288000"/>
+            <a:ext cx="9573961" cy="306000"/>
           </a:xfrm>
           <a:prstGeom prst="rect">
             <a:avLst/>
@@ -6253,7 +6436,105 @@
 </p:sld>
 </file>
 
-<file path=ppt/slides/slide4.xml><?xml version="1.0" encoding="utf-8"?>
+<file path=ppt/slides/slide5.xml><?xml version="1.0" encoding="utf-8"?>
+<p:sld xmlns:a="http://schemas.openxmlformats.org/drawingml/2006/main" xmlns:r="http://schemas.openxmlformats.org/officeDocument/2006/relationships" xmlns:p="http://schemas.openxmlformats.org/presentationml/2006/main">
+  <p:cSld>
+    <p:spTree>
+      <p:nvGrpSpPr>
+        <p:cNvPr id="1" name="">
+          <a:extLst>
+            <a:ext uri="{FF2B5EF4-FFF2-40B4-BE49-F238E27FC236}">
+              <a16:creationId xmlns:a16="http://schemas.microsoft.com/office/drawing/2014/main" id="{FC7CDD00-8F0F-BBDD-E553-0474BAD7D07B}"/>
+            </a:ext>
+          </a:extLst>
+        </p:cNvPr>
+        <p:cNvGrpSpPr/>
+        <p:nvPr/>
+      </p:nvGrpSpPr>
+      <p:grpSpPr>
+        <a:xfrm>
+          <a:off x="0" y="0"/>
+          <a:ext cx="0" cy="0"/>
+          <a:chOff x="0" y="0"/>
+          <a:chExt cx="0" cy="0"/>
+        </a:xfrm>
+      </p:grpSpPr>
+      <p:sp>
+        <p:nvSpPr>
+          <p:cNvPr id="2" name="Title 1">
+            <a:extLst>
+              <a:ext uri="{FF2B5EF4-FFF2-40B4-BE49-F238E27FC236}">
+                <a16:creationId xmlns:a16="http://schemas.microsoft.com/office/drawing/2014/main" id="{6537E871-67D2-A5ED-31F4-52DFE89B1345}"/>
+              </a:ext>
+            </a:extLst>
+          </p:cNvPr>
+          <p:cNvSpPr>
+            <a:spLocks noGrp="1"/>
+          </p:cNvSpPr>
+          <p:nvPr>
+            <p:ph type="title"/>
+          </p:nvPr>
+        </p:nvSpPr>
+        <p:spPr/>
+        <p:txBody>
+          <a:bodyPr/>
+          <a:lstStyle/>
+          <a:p>
+            <a:r>
+              <a:rPr lang="en-US" dirty="0"/>
+              <a:t>Dataset Gallery Sidebar</a:t>
+            </a:r>
+          </a:p>
+        </p:txBody>
+      </p:sp>
+      <p:sp>
+        <p:nvSpPr>
+          <p:cNvPr id="3" name="Content Placeholder 2">
+            <a:extLst>
+              <a:ext uri="{FF2B5EF4-FFF2-40B4-BE49-F238E27FC236}">
+                <a16:creationId xmlns:a16="http://schemas.microsoft.com/office/drawing/2014/main" id="{4F554BEA-40F2-76F8-4398-7BA2A898FF52}"/>
+              </a:ext>
+            </a:extLst>
+          </p:cNvPr>
+          <p:cNvSpPr>
+            <a:spLocks noGrp="1"/>
+          </p:cNvSpPr>
+          <p:nvPr>
+            <p:ph idx="1"/>
+          </p:nvPr>
+        </p:nvSpPr>
+        <p:spPr/>
+        <p:txBody>
+          <a:bodyPr/>
+          <a:lstStyle/>
+          <a:p>
+            <a:r>
+              <a:rPr lang="en-US" dirty="0"/>
+              <a:t>Not unmarked</a:t>
+            </a:r>
+          </a:p>
+          <a:p>
+            <a:r>
+              <a:rPr lang="en-US" dirty="0"/>
+              <a:t>212 x 464</a:t>
+            </a:r>
+          </a:p>
+        </p:txBody>
+      </p:sp>
+    </p:spTree>
+    <p:extLst>
+      <p:ext uri="{BB962C8B-B14F-4D97-AF65-F5344CB8AC3E}">
+        <p14:creationId xmlns:p14="http://schemas.microsoft.com/office/powerpoint/2010/main" val="1799300729"/>
+      </p:ext>
+    </p:extLst>
+  </p:cSld>
+  <p:clrMapOvr>
+    <a:masterClrMapping/>
+  </p:clrMapOvr>
+</p:sld>
+</file>
+
+<file path=ppt/slides/slide6.xml><?xml version="1.0" encoding="utf-8"?>
 <p:sld xmlns:a="http://schemas.openxmlformats.org/drawingml/2006/main" xmlns:r="http://schemas.openxmlformats.org/officeDocument/2006/relationships" xmlns:p="http://schemas.openxmlformats.org/presentationml/2006/main">
   <p:cSld>
     <p:spTree>
@@ -6285,7 +6566,7 @@
           <p:nvPr/>
         </p:nvPicPr>
         <p:blipFill>
-          <a:blip r:embed="rId2"/>
+          <a:blip r:embed="rId3"/>
           <a:stretch>
             <a:fillRect/>
           </a:stretch>

</xml_diff>

<commit_message>
[DE-2265]: Added instructions for splitting and verifying the dataset. Made dataset splitting a discrete documentation. Added steps for navigating to the Projects. Updating screenshots for the email verification, login, and main projects page that seemed to be quite different now.
</commit_message>
<xml_diff>
--- a/images_with_layers.pptx
+++ b/images_with_layers.pptx
@@ -5,15 +5,25 @@
     <p:sldMasterId id="2147483648" r:id="rId1"/>
   </p:sldMasterIdLst>
   <p:notesMasterIdLst>
-    <p:notesMasterId r:id="rId8"/>
+    <p:notesMasterId r:id="rId18"/>
   </p:notesMasterIdLst>
   <p:sldIdLst>
-    <p:sldId id="261" r:id="rId2"/>
-    <p:sldId id="256" r:id="rId3"/>
-    <p:sldId id="257" r:id="rId4"/>
-    <p:sldId id="259" r:id="rId5"/>
-    <p:sldId id="262" r:id="rId6"/>
-    <p:sldId id="260" r:id="rId7"/>
+    <p:sldId id="264" r:id="rId2"/>
+    <p:sldId id="265" r:id="rId3"/>
+    <p:sldId id="267" r:id="rId4"/>
+    <p:sldId id="266" r:id="rId5"/>
+    <p:sldId id="261" r:id="rId6"/>
+    <p:sldId id="256" r:id="rId7"/>
+    <p:sldId id="257" r:id="rId8"/>
+    <p:sldId id="259" r:id="rId9"/>
+    <p:sldId id="268" r:id="rId10"/>
+    <p:sldId id="269" r:id="rId11"/>
+    <p:sldId id="270" r:id="rId12"/>
+    <p:sldId id="271" r:id="rId13"/>
+    <p:sldId id="272" r:id="rId14"/>
+    <p:sldId id="273" r:id="rId15"/>
+    <p:sldId id="262" r:id="rId16"/>
+    <p:sldId id="260" r:id="rId17"/>
   </p:sldIdLst>
   <p:sldSz cx="12192000" cy="6858000"/>
   <p:notesSz cx="6858000" cy="9144000"/>
@@ -115,12 +125,42 @@
   <p:extLst>
     <p:ext uri="{521415D9-36F7-43E2-AB2F-B90AF26B5E84}">
       <p14:sectionLst xmlns:p14="http://schemas.microsoft.com/office/powerpoint/2010/main">
+        <p14:section name="Verify Email" id="{A2088BEF-74F3-42A9-A2C1-EBED34B9363D}">
+          <p14:sldIdLst>
+            <p14:sldId id="264"/>
+            <p14:sldId id="265"/>
+          </p14:sldIdLst>
+        </p14:section>
+        <p14:section name="Login Page" id="{8AB4A417-FB6B-4774-A7CF-EF4461F143C1}">
+          <p14:sldIdLst>
+            <p14:sldId id="267"/>
+            <p14:sldId id="266"/>
+          </p14:sldIdLst>
+        </p14:section>
         <p14:section name="Home Page and Variants" id="{9EE3B63E-DA1C-47B6-82D6-E79847A08A80}">
           <p14:sldIdLst>
             <p14:sldId id="261"/>
             <p14:sldId id="256"/>
             <p14:sldId id="257"/>
             <p14:sldId id="259"/>
+          </p14:sldIdLst>
+        </p14:section>
+        <p14:section name="Projects" id="{03FB2B58-827B-48C9-AD77-448ACF3B58C4}">
+          <p14:sldIdLst>
+            <p14:sldId id="268"/>
+            <p14:sldId id="269"/>
+          </p14:sldIdLst>
+        </p14:section>
+        <p14:section name="Create Project" id="{80E44758-F3E7-4183-870E-68AD10FB3027}">
+          <p14:sldIdLst>
+            <p14:sldId id="270"/>
+            <p14:sldId id="271"/>
+          </p14:sldIdLst>
+        </p14:section>
+        <p14:section name="Created Project" id="{AE4F5735-EF9D-4838-BC43-12C85FD3DA56}">
+          <p14:sldIdLst>
+            <p14:sldId id="272"/>
+            <p14:sldId id="273"/>
           </p14:sldIdLst>
         </p14:section>
         <p14:section name="Dataset Gallery" id="{69866AF7-968C-4F26-9ECA-AA64F6FFB6E8}">
@@ -630,7 +670,7 @@
           <a:p>
             <a:fld id="{E487E608-D9C6-4B3C-A9A4-BEAD08ECA06D}" type="datetimeFigureOut">
               <a:rPr lang="en-US" smtClean="0"/>
-              <a:t>9/19/2025</a:t>
+              <a:t>11/17/2025</a:t>
             </a:fld>
             <a:endParaRPr lang="en-US"/>
           </a:p>
@@ -1005,7 +1045,7 @@
           <a:p>
             <a:fld id="{874397DF-5812-45E4-B5F0-BF2AEB9BFE48}" type="slidenum">
               <a:rPr lang="en-US" smtClean="0"/>
-              <a:t>2</a:t>
+              <a:t>6</a:t>
             </a:fld>
             <a:endParaRPr lang="en-US"/>
           </a:p>
@@ -1156,7 +1196,7 @@
           <a:p>
             <a:fld id="{874397DF-5812-45E4-B5F0-BF2AEB9BFE48}" type="slidenum">
               <a:rPr lang="en-US" smtClean="0"/>
-              <a:t>3</a:t>
+              <a:t>7</a:t>
             </a:fld>
             <a:endParaRPr lang="en-US"/>
           </a:p>
@@ -1256,7 +1296,7 @@
             </a:pPr>
             <a:r>
               <a:rPr lang="en-US" dirty="0"/>
-              <a:t>Marked:  /docs/studio/assets/user/home-page-breakdown.png</a:t>
+              <a:t>Marked:  /docs/studio/assets/navigation/navigation-bar.png</a:t>
             </a:r>
           </a:p>
           <a:p>
@@ -1307,7 +1347,7 @@
           <a:p>
             <a:fld id="{874397DF-5812-45E4-B5F0-BF2AEB9BFE48}" type="slidenum">
               <a:rPr lang="en-US" smtClean="0"/>
-              <a:t>4</a:t>
+              <a:t>8</a:t>
             </a:fld>
             <a:endParaRPr lang="en-US"/>
           </a:p>
@@ -1370,6 +1410,387 @@
           <a:bodyPr/>
           <a:lstStyle/>
           <a:p>
+            <a:pPr marL="0" marR="0" lvl="0" indent="0" algn="l" defTabSz="914400" rtl="0" eaLnBrk="1" fontAlgn="auto" latinLnBrk="0" hangingPunct="1">
+              <a:lnSpc>
+                <a:spcPct val="100000"/>
+              </a:lnSpc>
+              <a:spcBef>
+                <a:spcPts val="0"/>
+              </a:spcBef>
+              <a:spcAft>
+                <a:spcPts val="0"/>
+              </a:spcAft>
+              <a:buClrTx/>
+              <a:buSzTx/>
+              <a:buFontTx/>
+              <a:buNone/>
+              <a:tabLst/>
+              <a:defRPr/>
+            </a:pPr>
+            <a:r>
+              <a:rPr lang="en-US" dirty="0"/>
+              <a:t>Marked: /docs/</a:t>
+            </a:r>
+            <a:r>
+              <a:rPr lang="en-US" sz="1200" b="0" u="sng" kern="1200" dirty="0">
+                <a:solidFill>
+                  <a:schemeClr val="tx1"/>
+                </a:solidFill>
+                <a:effectLst/>
+                <a:latin typeface="+mn-lt"/>
+                <a:ea typeface="+mn-ea"/>
+                <a:cs typeface="+mn-cs"/>
+              </a:rPr>
+              <a:t>studio/assets/projects/create-project.jpg</a:t>
+            </a:r>
+            <a:endParaRPr lang="en-US" sz="1200" b="0" kern="1200" dirty="0">
+              <a:solidFill>
+                <a:schemeClr val="tx1"/>
+              </a:solidFill>
+              <a:effectLst/>
+              <a:latin typeface="+mn-lt"/>
+              <a:ea typeface="+mn-ea"/>
+              <a:cs typeface="+mn-cs"/>
+            </a:endParaRPr>
+          </a:p>
+          <a:p>
+            <a:endParaRPr lang="en-US" dirty="0"/>
+          </a:p>
+        </p:txBody>
+      </p:sp>
+      <p:sp>
+        <p:nvSpPr>
+          <p:cNvPr id="4" name="Slide Number Placeholder 3"/>
+          <p:cNvSpPr>
+            <a:spLocks noGrp="1"/>
+          </p:cNvSpPr>
+          <p:nvPr>
+            <p:ph type="sldNum" sz="quarter" idx="5"/>
+          </p:nvPr>
+        </p:nvSpPr>
+        <p:spPr/>
+        <p:txBody>
+          <a:bodyPr/>
+          <a:lstStyle/>
+          <a:p>
+            <a:fld id="{874397DF-5812-45E4-B5F0-BF2AEB9BFE48}" type="slidenum">
+              <a:rPr lang="en-US" smtClean="0"/>
+              <a:t>10</a:t>
+            </a:fld>
+            <a:endParaRPr lang="en-US"/>
+          </a:p>
+        </p:txBody>
+      </p:sp>
+    </p:spTree>
+    <p:extLst>
+      <p:ext uri="{BB962C8B-B14F-4D97-AF65-F5344CB8AC3E}">
+        <p14:creationId xmlns:p14="http://schemas.microsoft.com/office/powerpoint/2010/main" val="189310779"/>
+      </p:ext>
+    </p:extLst>
+  </p:cSld>
+  <p:clrMapOvr>
+    <a:masterClrMapping/>
+  </p:clrMapOvr>
+</p:notes>
+</file>
+
+<file path=ppt/notesSlides/notesSlide5.xml><?xml version="1.0" encoding="utf-8"?>
+<p:notes xmlns:a="http://schemas.openxmlformats.org/drawingml/2006/main" xmlns:r="http://schemas.openxmlformats.org/officeDocument/2006/relationships" xmlns:p="http://schemas.openxmlformats.org/presentationml/2006/main">
+  <p:cSld>
+    <p:spTree>
+      <p:nvGrpSpPr>
+        <p:cNvPr id="1" name=""/>
+        <p:cNvGrpSpPr/>
+        <p:nvPr/>
+      </p:nvGrpSpPr>
+      <p:grpSpPr>
+        <a:xfrm>
+          <a:off x="0" y="0"/>
+          <a:ext cx="0" cy="0"/>
+          <a:chOff x="0" y="0"/>
+          <a:chExt cx="0" cy="0"/>
+        </a:xfrm>
+      </p:grpSpPr>
+      <p:sp>
+        <p:nvSpPr>
+          <p:cNvPr id="2" name="Slide Image Placeholder 1"/>
+          <p:cNvSpPr>
+            <a:spLocks noGrp="1" noRot="1" noChangeAspect="1"/>
+          </p:cNvSpPr>
+          <p:nvPr>
+            <p:ph type="sldImg"/>
+          </p:nvPr>
+        </p:nvSpPr>
+        <p:spPr/>
+      </p:sp>
+      <p:sp>
+        <p:nvSpPr>
+          <p:cNvPr id="3" name="Notes Placeholder 2"/>
+          <p:cNvSpPr>
+            <a:spLocks noGrp="1"/>
+          </p:cNvSpPr>
+          <p:nvPr>
+            <p:ph type="body" idx="1"/>
+          </p:nvPr>
+        </p:nvSpPr>
+        <p:spPr/>
+        <p:txBody>
+          <a:bodyPr/>
+          <a:lstStyle/>
+          <a:p>
+            <a:pPr marL="0" marR="0" lvl="0" indent="0" algn="l" defTabSz="914400" rtl="0" eaLnBrk="1" fontAlgn="auto" latinLnBrk="0" hangingPunct="1">
+              <a:lnSpc>
+                <a:spcPct val="100000"/>
+              </a:lnSpc>
+              <a:spcBef>
+                <a:spcPts val="0"/>
+              </a:spcBef>
+              <a:spcAft>
+                <a:spcPts val="0"/>
+              </a:spcAft>
+              <a:buClrTx/>
+              <a:buSzTx/>
+              <a:buFontTx/>
+              <a:buNone/>
+              <a:tabLst/>
+              <a:defRPr/>
+            </a:pPr>
+            <a:r>
+              <a:rPr lang="en-US" dirty="0"/>
+              <a:t>Marked: docs/</a:t>
+            </a:r>
+            <a:r>
+              <a:rPr lang="en-US" sz="1200" b="0" u="sng" kern="1200" dirty="0">
+                <a:solidFill>
+                  <a:schemeClr val="tx1"/>
+                </a:solidFill>
+                <a:effectLst/>
+                <a:latin typeface="+mn-lt"/>
+                <a:ea typeface="+mn-ea"/>
+                <a:cs typeface="+mn-cs"/>
+              </a:rPr>
+              <a:t>studio/assets/projects/create-project-fields.jpg</a:t>
+            </a:r>
+            <a:endParaRPr lang="en-US" sz="1200" b="0" kern="1200" dirty="0">
+              <a:solidFill>
+                <a:schemeClr val="tx1"/>
+              </a:solidFill>
+              <a:effectLst/>
+              <a:latin typeface="+mn-lt"/>
+              <a:ea typeface="+mn-ea"/>
+              <a:cs typeface="+mn-cs"/>
+            </a:endParaRPr>
+          </a:p>
+          <a:p>
+            <a:endParaRPr lang="en-US" dirty="0"/>
+          </a:p>
+        </p:txBody>
+      </p:sp>
+      <p:sp>
+        <p:nvSpPr>
+          <p:cNvPr id="4" name="Slide Number Placeholder 3"/>
+          <p:cNvSpPr>
+            <a:spLocks noGrp="1"/>
+          </p:cNvSpPr>
+          <p:nvPr>
+            <p:ph type="sldNum" sz="quarter" idx="5"/>
+          </p:nvPr>
+        </p:nvSpPr>
+        <p:spPr/>
+        <p:txBody>
+          <a:bodyPr/>
+          <a:lstStyle/>
+          <a:p>
+            <a:fld id="{874397DF-5812-45E4-B5F0-BF2AEB9BFE48}" type="slidenum">
+              <a:rPr lang="en-US" smtClean="0"/>
+              <a:t>12</a:t>
+            </a:fld>
+            <a:endParaRPr lang="en-US"/>
+          </a:p>
+        </p:txBody>
+      </p:sp>
+    </p:spTree>
+    <p:extLst>
+      <p:ext uri="{BB962C8B-B14F-4D97-AF65-F5344CB8AC3E}">
+        <p14:creationId xmlns:p14="http://schemas.microsoft.com/office/powerpoint/2010/main" val="2999767519"/>
+      </p:ext>
+    </p:extLst>
+  </p:cSld>
+  <p:clrMapOvr>
+    <a:masterClrMapping/>
+  </p:clrMapOvr>
+</p:notes>
+</file>
+
+<file path=ppt/notesSlides/notesSlide6.xml><?xml version="1.0" encoding="utf-8"?>
+<p:notes xmlns:a="http://schemas.openxmlformats.org/drawingml/2006/main" xmlns:r="http://schemas.openxmlformats.org/officeDocument/2006/relationships" xmlns:p="http://schemas.openxmlformats.org/presentationml/2006/main">
+  <p:cSld>
+    <p:spTree>
+      <p:nvGrpSpPr>
+        <p:cNvPr id="1" name=""/>
+        <p:cNvGrpSpPr/>
+        <p:nvPr/>
+      </p:nvGrpSpPr>
+      <p:grpSpPr>
+        <a:xfrm>
+          <a:off x="0" y="0"/>
+          <a:ext cx="0" cy="0"/>
+          <a:chOff x="0" y="0"/>
+          <a:chExt cx="0" cy="0"/>
+        </a:xfrm>
+      </p:grpSpPr>
+      <p:sp>
+        <p:nvSpPr>
+          <p:cNvPr id="2" name="Slide Image Placeholder 1"/>
+          <p:cNvSpPr>
+            <a:spLocks noGrp="1" noRot="1" noChangeAspect="1"/>
+          </p:cNvSpPr>
+          <p:nvPr>
+            <p:ph type="sldImg"/>
+          </p:nvPr>
+        </p:nvSpPr>
+        <p:spPr/>
+      </p:sp>
+      <p:sp>
+        <p:nvSpPr>
+          <p:cNvPr id="3" name="Notes Placeholder 2"/>
+          <p:cNvSpPr>
+            <a:spLocks noGrp="1"/>
+          </p:cNvSpPr>
+          <p:nvPr>
+            <p:ph type="body" idx="1"/>
+          </p:nvPr>
+        </p:nvSpPr>
+        <p:spPr/>
+        <p:txBody>
+          <a:bodyPr/>
+          <a:lstStyle/>
+          <a:p>
+            <a:pPr marL="0" marR="0" lvl="0" indent="0" algn="l" defTabSz="914400" rtl="0" eaLnBrk="1" fontAlgn="auto" latinLnBrk="0" hangingPunct="1">
+              <a:lnSpc>
+                <a:spcPct val="100000"/>
+              </a:lnSpc>
+              <a:spcBef>
+                <a:spcPts val="0"/>
+              </a:spcBef>
+              <a:spcAft>
+                <a:spcPts val="0"/>
+              </a:spcAft>
+              <a:buClrTx/>
+              <a:buSzTx/>
+              <a:buFontTx/>
+              <a:buNone/>
+              <a:tabLst/>
+              <a:defRPr/>
+            </a:pPr>
+            <a:r>
+              <a:rPr lang="en-US" dirty="0"/>
+              <a:t>Marked: </a:t>
+            </a:r>
+            <a:r>
+              <a:rPr lang="en-US" sz="1200" b="0" u="sng" kern="1200" dirty="0">
+                <a:solidFill>
+                  <a:schemeClr val="tx1"/>
+                </a:solidFill>
+                <a:effectLst/>
+                <a:latin typeface="+mn-lt"/>
+                <a:ea typeface="+mn-ea"/>
+                <a:cs typeface="+mn-cs"/>
+              </a:rPr>
+              <a:t>/studio/assets/projects/new-project.jpg</a:t>
+            </a:r>
+            <a:endParaRPr lang="en-US" sz="1200" b="0" kern="1200" dirty="0">
+              <a:solidFill>
+                <a:schemeClr val="tx1"/>
+              </a:solidFill>
+              <a:effectLst/>
+              <a:latin typeface="+mn-lt"/>
+              <a:ea typeface="+mn-ea"/>
+              <a:cs typeface="+mn-cs"/>
+            </a:endParaRPr>
+          </a:p>
+        </p:txBody>
+      </p:sp>
+      <p:sp>
+        <p:nvSpPr>
+          <p:cNvPr id="4" name="Slide Number Placeholder 3"/>
+          <p:cNvSpPr>
+            <a:spLocks noGrp="1"/>
+          </p:cNvSpPr>
+          <p:nvPr>
+            <p:ph type="sldNum" sz="quarter" idx="5"/>
+          </p:nvPr>
+        </p:nvSpPr>
+        <p:spPr/>
+        <p:txBody>
+          <a:bodyPr/>
+          <a:lstStyle/>
+          <a:p>
+            <a:fld id="{874397DF-5812-45E4-B5F0-BF2AEB9BFE48}" type="slidenum">
+              <a:rPr lang="en-US" smtClean="0"/>
+              <a:t>14</a:t>
+            </a:fld>
+            <a:endParaRPr lang="en-US"/>
+          </a:p>
+        </p:txBody>
+      </p:sp>
+    </p:spTree>
+    <p:extLst>
+      <p:ext uri="{BB962C8B-B14F-4D97-AF65-F5344CB8AC3E}">
+        <p14:creationId xmlns:p14="http://schemas.microsoft.com/office/powerpoint/2010/main" val="2070805352"/>
+      </p:ext>
+    </p:extLst>
+  </p:cSld>
+  <p:clrMapOvr>
+    <a:masterClrMapping/>
+  </p:clrMapOvr>
+</p:notes>
+</file>
+
+<file path=ppt/notesSlides/notesSlide7.xml><?xml version="1.0" encoding="utf-8"?>
+<p:notes xmlns:a="http://schemas.openxmlformats.org/drawingml/2006/main" xmlns:r="http://schemas.openxmlformats.org/officeDocument/2006/relationships" xmlns:p="http://schemas.openxmlformats.org/presentationml/2006/main">
+  <p:cSld>
+    <p:spTree>
+      <p:nvGrpSpPr>
+        <p:cNvPr id="1" name=""/>
+        <p:cNvGrpSpPr/>
+        <p:nvPr/>
+      </p:nvGrpSpPr>
+      <p:grpSpPr>
+        <a:xfrm>
+          <a:off x="0" y="0"/>
+          <a:ext cx="0" cy="0"/>
+          <a:chOff x="0" y="0"/>
+          <a:chExt cx="0" cy="0"/>
+        </a:xfrm>
+      </p:grpSpPr>
+      <p:sp>
+        <p:nvSpPr>
+          <p:cNvPr id="2" name="Slide Image Placeholder 1"/>
+          <p:cNvSpPr>
+            <a:spLocks noGrp="1" noRot="1" noChangeAspect="1"/>
+          </p:cNvSpPr>
+          <p:nvPr>
+            <p:ph type="sldImg"/>
+          </p:nvPr>
+        </p:nvSpPr>
+        <p:spPr/>
+      </p:sp>
+      <p:sp>
+        <p:nvSpPr>
+          <p:cNvPr id="3" name="Notes Placeholder 2"/>
+          <p:cNvSpPr>
+            <a:spLocks noGrp="1"/>
+          </p:cNvSpPr>
+          <p:nvPr>
+            <p:ph type="body" idx="1"/>
+          </p:nvPr>
+        </p:nvSpPr>
+        <p:spPr/>
+        <p:txBody>
+          <a:bodyPr/>
+          <a:lstStyle/>
+          <a:p>
             <a:r>
               <a:rPr lang="en-US" dirty="0"/>
               <a:t>Marked:  </a:t>
@@ -1407,7 +1828,7 @@
           <a:p>
             <a:fld id="{874397DF-5812-45E4-B5F0-BF2AEB9BFE48}" type="slidenum">
               <a:rPr lang="en-US" smtClean="0"/>
-              <a:t>6</a:t>
+              <a:t>16</a:t>
             </a:fld>
             <a:endParaRPr lang="en-US"/>
           </a:p>
@@ -1573,7 +1994,7 @@
           <a:p>
             <a:fld id="{D241CDF3-A1FB-4215-9C3B-B36887AAFAD2}" type="datetimeFigureOut">
               <a:rPr lang="en-US" smtClean="0"/>
-              <a:t>9/19/2025</a:t>
+              <a:t>11/17/2025</a:t>
             </a:fld>
             <a:endParaRPr lang="en-US"/>
           </a:p>
@@ -1771,7 +2192,7 @@
           <a:p>
             <a:fld id="{D241CDF3-A1FB-4215-9C3B-B36887AAFAD2}" type="datetimeFigureOut">
               <a:rPr lang="en-US" smtClean="0"/>
-              <a:t>9/19/2025</a:t>
+              <a:t>11/17/2025</a:t>
             </a:fld>
             <a:endParaRPr lang="en-US"/>
           </a:p>
@@ -1979,7 +2400,7 @@
           <a:p>
             <a:fld id="{D241CDF3-A1FB-4215-9C3B-B36887AAFAD2}" type="datetimeFigureOut">
               <a:rPr lang="en-US" smtClean="0"/>
-              <a:t>9/19/2025</a:t>
+              <a:t>11/17/2025</a:t>
             </a:fld>
             <a:endParaRPr lang="en-US"/>
           </a:p>
@@ -2177,7 +2598,7 @@
           <a:p>
             <a:fld id="{D241CDF3-A1FB-4215-9C3B-B36887AAFAD2}" type="datetimeFigureOut">
               <a:rPr lang="en-US" smtClean="0"/>
-              <a:t>9/19/2025</a:t>
+              <a:t>11/17/2025</a:t>
             </a:fld>
             <a:endParaRPr lang="en-US"/>
           </a:p>
@@ -2452,7 +2873,7 @@
           <a:p>
             <a:fld id="{D241CDF3-A1FB-4215-9C3B-B36887AAFAD2}" type="datetimeFigureOut">
               <a:rPr lang="en-US" smtClean="0"/>
-              <a:t>9/19/2025</a:t>
+              <a:t>11/17/2025</a:t>
             </a:fld>
             <a:endParaRPr lang="en-US"/>
           </a:p>
@@ -2717,7 +3138,7 @@
           <a:p>
             <a:fld id="{D241CDF3-A1FB-4215-9C3B-B36887AAFAD2}" type="datetimeFigureOut">
               <a:rPr lang="en-US" smtClean="0"/>
-              <a:t>9/19/2025</a:t>
+              <a:t>11/17/2025</a:t>
             </a:fld>
             <a:endParaRPr lang="en-US"/>
           </a:p>
@@ -3129,7 +3550,7 @@
           <a:p>
             <a:fld id="{D241CDF3-A1FB-4215-9C3B-B36887AAFAD2}" type="datetimeFigureOut">
               <a:rPr lang="en-US" smtClean="0"/>
-              <a:t>9/19/2025</a:t>
+              <a:t>11/17/2025</a:t>
             </a:fld>
             <a:endParaRPr lang="en-US"/>
           </a:p>
@@ -3270,7 +3691,7 @@
           <a:p>
             <a:fld id="{D241CDF3-A1FB-4215-9C3B-B36887AAFAD2}" type="datetimeFigureOut">
               <a:rPr lang="en-US" smtClean="0"/>
-              <a:t>9/19/2025</a:t>
+              <a:t>11/17/2025</a:t>
             </a:fld>
             <a:endParaRPr lang="en-US"/>
           </a:p>
@@ -3383,7 +3804,7 @@
           <a:p>
             <a:fld id="{D241CDF3-A1FB-4215-9C3B-B36887AAFAD2}" type="datetimeFigureOut">
               <a:rPr lang="en-US" smtClean="0"/>
-              <a:t>9/19/2025</a:t>
+              <a:t>11/17/2025</a:t>
             </a:fld>
             <a:endParaRPr lang="en-US"/>
           </a:p>
@@ -3694,7 +4115,7 @@
           <a:p>
             <a:fld id="{D241CDF3-A1FB-4215-9C3B-B36887AAFAD2}" type="datetimeFigureOut">
               <a:rPr lang="en-US" smtClean="0"/>
-              <a:t>9/19/2025</a:t>
+              <a:t>11/17/2025</a:t>
             </a:fld>
             <a:endParaRPr lang="en-US"/>
           </a:p>
@@ -3982,7 +4403,7 @@
           <a:p>
             <a:fld id="{D241CDF3-A1FB-4215-9C3B-B36887AAFAD2}" type="datetimeFigureOut">
               <a:rPr lang="en-US" smtClean="0"/>
-              <a:t>9/19/2025</a:t>
+              <a:t>11/17/2025</a:t>
             </a:fld>
             <a:endParaRPr lang="en-US"/>
           </a:p>
@@ -4223,7 +4644,7 @@
           <a:p>
             <a:fld id="{D241CDF3-A1FB-4215-9C3B-B36887AAFAD2}" type="datetimeFigureOut">
               <a:rPr lang="en-US" smtClean="0"/>
-              <a:t>9/19/2025</a:t>
+              <a:t>11/17/2025</a:t>
             </a:fld>
             <a:endParaRPr lang="en-US"/>
           </a:p>
@@ -4628,7 +5049,13 @@
   <p:cSld>
     <p:spTree>
       <p:nvGrpSpPr>
-        <p:cNvPr id="1" name=""/>
+        <p:cNvPr id="1" name="">
+          <a:extLst>
+            <a:ext uri="{FF2B5EF4-FFF2-40B4-BE49-F238E27FC236}">
+              <a16:creationId xmlns:a16="http://schemas.microsoft.com/office/drawing/2014/main" id="{61FFE42E-9FCD-1DB6-26E9-F9852BF11AAC}"/>
+            </a:ext>
+          </a:extLst>
+        </p:cNvPr>
         <p:cNvGrpSpPr/>
         <p:nvPr/>
       </p:nvGrpSpPr>
@@ -4645,7 +5072,7 @@
           <p:cNvPr id="2" name="Title 1">
             <a:extLst>
               <a:ext uri="{FF2B5EF4-FFF2-40B4-BE49-F238E27FC236}">
-                <a16:creationId xmlns:a16="http://schemas.microsoft.com/office/drawing/2014/main" id="{16BDF30B-6797-CA80-5FF9-1A95CBDF6F67}"/>
+                <a16:creationId xmlns:a16="http://schemas.microsoft.com/office/drawing/2014/main" id="{E0018983-D601-F4CC-2FBB-0AA015B139DF}"/>
               </a:ext>
             </a:extLst>
           </p:cNvPr>
@@ -4663,7 +5090,7 @@
           <a:p>
             <a:r>
               <a:rPr lang="en-US" dirty="0"/>
-              <a:t>Home Page Image</a:t>
+              <a:t>Verify Email Image</a:t>
             </a:r>
           </a:p>
         </p:txBody>
@@ -4673,7 +5100,7 @@
           <p:cNvPr id="3" name="Content Placeholder 2">
             <a:extLst>
               <a:ext uri="{FF2B5EF4-FFF2-40B4-BE49-F238E27FC236}">
-                <a16:creationId xmlns:a16="http://schemas.microsoft.com/office/drawing/2014/main" id="{39B1F5AD-648D-9504-BDB3-13C31619395B}"/>
+                <a16:creationId xmlns:a16="http://schemas.microsoft.com/office/drawing/2014/main" id="{C568C9B6-A336-B729-9E16-A08833395A54}"/>
               </a:ext>
             </a:extLst>
           </p:cNvPr>
@@ -4691,19 +5118,7 @@
           <a:p>
             <a:r>
               <a:rPr lang="en-US" dirty="0"/>
-              <a:t>Unmarked:  /docs/studio/assets/user/home-page.png</a:t>
-            </a:r>
-          </a:p>
-          <a:p>
-            <a:r>
-              <a:rPr lang="en-US" dirty="0"/>
-              <a:t>1005 x 660 pixels</a:t>
-            </a:r>
-          </a:p>
-          <a:p>
-            <a:r>
-              <a:rPr lang="en-US" dirty="0"/>
-              <a:t>3 variants</a:t>
+              <a:t>Unmarked:  /docs/studio/assets/user/email-verification.jpg</a:t>
             </a:r>
           </a:p>
         </p:txBody>
@@ -4711,7 +5126,7 @@
     </p:spTree>
     <p:extLst>
       <p:ext uri="{BB962C8B-B14F-4D97-AF65-F5344CB8AC3E}">
-        <p14:creationId xmlns:p14="http://schemas.microsoft.com/office/powerpoint/2010/main" val="732937030"/>
+        <p14:creationId xmlns:p14="http://schemas.microsoft.com/office/powerpoint/2010/main" val="903728305"/>
       </p:ext>
     </p:extLst>
   </p:cSld>
@@ -4721,7 +5136,7 @@
 </p:sld>
 </file>
 
-<file path=ppt/slides/slide2.xml><?xml version="1.0" encoding="utf-8"?>
+<file path=ppt/slides/slide10.xml><?xml version="1.0" encoding="utf-8"?>
 <p:sld xmlns:a="http://schemas.openxmlformats.org/drawingml/2006/main" xmlns:r="http://schemas.openxmlformats.org/officeDocument/2006/relationships" xmlns:p="http://schemas.openxmlformats.org/presentationml/2006/main">
   <p:cSld>
     <p:spTree>
@@ -4743,30 +5158,25 @@
           <p:cNvPr id="5" name="Picture 4">
             <a:extLst>
               <a:ext uri="{FF2B5EF4-FFF2-40B4-BE49-F238E27FC236}">
-                <a16:creationId xmlns:a16="http://schemas.microsoft.com/office/drawing/2014/main" id="{743A2118-C1EA-9738-2846-3C4377B4E3E9}"/>
+                <a16:creationId xmlns:a16="http://schemas.microsoft.com/office/drawing/2014/main" id="{31BF084C-3F4E-251E-F938-C3DBA1C99C79}"/>
               </a:ext>
             </a:extLst>
           </p:cNvPr>
           <p:cNvPicPr>
-            <a:picLocks noGrp="1" noRot="1" noChangeAspect="1" noMove="1" noResize="1" noEditPoints="1" noAdjustHandles="1" noChangeArrowheads="1" noChangeShapeType="1" noCrop="1"/>
+            <a:picLocks noChangeAspect="1"/>
           </p:cNvPicPr>
           <p:nvPr/>
         </p:nvPicPr>
         <p:blipFill>
-          <a:blip r:embed="rId3">
-            <a:extLst>
-              <a:ext uri="{28A0092B-C50C-407E-A947-70E740481C1C}">
-                <a14:useLocalDpi xmlns:a14="http://schemas.microsoft.com/office/drawing/2010/main" val="0"/>
-              </a:ext>
-            </a:extLst>
-          </a:blip>
-          <a:srcRect/>
-          <a:stretch/>
+          <a:blip r:embed="rId3"/>
+          <a:stretch>
+            <a:fillRect/>
+          </a:stretch>
         </p:blipFill>
         <p:spPr>
           <a:xfrm>
-            <a:off x="1316272" y="290074"/>
-            <a:ext cx="9559454" cy="6277851"/>
+            <a:off x="1112031" y="0"/>
+            <a:ext cx="9967938" cy="6858000"/>
           </a:xfrm>
           <a:prstGeom prst="rect">
             <a:avLst/>
@@ -4775,10 +5185,10 @@
       </p:pic>
       <p:sp>
         <p:nvSpPr>
-          <p:cNvPr id="7" name="Rectangle 6">
-            <a:extLst>
-              <a:ext uri="{FF2B5EF4-FFF2-40B4-BE49-F238E27FC236}">
-                <a16:creationId xmlns:a16="http://schemas.microsoft.com/office/drawing/2014/main" id="{7A08FA56-6667-2FEB-DFC0-5795598FD922}"/>
+          <p:cNvPr id="6" name="Rectangle 5">
+            <a:extLst>
+              <a:ext uri="{FF2B5EF4-FFF2-40B4-BE49-F238E27FC236}">
+                <a16:creationId xmlns:a16="http://schemas.microsoft.com/office/drawing/2014/main" id="{70A41AB3-5778-A4F5-A95D-354A8B37494D}"/>
               </a:ext>
             </a:extLst>
           </p:cNvPr>
@@ -4787,8 +5197,8 @@
         </p:nvSpPr>
         <p:spPr>
           <a:xfrm>
-            <a:off x="1256565" y="226337"/>
-            <a:ext cx="9687660" cy="434565"/>
+            <a:off x="10133814" y="659876"/>
+            <a:ext cx="838986" cy="311086"/>
           </a:xfrm>
           <a:prstGeom prst="rect">
             <a:avLst/>
@@ -4837,51 +5247,158 @@
           </a:p>
         </p:txBody>
       </p:sp>
-      <p:sp>
-        <p:nvSpPr>
-          <p:cNvPr id="8" name="TextBox 7">
-            <a:extLst>
-              <a:ext uri="{FF2B5EF4-FFF2-40B4-BE49-F238E27FC236}">
-                <a16:creationId xmlns:a16="http://schemas.microsoft.com/office/drawing/2014/main" id="{9B1E6C77-DB95-5CB9-F5BE-10B04E4B3331}"/>
-              </a:ext>
-            </a:extLst>
-          </p:cNvPr>
-          <p:cNvSpPr txBox="1"/>
+    </p:spTree>
+    <p:extLst>
+      <p:ext uri="{BB962C8B-B14F-4D97-AF65-F5344CB8AC3E}">
+        <p14:creationId xmlns:p14="http://schemas.microsoft.com/office/powerpoint/2010/main" val="479816760"/>
+      </p:ext>
+    </p:extLst>
+  </p:cSld>
+  <p:clrMapOvr>
+    <a:masterClrMapping/>
+  </p:clrMapOvr>
+</p:sld>
+</file>
+
+<file path=ppt/slides/slide11.xml><?xml version="1.0" encoding="utf-8"?>
+<p:sld xmlns:a="http://schemas.openxmlformats.org/drawingml/2006/main" xmlns:r="http://schemas.openxmlformats.org/officeDocument/2006/relationships" xmlns:p="http://schemas.openxmlformats.org/presentationml/2006/main">
+  <p:cSld>
+    <p:spTree>
+      <p:nvGrpSpPr>
+        <p:cNvPr id="1" name=""/>
+        <p:cNvGrpSpPr/>
+        <p:nvPr/>
+      </p:nvGrpSpPr>
+      <p:grpSpPr>
+        <a:xfrm>
+          <a:off x="0" y="0"/>
+          <a:ext cx="0" cy="0"/>
+          <a:chOff x="0" y="0"/>
+          <a:chExt cx="0" cy="0"/>
+        </a:xfrm>
+      </p:grpSpPr>
+      <p:sp>
+        <p:nvSpPr>
+          <p:cNvPr id="2" name="Title 1">
+            <a:extLst>
+              <a:ext uri="{FF2B5EF4-FFF2-40B4-BE49-F238E27FC236}">
+                <a16:creationId xmlns:a16="http://schemas.microsoft.com/office/drawing/2014/main" id="{2754BFBF-7F07-EA8D-B8A1-272C146728C0}"/>
+              </a:ext>
+            </a:extLst>
+          </p:cNvPr>
+          <p:cNvSpPr>
+            <a:spLocks noGrp="1"/>
+          </p:cNvSpPr>
+          <p:nvPr>
+            <p:ph type="title"/>
+          </p:nvPr>
+        </p:nvSpPr>
+        <p:spPr/>
+        <p:txBody>
+          <a:bodyPr/>
+          <a:lstStyle/>
+          <a:p>
+            <a:r>
+              <a:rPr lang="en-US" dirty="0"/>
+              <a:t>Create Project Image</a:t>
+            </a:r>
+          </a:p>
+        </p:txBody>
+      </p:sp>
+      <p:sp>
+        <p:nvSpPr>
+          <p:cNvPr id="3" name="Content Placeholder 2">
+            <a:extLst>
+              <a:ext uri="{FF2B5EF4-FFF2-40B4-BE49-F238E27FC236}">
+                <a16:creationId xmlns:a16="http://schemas.microsoft.com/office/drawing/2014/main" id="{E5D400A7-1429-C6E5-FEE9-E437D8A14CAB}"/>
+              </a:ext>
+            </a:extLst>
+          </p:cNvPr>
+          <p:cNvSpPr>
+            <a:spLocks noGrp="1"/>
+          </p:cNvSpPr>
+          <p:nvPr>
+            <p:ph idx="1"/>
+          </p:nvPr>
+        </p:nvSpPr>
+        <p:spPr/>
+        <p:txBody>
+          <a:bodyPr/>
+          <a:lstStyle/>
+          <a:p>
+            <a:r>
+              <a:rPr lang="en-US" dirty="0"/>
+              <a:t>Unmarked: None</a:t>
+            </a:r>
+          </a:p>
+        </p:txBody>
+      </p:sp>
+    </p:spTree>
+    <p:extLst>
+      <p:ext uri="{BB962C8B-B14F-4D97-AF65-F5344CB8AC3E}">
+        <p14:creationId xmlns:p14="http://schemas.microsoft.com/office/powerpoint/2010/main" val="177138575"/>
+      </p:ext>
+    </p:extLst>
+  </p:cSld>
+  <p:clrMapOvr>
+    <a:masterClrMapping/>
+  </p:clrMapOvr>
+</p:sld>
+</file>
+
+<file path=ppt/slides/slide12.xml><?xml version="1.0" encoding="utf-8"?>
+<p:sld xmlns:a="http://schemas.openxmlformats.org/drawingml/2006/main" xmlns:r="http://schemas.openxmlformats.org/officeDocument/2006/relationships" xmlns:p="http://schemas.openxmlformats.org/presentationml/2006/main">
+  <p:cSld>
+    <p:spTree>
+      <p:nvGrpSpPr>
+        <p:cNvPr id="1" name=""/>
+        <p:cNvGrpSpPr/>
+        <p:nvPr/>
+      </p:nvGrpSpPr>
+      <p:grpSpPr>
+        <a:xfrm>
+          <a:off x="0" y="0"/>
+          <a:ext cx="0" cy="0"/>
+          <a:chOff x="0" y="0"/>
+          <a:chExt cx="0" cy="0"/>
+        </a:xfrm>
+      </p:grpSpPr>
+      <p:pic>
+        <p:nvPicPr>
+          <p:cNvPr id="5" name="Picture 4">
+            <a:extLst>
+              <a:ext uri="{FF2B5EF4-FFF2-40B4-BE49-F238E27FC236}">
+                <a16:creationId xmlns:a16="http://schemas.microsoft.com/office/drawing/2014/main" id="{0F69F3A9-D836-C1CA-0FD5-84FD6E9FFBB0}"/>
+              </a:ext>
+            </a:extLst>
+          </p:cNvPr>
+          <p:cNvPicPr>
+            <a:picLocks noChangeAspect="1"/>
+          </p:cNvPicPr>
           <p:nvPr/>
-        </p:nvSpPr>
+        </p:nvPicPr>
+        <p:blipFill>
+          <a:blip r:embed="rId3"/>
+          <a:stretch>
+            <a:fillRect/>
+          </a:stretch>
+        </p:blipFill>
         <p:spPr>
           <a:xfrm>
-            <a:off x="948467" y="201252"/>
-            <a:ext cx="308098" cy="369332"/>
+            <a:off x="0" y="318247"/>
+            <a:ext cx="12192000" cy="6221506"/>
           </a:xfrm>
           <a:prstGeom prst="rect">
             <a:avLst/>
           </a:prstGeom>
-          <a:noFill/>
         </p:spPr>
-        <p:txBody>
-          <a:bodyPr wrap="none" rtlCol="0">
-            <a:spAutoFit/>
-          </a:bodyPr>
-          <a:lstStyle/>
-          <a:p>
-            <a:r>
-              <a:rPr lang="en-US" dirty="0">
-                <a:solidFill>
-                  <a:srgbClr val="FF0000"/>
-                </a:solidFill>
-              </a:rPr>
-              <a:t>1</a:t>
-            </a:r>
-          </a:p>
-        </p:txBody>
-      </p:sp>
-      <p:sp>
-        <p:nvSpPr>
-          <p:cNvPr id="9" name="Rectangle 8">
-            <a:extLst>
-              <a:ext uri="{FF2B5EF4-FFF2-40B4-BE49-F238E27FC236}">
-                <a16:creationId xmlns:a16="http://schemas.microsoft.com/office/drawing/2014/main" id="{6D48391C-EA04-C850-11E2-9DD29AEEAAE8}"/>
+      </p:pic>
+      <p:sp>
+        <p:nvSpPr>
+          <p:cNvPr id="6" name="Rectangle 5">
+            <a:extLst>
+              <a:ext uri="{FF2B5EF4-FFF2-40B4-BE49-F238E27FC236}">
+                <a16:creationId xmlns:a16="http://schemas.microsoft.com/office/drawing/2014/main" id="{BFCE4A81-3065-CA3C-42C9-D2ED31675E1A}"/>
               </a:ext>
             </a:extLst>
           </p:cNvPr>
@@ -4890,8 +5407,8 @@
         </p:nvSpPr>
         <p:spPr>
           <a:xfrm>
-            <a:off x="4267955" y="151078"/>
-            <a:ext cx="1494670" cy="534909"/>
+            <a:off x="8066889" y="4307951"/>
+            <a:ext cx="810411" cy="425974"/>
           </a:xfrm>
           <a:prstGeom prst="rect">
             <a:avLst/>
@@ -4942,49 +5459,249 @@
       </p:sp>
       <p:sp>
         <p:nvSpPr>
-          <p:cNvPr id="10" name="TextBox 9">
-            <a:extLst>
-              <a:ext uri="{FF2B5EF4-FFF2-40B4-BE49-F238E27FC236}">
-                <a16:creationId xmlns:a16="http://schemas.microsoft.com/office/drawing/2014/main" id="{79E39D9C-5B4D-15B1-CE5E-940082C00152}"/>
-              </a:ext>
-            </a:extLst>
-          </p:cNvPr>
-          <p:cNvSpPr txBox="1"/>
+          <p:cNvPr id="7" name="Arrow: Down 6">
+            <a:extLst>
+              <a:ext uri="{FF2B5EF4-FFF2-40B4-BE49-F238E27FC236}">
+                <a16:creationId xmlns:a16="http://schemas.microsoft.com/office/drawing/2014/main" id="{E1162D16-E76C-4FDB-0B5E-94168A5B0037}"/>
+              </a:ext>
+            </a:extLst>
+          </p:cNvPr>
+          <p:cNvSpPr/>
+          <p:nvPr/>
+        </p:nvSpPr>
+        <p:spPr>
+          <a:xfrm rot="2945459">
+            <a:off x="9799538" y="1182396"/>
+            <a:ext cx="742950" cy="2270857"/>
+          </a:xfrm>
+          <a:prstGeom prst="downArrow">
+            <a:avLst/>
+          </a:prstGeom>
+        </p:spPr>
+        <p:style>
+          <a:lnRef idx="2">
+            <a:schemeClr val="accent6">
+              <a:shade val="15000"/>
+            </a:schemeClr>
+          </a:lnRef>
+          <a:fillRef idx="1">
+            <a:schemeClr val="accent6"/>
+          </a:fillRef>
+          <a:effectRef idx="0">
+            <a:schemeClr val="accent6"/>
+          </a:effectRef>
+          <a:fontRef idx="minor">
+            <a:schemeClr val="lt1"/>
+          </a:fontRef>
+        </p:style>
+        <p:txBody>
+          <a:bodyPr rtlCol="0" anchor="ctr"/>
+          <a:lstStyle/>
+          <a:p>
+            <a:pPr algn="ctr"/>
+            <a:endParaRPr lang="en-US"/>
+          </a:p>
+        </p:txBody>
+      </p:sp>
+      <p:sp>
+        <p:nvSpPr>
+          <p:cNvPr id="8" name="Oval 7">
+            <a:extLst>
+              <a:ext uri="{FF2B5EF4-FFF2-40B4-BE49-F238E27FC236}">
+                <a16:creationId xmlns:a16="http://schemas.microsoft.com/office/drawing/2014/main" id="{5DA4AE31-1635-B773-23C9-BB9E840578AA}"/>
+              </a:ext>
+            </a:extLst>
+          </p:cNvPr>
+          <p:cNvSpPr/>
           <p:nvPr/>
         </p:nvSpPr>
         <p:spPr>
           <a:xfrm>
-            <a:off x="3959857" y="201252"/>
-            <a:ext cx="308098" cy="369332"/>
+            <a:off x="11001080" y="970962"/>
+            <a:ext cx="1093510" cy="716436"/>
+          </a:xfrm>
+          <a:prstGeom prst="ellipse">
+            <a:avLst/>
+          </a:prstGeom>
+          <a:noFill/>
+        </p:spPr>
+        <p:style>
+          <a:lnRef idx="2">
+            <a:schemeClr val="accent6"/>
+          </a:lnRef>
+          <a:fillRef idx="1">
+            <a:schemeClr val="lt1"/>
+          </a:fillRef>
+          <a:effectRef idx="0">
+            <a:schemeClr val="accent6"/>
+          </a:effectRef>
+          <a:fontRef idx="minor">
+            <a:schemeClr val="dk1"/>
+          </a:fontRef>
+        </p:style>
+        <p:txBody>
+          <a:bodyPr rtlCol="0" anchor="ctr"/>
+          <a:lstStyle/>
+          <a:p>
+            <a:pPr algn="ctr"/>
+            <a:endParaRPr lang="en-US">
+              <a:noFill/>
+            </a:endParaRPr>
+          </a:p>
+        </p:txBody>
+      </p:sp>
+    </p:spTree>
+    <p:extLst>
+      <p:ext uri="{BB962C8B-B14F-4D97-AF65-F5344CB8AC3E}">
+        <p14:creationId xmlns:p14="http://schemas.microsoft.com/office/powerpoint/2010/main" val="3261600860"/>
+      </p:ext>
+    </p:extLst>
+  </p:cSld>
+  <p:clrMapOvr>
+    <a:masterClrMapping/>
+  </p:clrMapOvr>
+</p:sld>
+</file>
+
+<file path=ppt/slides/slide13.xml><?xml version="1.0" encoding="utf-8"?>
+<p:sld xmlns:a="http://schemas.openxmlformats.org/drawingml/2006/main" xmlns:r="http://schemas.openxmlformats.org/officeDocument/2006/relationships" xmlns:p="http://schemas.openxmlformats.org/presentationml/2006/main">
+  <p:cSld>
+    <p:spTree>
+      <p:nvGrpSpPr>
+        <p:cNvPr id="1" name=""/>
+        <p:cNvGrpSpPr/>
+        <p:nvPr/>
+      </p:nvGrpSpPr>
+      <p:grpSpPr>
+        <a:xfrm>
+          <a:off x="0" y="0"/>
+          <a:ext cx="0" cy="0"/>
+          <a:chOff x="0" y="0"/>
+          <a:chExt cx="0" cy="0"/>
+        </a:xfrm>
+      </p:grpSpPr>
+      <p:sp>
+        <p:nvSpPr>
+          <p:cNvPr id="2" name="Title 1">
+            <a:extLst>
+              <a:ext uri="{FF2B5EF4-FFF2-40B4-BE49-F238E27FC236}">
+                <a16:creationId xmlns:a16="http://schemas.microsoft.com/office/drawing/2014/main" id="{4AB5246D-AC5F-6B0B-0BF4-B4E936C2850D}"/>
+              </a:ext>
+            </a:extLst>
+          </p:cNvPr>
+          <p:cNvSpPr>
+            <a:spLocks noGrp="1"/>
+          </p:cNvSpPr>
+          <p:nvPr>
+            <p:ph type="title"/>
+          </p:nvPr>
+        </p:nvSpPr>
+        <p:spPr/>
+        <p:txBody>
+          <a:bodyPr/>
+          <a:lstStyle/>
+          <a:p>
+            <a:r>
+              <a:rPr lang="en-US" dirty="0"/>
+              <a:t>Created Project Image</a:t>
+            </a:r>
+          </a:p>
+        </p:txBody>
+      </p:sp>
+      <p:sp>
+        <p:nvSpPr>
+          <p:cNvPr id="3" name="Content Placeholder 2">
+            <a:extLst>
+              <a:ext uri="{FF2B5EF4-FFF2-40B4-BE49-F238E27FC236}">
+                <a16:creationId xmlns:a16="http://schemas.microsoft.com/office/drawing/2014/main" id="{04268344-160D-64FE-7CF3-7ECAEEC42F09}"/>
+              </a:ext>
+            </a:extLst>
+          </p:cNvPr>
+          <p:cNvSpPr>
+            <a:spLocks noGrp="1"/>
+          </p:cNvSpPr>
+          <p:nvPr>
+            <p:ph idx="1"/>
+          </p:nvPr>
+        </p:nvSpPr>
+        <p:spPr/>
+        <p:txBody>
+          <a:bodyPr/>
+          <a:lstStyle/>
+          <a:p>
+            <a:r>
+              <a:rPr lang="en-US" dirty="0"/>
+              <a:t>Unmarked: None</a:t>
+            </a:r>
+          </a:p>
+        </p:txBody>
+      </p:sp>
+    </p:spTree>
+    <p:extLst>
+      <p:ext uri="{BB962C8B-B14F-4D97-AF65-F5344CB8AC3E}">
+        <p14:creationId xmlns:p14="http://schemas.microsoft.com/office/powerpoint/2010/main" val="1943592596"/>
+      </p:ext>
+    </p:extLst>
+  </p:cSld>
+  <p:clrMapOvr>
+    <a:masterClrMapping/>
+  </p:clrMapOvr>
+</p:sld>
+</file>
+
+<file path=ppt/slides/slide14.xml><?xml version="1.0" encoding="utf-8"?>
+<p:sld xmlns:a="http://schemas.openxmlformats.org/drawingml/2006/main" xmlns:r="http://schemas.openxmlformats.org/officeDocument/2006/relationships" xmlns:p="http://schemas.openxmlformats.org/presentationml/2006/main">
+  <p:cSld>
+    <p:spTree>
+      <p:nvGrpSpPr>
+        <p:cNvPr id="1" name=""/>
+        <p:cNvGrpSpPr/>
+        <p:nvPr/>
+      </p:nvGrpSpPr>
+      <p:grpSpPr>
+        <a:xfrm>
+          <a:off x="0" y="0"/>
+          <a:ext cx="0" cy="0"/>
+          <a:chOff x="0" y="0"/>
+          <a:chExt cx="0" cy="0"/>
+        </a:xfrm>
+      </p:grpSpPr>
+      <p:pic>
+        <p:nvPicPr>
+          <p:cNvPr id="5" name="Picture 4">
+            <a:extLst>
+              <a:ext uri="{FF2B5EF4-FFF2-40B4-BE49-F238E27FC236}">
+                <a16:creationId xmlns:a16="http://schemas.microsoft.com/office/drawing/2014/main" id="{80BEDB98-47F1-3F76-F395-6D8026747FC4}"/>
+              </a:ext>
+            </a:extLst>
+          </p:cNvPr>
+          <p:cNvPicPr>
+            <a:picLocks noChangeAspect="1"/>
+          </p:cNvPicPr>
+          <p:nvPr/>
+        </p:nvPicPr>
+        <p:blipFill>
+          <a:blip r:embed="rId3"/>
+          <a:stretch>
+            <a:fillRect/>
+          </a:stretch>
+        </p:blipFill>
+        <p:spPr>
+          <a:xfrm>
+            <a:off x="0" y="320444"/>
+            <a:ext cx="12192000" cy="6217112"/>
           </a:xfrm>
           <a:prstGeom prst="rect">
             <a:avLst/>
           </a:prstGeom>
-          <a:noFill/>
         </p:spPr>
-        <p:txBody>
-          <a:bodyPr wrap="none" rtlCol="0">
-            <a:spAutoFit/>
-          </a:bodyPr>
-          <a:lstStyle/>
-          <a:p>
-            <a:r>
-              <a:rPr lang="en-US" dirty="0">
-                <a:solidFill>
-                  <a:srgbClr val="FF0000"/>
-                </a:solidFill>
-              </a:rPr>
-              <a:t>2</a:t>
-            </a:r>
-          </a:p>
-        </p:txBody>
-      </p:sp>
-      <p:sp>
-        <p:nvSpPr>
-          <p:cNvPr id="11" name="Rectangle 10">
-            <a:extLst>
-              <a:ext uri="{FF2B5EF4-FFF2-40B4-BE49-F238E27FC236}">
-                <a16:creationId xmlns:a16="http://schemas.microsoft.com/office/drawing/2014/main" id="{2833DB43-D41E-B980-2962-A29C8DC3C52A}"/>
+      </p:pic>
+      <p:sp>
+        <p:nvSpPr>
+          <p:cNvPr id="6" name="Rectangle 5">
+            <a:extLst>
+              <a:ext uri="{FF2B5EF4-FFF2-40B4-BE49-F238E27FC236}">
+                <a16:creationId xmlns:a16="http://schemas.microsoft.com/office/drawing/2014/main" id="{AE6D52E0-8337-0D7C-8178-83BBDCB5A4DA}"/>
               </a:ext>
             </a:extLst>
           </p:cNvPr>
@@ -4993,8 +5710,8 @@
         </p:nvSpPr>
         <p:spPr>
           <a:xfrm>
-            <a:off x="2017988" y="774810"/>
-            <a:ext cx="4726844" cy="1153578"/>
+            <a:off x="4095750" y="1743075"/>
+            <a:ext cx="4029075" cy="4210050"/>
           </a:xfrm>
           <a:prstGeom prst="rect">
             <a:avLst/>
@@ -5045,69 +5762,27 @@
       </p:sp>
       <p:sp>
         <p:nvSpPr>
-          <p:cNvPr id="12" name="TextBox 11">
-            <a:extLst>
-              <a:ext uri="{FF2B5EF4-FFF2-40B4-BE49-F238E27FC236}">
-                <a16:creationId xmlns:a16="http://schemas.microsoft.com/office/drawing/2014/main" id="{FC04C220-DD23-CC83-B1D2-AB1922EBBA7F}"/>
-              </a:ext>
-            </a:extLst>
-          </p:cNvPr>
-          <p:cNvSpPr txBox="1"/>
+          <p:cNvPr id="7" name="Arrow: Down 6">
+            <a:extLst>
+              <a:ext uri="{FF2B5EF4-FFF2-40B4-BE49-F238E27FC236}">
+                <a16:creationId xmlns:a16="http://schemas.microsoft.com/office/drawing/2014/main" id="{A6BB729C-F3AE-DC34-ED08-87C27344C5D7}"/>
+              </a:ext>
+            </a:extLst>
+          </p:cNvPr>
+          <p:cNvSpPr/>
           <p:nvPr/>
         </p:nvSpPr>
         <p:spPr>
-          <a:xfrm>
-            <a:off x="1709890" y="774810"/>
-            <a:ext cx="308098" cy="369332"/>
+          <a:xfrm rot="10800000">
+            <a:off x="5819775" y="6006870"/>
+            <a:ext cx="552450" cy="333375"/>
           </a:xfrm>
-          <a:prstGeom prst="rect">
+          <a:prstGeom prst="downArrow">
             <a:avLst/>
           </a:prstGeom>
-          <a:noFill/>
-        </p:spPr>
-        <p:txBody>
-          <a:bodyPr wrap="none" rtlCol="0">
-            <a:spAutoFit/>
-          </a:bodyPr>
-          <a:lstStyle/>
-          <a:p>
-            <a:r>
-              <a:rPr lang="en-US" dirty="0">
-                <a:solidFill>
-                  <a:srgbClr val="FF0000"/>
-                </a:solidFill>
-              </a:rPr>
-              <a:t>3</a:t>
-            </a:r>
-          </a:p>
-        </p:txBody>
-      </p:sp>
-      <p:sp>
-        <p:nvSpPr>
-          <p:cNvPr id="13" name="Rectangle 12">
-            <a:extLst>
-              <a:ext uri="{FF2B5EF4-FFF2-40B4-BE49-F238E27FC236}">
-                <a16:creationId xmlns:a16="http://schemas.microsoft.com/office/drawing/2014/main" id="{C108EFD0-0B82-6469-1709-FA5655D787C6}"/>
-              </a:ext>
-            </a:extLst>
-          </p:cNvPr>
-          <p:cNvSpPr/>
-          <p:nvPr/>
-        </p:nvSpPr>
-        <p:spPr>
-          <a:xfrm>
-            <a:off x="2017988" y="1992124"/>
-            <a:ext cx="4726843" cy="1602101"/>
-          </a:xfrm>
-          <a:prstGeom prst="rect">
-            <a:avLst/>
-          </a:prstGeom>
-          <a:noFill/>
-          <a:ln w="38100">
-            <a:solidFill>
-              <a:srgbClr val="FF0000"/>
-            </a:solidFill>
-          </a:ln>
+          <a:solidFill>
+            <a:srgbClr val="FF0000"/>
+          </a:solidFill>
         </p:spPr>
         <p:style>
           <a:lnRef idx="2">
@@ -5130,271 +5805,14 @@
           <a:lstStyle/>
           <a:p>
             <a:pPr algn="ctr"/>
-            <a:endParaRPr lang="en-US">
-              <a:ln w="0"/>
-              <a:solidFill>
-                <a:schemeClr val="tx1"/>
-              </a:solidFill>
-              <a:effectLst>
-                <a:outerShdw blurRad="38100" dist="19050" dir="2700000" algn="tl" rotWithShape="0">
-                  <a:schemeClr val="dk1">
-                    <a:alpha val="40000"/>
-                  </a:schemeClr>
-                </a:outerShdw>
-              </a:effectLst>
-            </a:endParaRPr>
-          </a:p>
-        </p:txBody>
-      </p:sp>
-      <p:sp>
-        <p:nvSpPr>
-          <p:cNvPr id="14" name="TextBox 13">
-            <a:extLst>
-              <a:ext uri="{FF2B5EF4-FFF2-40B4-BE49-F238E27FC236}">
-                <a16:creationId xmlns:a16="http://schemas.microsoft.com/office/drawing/2014/main" id="{A846B7CF-E7D2-BC5C-2705-E663D974A7E2}"/>
-              </a:ext>
-            </a:extLst>
-          </p:cNvPr>
-          <p:cNvSpPr txBox="1"/>
-          <p:nvPr/>
-        </p:nvSpPr>
-        <p:spPr>
-          <a:xfrm>
-            <a:off x="1709890" y="1992124"/>
-            <a:ext cx="308098" cy="369332"/>
-          </a:xfrm>
-          <a:prstGeom prst="rect">
-            <a:avLst/>
-          </a:prstGeom>
-          <a:noFill/>
-        </p:spPr>
-        <p:txBody>
-          <a:bodyPr wrap="none" rtlCol="0">
-            <a:spAutoFit/>
-          </a:bodyPr>
-          <a:lstStyle/>
-          <a:p>
-            <a:r>
-              <a:rPr lang="en-US" dirty="0">
-                <a:solidFill>
-                  <a:srgbClr val="FF0000"/>
-                </a:solidFill>
-              </a:rPr>
-              <a:t>4</a:t>
-            </a:r>
-          </a:p>
-        </p:txBody>
-      </p:sp>
-      <p:sp>
-        <p:nvSpPr>
-          <p:cNvPr id="15" name="Rectangle 14">
-            <a:extLst>
-              <a:ext uri="{FF2B5EF4-FFF2-40B4-BE49-F238E27FC236}">
-                <a16:creationId xmlns:a16="http://schemas.microsoft.com/office/drawing/2014/main" id="{12D14BB5-5053-B952-61E5-BD8A6FC3A4AD}"/>
-              </a:ext>
-            </a:extLst>
-          </p:cNvPr>
-          <p:cNvSpPr/>
-          <p:nvPr/>
-        </p:nvSpPr>
-        <p:spPr>
-          <a:xfrm>
-            <a:off x="6835251" y="774810"/>
-            <a:ext cx="3308907" cy="1206377"/>
-          </a:xfrm>
-          <a:prstGeom prst="rect">
-            <a:avLst/>
-          </a:prstGeom>
-          <a:noFill/>
-          <a:ln w="38100">
-            <a:solidFill>
-              <a:srgbClr val="FF0000"/>
-            </a:solidFill>
-          </a:ln>
-        </p:spPr>
-        <p:style>
-          <a:lnRef idx="2">
-            <a:schemeClr val="accent1">
-              <a:shade val="15000"/>
-            </a:schemeClr>
-          </a:lnRef>
-          <a:fillRef idx="1">
-            <a:schemeClr val="accent1"/>
-          </a:fillRef>
-          <a:effectRef idx="0">
-            <a:schemeClr val="accent1"/>
-          </a:effectRef>
-          <a:fontRef idx="minor">
-            <a:schemeClr val="lt1"/>
-          </a:fontRef>
-        </p:style>
-        <p:txBody>
-          <a:bodyPr rtlCol="0" anchor="ctr"/>
-          <a:lstStyle/>
-          <a:p>
-            <a:pPr algn="ctr"/>
-            <a:endParaRPr lang="en-US">
-              <a:ln w="0"/>
-              <a:solidFill>
-                <a:schemeClr val="tx1"/>
-              </a:solidFill>
-              <a:effectLst>
-                <a:outerShdw blurRad="38100" dist="19050" dir="2700000" algn="tl" rotWithShape="0">
-                  <a:schemeClr val="dk1">
-                    <a:alpha val="40000"/>
-                  </a:schemeClr>
-                </a:outerShdw>
-              </a:effectLst>
-            </a:endParaRPr>
-          </a:p>
-        </p:txBody>
-      </p:sp>
-      <p:sp>
-        <p:nvSpPr>
-          <p:cNvPr id="16" name="TextBox 15">
-            <a:extLst>
-              <a:ext uri="{FF2B5EF4-FFF2-40B4-BE49-F238E27FC236}">
-                <a16:creationId xmlns:a16="http://schemas.microsoft.com/office/drawing/2014/main" id="{98610F23-443B-34BB-F719-A7433A6FF245}"/>
-              </a:ext>
-            </a:extLst>
-          </p:cNvPr>
-          <p:cNvSpPr txBox="1"/>
-          <p:nvPr/>
-        </p:nvSpPr>
-        <p:spPr>
-          <a:xfrm>
-            <a:off x="10109018" y="702462"/>
-            <a:ext cx="308098" cy="369332"/>
-          </a:xfrm>
-          <a:prstGeom prst="rect">
-            <a:avLst/>
-          </a:prstGeom>
-          <a:noFill/>
-        </p:spPr>
-        <p:txBody>
-          <a:bodyPr wrap="none" rtlCol="0">
-            <a:spAutoFit/>
-          </a:bodyPr>
-          <a:lstStyle/>
-          <a:p>
-            <a:r>
-              <a:rPr lang="en-US" dirty="0">
-                <a:solidFill>
-                  <a:srgbClr val="FF0000"/>
-                </a:solidFill>
-              </a:rPr>
-              <a:t>5</a:t>
-            </a:r>
-          </a:p>
-        </p:txBody>
-      </p:sp>
-      <p:sp>
-        <p:nvSpPr>
-          <p:cNvPr id="17" name="Rectangle 16">
-            <a:extLst>
-              <a:ext uri="{FF2B5EF4-FFF2-40B4-BE49-F238E27FC236}">
-                <a16:creationId xmlns:a16="http://schemas.microsoft.com/office/drawing/2014/main" id="{5710D559-00D9-D4B5-840E-0929DD1D3752}"/>
-              </a:ext>
-            </a:extLst>
-          </p:cNvPr>
-          <p:cNvSpPr/>
-          <p:nvPr/>
-        </p:nvSpPr>
-        <p:spPr>
-          <a:xfrm>
-            <a:off x="6835250" y="2044924"/>
-            <a:ext cx="3308907" cy="4016394"/>
-          </a:xfrm>
-          <a:prstGeom prst="rect">
-            <a:avLst/>
-          </a:prstGeom>
-          <a:noFill/>
-          <a:ln w="38100">
-            <a:solidFill>
-              <a:srgbClr val="FF0000"/>
-            </a:solidFill>
-          </a:ln>
-        </p:spPr>
-        <p:style>
-          <a:lnRef idx="2">
-            <a:schemeClr val="accent1">
-              <a:shade val="15000"/>
-            </a:schemeClr>
-          </a:lnRef>
-          <a:fillRef idx="1">
-            <a:schemeClr val="accent1"/>
-          </a:fillRef>
-          <a:effectRef idx="0">
-            <a:schemeClr val="accent1"/>
-          </a:effectRef>
-          <a:fontRef idx="minor">
-            <a:schemeClr val="lt1"/>
-          </a:fontRef>
-        </p:style>
-        <p:txBody>
-          <a:bodyPr rtlCol="0" anchor="ctr"/>
-          <a:lstStyle/>
-          <a:p>
-            <a:pPr algn="ctr"/>
-            <a:endParaRPr lang="en-US">
-              <a:ln w="0"/>
-              <a:solidFill>
-                <a:schemeClr val="tx1"/>
-              </a:solidFill>
-              <a:effectLst>
-                <a:outerShdw blurRad="38100" dist="19050" dir="2700000" algn="tl" rotWithShape="0">
-                  <a:schemeClr val="dk1">
-                    <a:alpha val="40000"/>
-                  </a:schemeClr>
-                </a:outerShdw>
-              </a:effectLst>
-            </a:endParaRPr>
-          </a:p>
-        </p:txBody>
-      </p:sp>
-      <p:sp>
-        <p:nvSpPr>
-          <p:cNvPr id="18" name="TextBox 17">
-            <a:extLst>
-              <a:ext uri="{FF2B5EF4-FFF2-40B4-BE49-F238E27FC236}">
-                <a16:creationId xmlns:a16="http://schemas.microsoft.com/office/drawing/2014/main" id="{DDAEC382-88AF-0048-E5CD-7007074237EA}"/>
-              </a:ext>
-            </a:extLst>
-          </p:cNvPr>
-          <p:cNvSpPr txBox="1"/>
-          <p:nvPr/>
-        </p:nvSpPr>
-        <p:spPr>
-          <a:xfrm>
-            <a:off x="10144157" y="1981187"/>
-            <a:ext cx="308098" cy="369332"/>
-          </a:xfrm>
-          <a:prstGeom prst="rect">
-            <a:avLst/>
-          </a:prstGeom>
-          <a:noFill/>
-        </p:spPr>
-        <p:txBody>
-          <a:bodyPr wrap="none" rtlCol="0">
-            <a:spAutoFit/>
-          </a:bodyPr>
-          <a:lstStyle/>
-          <a:p>
-            <a:r>
-              <a:rPr lang="en-US" dirty="0">
-                <a:solidFill>
-                  <a:srgbClr val="FF0000"/>
-                </a:solidFill>
-              </a:rPr>
-              <a:t>6</a:t>
-            </a:r>
+            <a:endParaRPr lang="en-US"/>
           </a:p>
         </p:txBody>
       </p:sp>
     </p:spTree>
     <p:extLst>
       <p:ext uri="{BB962C8B-B14F-4D97-AF65-F5344CB8AC3E}">
-        <p14:creationId xmlns:p14="http://schemas.microsoft.com/office/powerpoint/2010/main" val="2030273751"/>
+        <p14:creationId xmlns:p14="http://schemas.microsoft.com/office/powerpoint/2010/main" val="2709341814"/>
       </p:ext>
     </p:extLst>
   </p:cSld>
@@ -5404,1039 +5822,7 @@
 </p:sld>
 </file>
 
-<file path=ppt/slides/slide3.xml><?xml version="1.0" encoding="utf-8"?>
-<p:sld xmlns:a="http://schemas.openxmlformats.org/drawingml/2006/main" xmlns:r="http://schemas.openxmlformats.org/officeDocument/2006/relationships" xmlns:p="http://schemas.openxmlformats.org/presentationml/2006/main">
-  <p:cSld>
-    <p:spTree>
-      <p:nvGrpSpPr>
-        <p:cNvPr id="1" name="">
-          <a:extLst>
-            <a:ext uri="{FF2B5EF4-FFF2-40B4-BE49-F238E27FC236}">
-              <a16:creationId xmlns:a16="http://schemas.microsoft.com/office/drawing/2014/main" id="{1C7C15F3-1C36-3169-7045-1C0AB65E9E14}"/>
-            </a:ext>
-          </a:extLst>
-        </p:cNvPr>
-        <p:cNvGrpSpPr/>
-        <p:nvPr/>
-      </p:nvGrpSpPr>
-      <p:grpSpPr>
-        <a:xfrm>
-          <a:off x="0" y="0"/>
-          <a:ext cx="0" cy="0"/>
-          <a:chOff x="0" y="0"/>
-          <a:chExt cx="0" cy="0"/>
-        </a:xfrm>
-      </p:grpSpPr>
-      <p:pic>
-        <p:nvPicPr>
-          <p:cNvPr id="5" name="Picture 4">
-            <a:extLst>
-              <a:ext uri="{FF2B5EF4-FFF2-40B4-BE49-F238E27FC236}">
-                <a16:creationId xmlns:a16="http://schemas.microsoft.com/office/drawing/2014/main" id="{60C0A187-7FAE-AE45-10F5-3BAF0B34869C}"/>
-              </a:ext>
-            </a:extLst>
-          </p:cNvPr>
-          <p:cNvPicPr>
-            <a:picLocks noGrp="1" noRot="1" noChangeAspect="1" noMove="1" noResize="1" noEditPoints="1" noAdjustHandles="1" noChangeArrowheads="1" noChangeShapeType="1" noCrop="1"/>
-          </p:cNvPicPr>
-          <p:nvPr/>
-        </p:nvPicPr>
-        <p:blipFill>
-          <a:blip r:embed="rId3">
-            <a:extLst>
-              <a:ext uri="{28A0092B-C50C-407E-A947-70E740481C1C}">
-                <a14:useLocalDpi xmlns:a14="http://schemas.microsoft.com/office/drawing/2010/main" val="0"/>
-              </a:ext>
-            </a:extLst>
-          </a:blip>
-          <a:srcRect/>
-          <a:stretch/>
-        </p:blipFill>
-        <p:spPr>
-          <a:xfrm>
-            <a:off x="1316272" y="290074"/>
-            <a:ext cx="9559455" cy="6277851"/>
-          </a:xfrm>
-          <a:prstGeom prst="rect">
-            <a:avLst/>
-          </a:prstGeom>
-        </p:spPr>
-      </p:pic>
-      <p:sp>
-        <p:nvSpPr>
-          <p:cNvPr id="9" name="Rectangle 8">
-            <a:extLst>
-              <a:ext uri="{FF2B5EF4-FFF2-40B4-BE49-F238E27FC236}">
-                <a16:creationId xmlns:a16="http://schemas.microsoft.com/office/drawing/2014/main" id="{0ACD48EA-BFF4-77F4-FA55-A99720CB1B88}"/>
-              </a:ext>
-            </a:extLst>
-          </p:cNvPr>
-          <p:cNvSpPr/>
-          <p:nvPr/>
-        </p:nvSpPr>
-        <p:spPr>
-          <a:xfrm>
-            <a:off x="4239380" y="176164"/>
-            <a:ext cx="1567758" cy="534909"/>
-          </a:xfrm>
-          <a:prstGeom prst="rect">
-            <a:avLst/>
-          </a:prstGeom>
-          <a:noFill/>
-          <a:ln w="38100">
-            <a:solidFill>
-              <a:srgbClr val="FF0000"/>
-            </a:solidFill>
-          </a:ln>
-        </p:spPr>
-        <p:style>
-          <a:lnRef idx="2">
-            <a:schemeClr val="accent1">
-              <a:shade val="15000"/>
-            </a:schemeClr>
-          </a:lnRef>
-          <a:fillRef idx="1">
-            <a:schemeClr val="accent1"/>
-          </a:fillRef>
-          <a:effectRef idx="0">
-            <a:schemeClr val="accent1"/>
-          </a:effectRef>
-          <a:fontRef idx="minor">
-            <a:schemeClr val="lt1"/>
-          </a:fontRef>
-        </p:style>
-        <p:txBody>
-          <a:bodyPr rtlCol="0" anchor="ctr"/>
-          <a:lstStyle/>
-          <a:p>
-            <a:pPr algn="ctr"/>
-            <a:endParaRPr lang="en-US">
-              <a:ln w="0"/>
-              <a:solidFill>
-                <a:schemeClr val="tx1"/>
-              </a:solidFill>
-              <a:effectLst>
-                <a:outerShdw blurRad="38100" dist="19050" dir="2700000" algn="tl" rotWithShape="0">
-                  <a:schemeClr val="dk1">
-                    <a:alpha val="40000"/>
-                  </a:schemeClr>
-                </a:outerShdw>
-              </a:effectLst>
-            </a:endParaRPr>
-          </a:p>
-        </p:txBody>
-      </p:sp>
-    </p:spTree>
-    <p:extLst>
-      <p:ext uri="{BB962C8B-B14F-4D97-AF65-F5344CB8AC3E}">
-        <p14:creationId xmlns:p14="http://schemas.microsoft.com/office/powerpoint/2010/main" val="2427920272"/>
-      </p:ext>
-    </p:extLst>
-  </p:cSld>
-  <p:clrMapOvr>
-    <a:masterClrMapping/>
-  </p:clrMapOvr>
-</p:sld>
-</file>
-
-<file path=ppt/slides/slide4.xml><?xml version="1.0" encoding="utf-8"?>
-<p:sld xmlns:a="http://schemas.openxmlformats.org/drawingml/2006/main" xmlns:r="http://schemas.openxmlformats.org/officeDocument/2006/relationships" xmlns:p="http://schemas.openxmlformats.org/presentationml/2006/main">
-  <p:cSld>
-    <p:spTree>
-      <p:nvGrpSpPr>
-        <p:cNvPr id="1" name="">
-          <a:extLst>
-            <a:ext uri="{FF2B5EF4-FFF2-40B4-BE49-F238E27FC236}">
-              <a16:creationId xmlns:a16="http://schemas.microsoft.com/office/drawing/2014/main" id="{4699E48C-9048-EDE2-981B-D5B27D232C60}"/>
-            </a:ext>
-          </a:extLst>
-        </p:cNvPr>
-        <p:cNvGrpSpPr/>
-        <p:nvPr/>
-      </p:nvGrpSpPr>
-      <p:grpSpPr>
-        <a:xfrm>
-          <a:off x="0" y="0"/>
-          <a:ext cx="0" cy="0"/>
-          <a:chOff x="0" y="0"/>
-          <a:chExt cx="0" cy="0"/>
-        </a:xfrm>
-      </p:grpSpPr>
-      <p:sp>
-        <p:nvSpPr>
-          <p:cNvPr id="8" name="TextBox 7">
-            <a:extLst>
-              <a:ext uri="{FF2B5EF4-FFF2-40B4-BE49-F238E27FC236}">
-                <a16:creationId xmlns:a16="http://schemas.microsoft.com/office/drawing/2014/main" id="{1E107447-00AF-0794-5BDB-B5C886C40847}"/>
-              </a:ext>
-            </a:extLst>
-          </p:cNvPr>
-          <p:cNvSpPr txBox="1"/>
-          <p:nvPr/>
-        </p:nvSpPr>
-        <p:spPr>
-          <a:xfrm>
-            <a:off x="1247106" y="612000"/>
-            <a:ext cx="308098" cy="369332"/>
-          </a:xfrm>
-          <a:prstGeom prst="rect">
-            <a:avLst/>
-          </a:prstGeom>
-          <a:noFill/>
-        </p:spPr>
-        <p:txBody>
-          <a:bodyPr wrap="none" rtlCol="0">
-            <a:spAutoFit/>
-          </a:bodyPr>
-          <a:lstStyle/>
-          <a:p>
-            <a:r>
-              <a:rPr lang="en-US" dirty="0">
-                <a:solidFill>
-                  <a:srgbClr val="FF0000"/>
-                </a:solidFill>
-              </a:rPr>
-              <a:t>1</a:t>
-            </a:r>
-          </a:p>
-        </p:txBody>
-      </p:sp>
-      <p:sp>
-        <p:nvSpPr>
-          <p:cNvPr id="10" name="TextBox 9">
-            <a:extLst>
-              <a:ext uri="{FF2B5EF4-FFF2-40B4-BE49-F238E27FC236}">
-                <a16:creationId xmlns:a16="http://schemas.microsoft.com/office/drawing/2014/main" id="{167DA61D-8CB4-5D76-7A06-103433A298DE}"/>
-              </a:ext>
-            </a:extLst>
-          </p:cNvPr>
-          <p:cNvSpPr txBox="1"/>
-          <p:nvPr/>
-        </p:nvSpPr>
-        <p:spPr>
-          <a:xfrm>
-            <a:off x="1956074" y="612000"/>
-            <a:ext cx="308098" cy="369332"/>
-          </a:xfrm>
-          <a:prstGeom prst="rect">
-            <a:avLst/>
-          </a:prstGeom>
-          <a:noFill/>
-        </p:spPr>
-        <p:txBody>
-          <a:bodyPr wrap="none" rtlCol="0">
-            <a:spAutoFit/>
-          </a:bodyPr>
-          <a:lstStyle/>
-          <a:p>
-            <a:r>
-              <a:rPr lang="en-US" dirty="0">
-                <a:solidFill>
-                  <a:srgbClr val="FF0000"/>
-                </a:solidFill>
-              </a:rPr>
-              <a:t>2</a:t>
-            </a:r>
-          </a:p>
-        </p:txBody>
-      </p:sp>
-      <p:sp>
-        <p:nvSpPr>
-          <p:cNvPr id="12" name="TextBox 11">
-            <a:extLst>
-              <a:ext uri="{FF2B5EF4-FFF2-40B4-BE49-F238E27FC236}">
-                <a16:creationId xmlns:a16="http://schemas.microsoft.com/office/drawing/2014/main" id="{60A86629-EEE5-FC0A-0F80-BB58BCCCBBAC}"/>
-              </a:ext>
-            </a:extLst>
-          </p:cNvPr>
-          <p:cNvSpPr txBox="1"/>
-          <p:nvPr/>
-        </p:nvSpPr>
-        <p:spPr>
-          <a:xfrm>
-            <a:off x="4104990" y="612000"/>
-            <a:ext cx="308098" cy="369332"/>
-          </a:xfrm>
-          <a:prstGeom prst="rect">
-            <a:avLst/>
-          </a:prstGeom>
-          <a:noFill/>
-        </p:spPr>
-        <p:txBody>
-          <a:bodyPr wrap="none" rtlCol="0">
-            <a:spAutoFit/>
-          </a:bodyPr>
-          <a:lstStyle/>
-          <a:p>
-            <a:r>
-              <a:rPr lang="en-US" dirty="0">
-                <a:solidFill>
-                  <a:srgbClr val="FF0000"/>
-                </a:solidFill>
-              </a:rPr>
-              <a:t>3</a:t>
-            </a:r>
-          </a:p>
-        </p:txBody>
-      </p:sp>
-      <p:sp>
-        <p:nvSpPr>
-          <p:cNvPr id="14" name="TextBox 13">
-            <a:extLst>
-              <a:ext uri="{FF2B5EF4-FFF2-40B4-BE49-F238E27FC236}">
-                <a16:creationId xmlns:a16="http://schemas.microsoft.com/office/drawing/2014/main" id="{AF8F806A-6581-ADA4-02E1-7E8FF39629F0}"/>
-              </a:ext>
-            </a:extLst>
-          </p:cNvPr>
-          <p:cNvSpPr txBox="1"/>
-          <p:nvPr/>
-        </p:nvSpPr>
-        <p:spPr>
-          <a:xfrm>
-            <a:off x="7592852" y="612000"/>
-            <a:ext cx="308098" cy="369332"/>
-          </a:xfrm>
-          <a:prstGeom prst="rect">
-            <a:avLst/>
-          </a:prstGeom>
-          <a:noFill/>
-        </p:spPr>
-        <p:txBody>
-          <a:bodyPr wrap="none" rtlCol="0">
-            <a:spAutoFit/>
-          </a:bodyPr>
-          <a:lstStyle/>
-          <a:p>
-            <a:r>
-              <a:rPr lang="en-US" dirty="0">
-                <a:solidFill>
-                  <a:srgbClr val="FF0000"/>
-                </a:solidFill>
-              </a:rPr>
-              <a:t>4</a:t>
-            </a:r>
-          </a:p>
-        </p:txBody>
-      </p:sp>
-      <p:sp>
-        <p:nvSpPr>
-          <p:cNvPr id="16" name="TextBox 15">
-            <a:extLst>
-              <a:ext uri="{FF2B5EF4-FFF2-40B4-BE49-F238E27FC236}">
-                <a16:creationId xmlns:a16="http://schemas.microsoft.com/office/drawing/2014/main" id="{BE2F7F57-2BC2-C81B-B04C-65FF5E1E8AEF}"/>
-              </a:ext>
-            </a:extLst>
-          </p:cNvPr>
-          <p:cNvSpPr txBox="1"/>
-          <p:nvPr/>
-        </p:nvSpPr>
-        <p:spPr>
-          <a:xfrm>
-            <a:off x="9254275" y="612000"/>
-            <a:ext cx="308098" cy="369332"/>
-          </a:xfrm>
-          <a:prstGeom prst="rect">
-            <a:avLst/>
-          </a:prstGeom>
-          <a:noFill/>
-        </p:spPr>
-        <p:txBody>
-          <a:bodyPr wrap="none" rtlCol="0">
-            <a:spAutoFit/>
-          </a:bodyPr>
-          <a:lstStyle/>
-          <a:p>
-            <a:r>
-              <a:rPr lang="en-US" dirty="0">
-                <a:solidFill>
-                  <a:srgbClr val="FF0000"/>
-                </a:solidFill>
-              </a:rPr>
-              <a:t>5</a:t>
-            </a:r>
-          </a:p>
-        </p:txBody>
-      </p:sp>
-      <p:sp>
-        <p:nvSpPr>
-          <p:cNvPr id="18" name="TextBox 17">
-            <a:extLst>
-              <a:ext uri="{FF2B5EF4-FFF2-40B4-BE49-F238E27FC236}">
-                <a16:creationId xmlns:a16="http://schemas.microsoft.com/office/drawing/2014/main" id="{5DDFC490-0EB6-E706-0A7A-D4107B4CBEF6}"/>
-              </a:ext>
-            </a:extLst>
-          </p:cNvPr>
-          <p:cNvSpPr txBox="1"/>
-          <p:nvPr/>
-        </p:nvSpPr>
-        <p:spPr>
-          <a:xfrm>
-            <a:off x="9741768" y="612000"/>
-            <a:ext cx="308098" cy="369332"/>
-          </a:xfrm>
-          <a:prstGeom prst="rect">
-            <a:avLst/>
-          </a:prstGeom>
-          <a:noFill/>
-        </p:spPr>
-        <p:txBody>
-          <a:bodyPr wrap="square" rtlCol="0">
-            <a:spAutoFit/>
-          </a:bodyPr>
-          <a:lstStyle/>
-          <a:p>
-            <a:r>
-              <a:rPr lang="en-US" dirty="0">
-                <a:solidFill>
-                  <a:srgbClr val="FF0000"/>
-                </a:solidFill>
-              </a:rPr>
-              <a:t>6</a:t>
-            </a:r>
-          </a:p>
-        </p:txBody>
-      </p:sp>
-      <p:sp>
-        <p:nvSpPr>
-          <p:cNvPr id="3" name="TextBox 2">
-            <a:extLst>
-              <a:ext uri="{FF2B5EF4-FFF2-40B4-BE49-F238E27FC236}">
-                <a16:creationId xmlns:a16="http://schemas.microsoft.com/office/drawing/2014/main" id="{9A8F4913-9D14-11CE-7CD0-FDE51C54D856}"/>
-              </a:ext>
-            </a:extLst>
-          </p:cNvPr>
-          <p:cNvSpPr txBox="1"/>
-          <p:nvPr/>
-        </p:nvSpPr>
-        <p:spPr>
-          <a:xfrm>
-            <a:off x="10100763" y="612000"/>
-            <a:ext cx="308098" cy="369332"/>
-          </a:xfrm>
-          <a:prstGeom prst="rect">
-            <a:avLst/>
-          </a:prstGeom>
-          <a:noFill/>
-        </p:spPr>
-        <p:txBody>
-          <a:bodyPr wrap="square" rtlCol="0">
-            <a:spAutoFit/>
-          </a:bodyPr>
-          <a:lstStyle/>
-          <a:p>
-            <a:r>
-              <a:rPr lang="en-US" dirty="0">
-                <a:solidFill>
-                  <a:srgbClr val="FF0000"/>
-                </a:solidFill>
-              </a:rPr>
-              <a:t>7</a:t>
-            </a:r>
-          </a:p>
-        </p:txBody>
-      </p:sp>
-      <p:pic>
-        <p:nvPicPr>
-          <p:cNvPr id="5" name="Picture 4">
-            <a:extLst>
-              <a:ext uri="{FF2B5EF4-FFF2-40B4-BE49-F238E27FC236}">
-                <a16:creationId xmlns:a16="http://schemas.microsoft.com/office/drawing/2014/main" id="{DADB91F5-08C6-5411-5BB7-3FFB52573ACF}"/>
-              </a:ext>
-            </a:extLst>
-          </p:cNvPr>
-          <p:cNvPicPr preferRelativeResize="0">
-            <a:picLocks/>
-          </p:cNvPicPr>
-          <p:nvPr/>
-        </p:nvPicPr>
-        <p:blipFill>
-          <a:blip r:embed="rId3">
-            <a:extLst>
-              <a:ext uri="{28A0092B-C50C-407E-A947-70E740481C1C}">
-                <a14:useLocalDpi xmlns:a14="http://schemas.microsoft.com/office/drawing/2010/main" val="0"/>
-              </a:ext>
-            </a:extLst>
-          </a:blip>
-          <a:srcRect t="-72" b="95205"/>
-          <a:stretch>
-            <a:fillRect/>
-          </a:stretch>
-        </p:blipFill>
-        <p:spPr>
-          <a:xfrm>
-            <a:off x="1296000" y="288000"/>
-            <a:ext cx="9573961" cy="306000"/>
-          </a:xfrm>
-          <a:prstGeom prst="rect">
-            <a:avLst/>
-          </a:prstGeom>
-        </p:spPr>
-      </p:pic>
-      <p:sp>
-        <p:nvSpPr>
-          <p:cNvPr id="7" name="Rectangle 6">
-            <a:extLst>
-              <a:ext uri="{FF2B5EF4-FFF2-40B4-BE49-F238E27FC236}">
-                <a16:creationId xmlns:a16="http://schemas.microsoft.com/office/drawing/2014/main" id="{1154C8EF-2181-C5EB-0505-FA6C78C42E85}"/>
-              </a:ext>
-            </a:extLst>
-          </p:cNvPr>
-          <p:cNvSpPr/>
-          <p:nvPr/>
-        </p:nvSpPr>
-        <p:spPr>
-          <a:xfrm>
-            <a:off x="1347788" y="216000"/>
-            <a:ext cx="508172" cy="432000"/>
-          </a:xfrm>
-          <a:prstGeom prst="rect">
-            <a:avLst/>
-          </a:prstGeom>
-          <a:noFill/>
-          <a:ln w="38100">
-            <a:solidFill>
-              <a:srgbClr val="FF0000"/>
-            </a:solidFill>
-          </a:ln>
-        </p:spPr>
-        <p:style>
-          <a:lnRef idx="2">
-            <a:schemeClr val="accent1">
-              <a:shade val="15000"/>
-            </a:schemeClr>
-          </a:lnRef>
-          <a:fillRef idx="1">
-            <a:schemeClr val="accent1"/>
-          </a:fillRef>
-          <a:effectRef idx="0">
-            <a:schemeClr val="accent1"/>
-          </a:effectRef>
-          <a:fontRef idx="minor">
-            <a:schemeClr val="lt1"/>
-          </a:fontRef>
-        </p:style>
-        <p:txBody>
-          <a:bodyPr rtlCol="0" anchor="ctr"/>
-          <a:lstStyle/>
-          <a:p>
-            <a:pPr algn="ctr"/>
-            <a:endParaRPr lang="en-US">
-              <a:ln w="0"/>
-              <a:solidFill>
-                <a:schemeClr val="tx1"/>
-              </a:solidFill>
-              <a:effectLst>
-                <a:outerShdw blurRad="38100" dist="19050" dir="2700000" algn="tl" rotWithShape="0">
-                  <a:schemeClr val="dk1">
-                    <a:alpha val="40000"/>
-                  </a:schemeClr>
-                </a:outerShdw>
-              </a:effectLst>
-            </a:endParaRPr>
-          </a:p>
-        </p:txBody>
-      </p:sp>
-      <p:sp>
-        <p:nvSpPr>
-          <p:cNvPr id="9" name="Rectangle 8">
-            <a:extLst>
-              <a:ext uri="{FF2B5EF4-FFF2-40B4-BE49-F238E27FC236}">
-                <a16:creationId xmlns:a16="http://schemas.microsoft.com/office/drawing/2014/main" id="{BB20B77C-AB5A-03CB-D8DA-1A5E8F64A150}"/>
-              </a:ext>
-            </a:extLst>
-          </p:cNvPr>
-          <p:cNvSpPr/>
-          <p:nvPr/>
-        </p:nvSpPr>
-        <p:spPr>
-          <a:xfrm>
-            <a:off x="2057400" y="216000"/>
-            <a:ext cx="381000" cy="432000"/>
-          </a:xfrm>
-          <a:prstGeom prst="rect">
-            <a:avLst/>
-          </a:prstGeom>
-          <a:noFill/>
-          <a:ln w="38100">
-            <a:solidFill>
-              <a:srgbClr val="FF0000"/>
-            </a:solidFill>
-          </a:ln>
-        </p:spPr>
-        <p:style>
-          <a:lnRef idx="2">
-            <a:schemeClr val="accent1">
-              <a:shade val="15000"/>
-            </a:schemeClr>
-          </a:lnRef>
-          <a:fillRef idx="1">
-            <a:schemeClr val="accent1"/>
-          </a:fillRef>
-          <a:effectRef idx="0">
-            <a:schemeClr val="accent1"/>
-          </a:effectRef>
-          <a:fontRef idx="minor">
-            <a:schemeClr val="lt1"/>
-          </a:fontRef>
-        </p:style>
-        <p:txBody>
-          <a:bodyPr rtlCol="0" anchor="ctr"/>
-          <a:lstStyle/>
-          <a:p>
-            <a:pPr algn="ctr"/>
-            <a:endParaRPr lang="en-US" dirty="0">
-              <a:ln w="0"/>
-              <a:solidFill>
-                <a:schemeClr val="tx1"/>
-              </a:solidFill>
-              <a:effectLst>
-                <a:outerShdw blurRad="38100" dist="19050" dir="2700000" algn="tl" rotWithShape="0">
-                  <a:schemeClr val="dk1">
-                    <a:alpha val="40000"/>
-                  </a:schemeClr>
-                </a:outerShdw>
-              </a:effectLst>
-            </a:endParaRPr>
-          </a:p>
-        </p:txBody>
-      </p:sp>
-      <p:sp>
-        <p:nvSpPr>
-          <p:cNvPr id="11" name="Rectangle 10">
-            <a:extLst>
-              <a:ext uri="{FF2B5EF4-FFF2-40B4-BE49-F238E27FC236}">
-                <a16:creationId xmlns:a16="http://schemas.microsoft.com/office/drawing/2014/main" id="{0A6D7683-FE00-C1C6-EE58-D18D58B85268}"/>
-              </a:ext>
-            </a:extLst>
-          </p:cNvPr>
-          <p:cNvSpPr/>
-          <p:nvPr/>
-        </p:nvSpPr>
-        <p:spPr>
-          <a:xfrm>
-            <a:off x="4209764" y="216000"/>
-            <a:ext cx="1538243" cy="432000"/>
-          </a:xfrm>
-          <a:prstGeom prst="rect">
-            <a:avLst/>
-          </a:prstGeom>
-          <a:noFill/>
-          <a:ln w="38100">
-            <a:solidFill>
-              <a:srgbClr val="FF0000"/>
-            </a:solidFill>
-          </a:ln>
-        </p:spPr>
-        <p:style>
-          <a:lnRef idx="2">
-            <a:schemeClr val="accent1">
-              <a:shade val="15000"/>
-            </a:schemeClr>
-          </a:lnRef>
-          <a:fillRef idx="1">
-            <a:schemeClr val="accent1"/>
-          </a:fillRef>
-          <a:effectRef idx="0">
-            <a:schemeClr val="accent1"/>
-          </a:effectRef>
-          <a:fontRef idx="minor">
-            <a:schemeClr val="lt1"/>
-          </a:fontRef>
-        </p:style>
-        <p:txBody>
-          <a:bodyPr rtlCol="0" anchor="ctr"/>
-          <a:lstStyle/>
-          <a:p>
-            <a:pPr algn="ctr"/>
-            <a:endParaRPr lang="en-US">
-              <a:ln w="0"/>
-              <a:solidFill>
-                <a:schemeClr val="tx1"/>
-              </a:solidFill>
-              <a:effectLst>
-                <a:outerShdw blurRad="38100" dist="19050" dir="2700000" algn="tl" rotWithShape="0">
-                  <a:schemeClr val="dk1">
-                    <a:alpha val="40000"/>
-                  </a:schemeClr>
-                </a:outerShdw>
-              </a:effectLst>
-            </a:endParaRPr>
-          </a:p>
-        </p:txBody>
-      </p:sp>
-      <p:sp>
-        <p:nvSpPr>
-          <p:cNvPr id="13" name="Rectangle 12">
-            <a:extLst>
-              <a:ext uri="{FF2B5EF4-FFF2-40B4-BE49-F238E27FC236}">
-                <a16:creationId xmlns:a16="http://schemas.microsoft.com/office/drawing/2014/main" id="{87F319DB-E90A-F9AB-1273-9B6163824C75}"/>
-              </a:ext>
-            </a:extLst>
-          </p:cNvPr>
-          <p:cNvSpPr/>
-          <p:nvPr/>
-        </p:nvSpPr>
-        <p:spPr>
-          <a:xfrm>
-            <a:off x="7707041" y="216000"/>
-            <a:ext cx="1495426" cy="432000"/>
-          </a:xfrm>
-          <a:prstGeom prst="rect">
-            <a:avLst/>
-          </a:prstGeom>
-          <a:noFill/>
-          <a:ln w="38100">
-            <a:solidFill>
-              <a:srgbClr val="FF0000"/>
-            </a:solidFill>
-          </a:ln>
-        </p:spPr>
-        <p:style>
-          <a:lnRef idx="2">
-            <a:schemeClr val="accent1">
-              <a:shade val="15000"/>
-            </a:schemeClr>
-          </a:lnRef>
-          <a:fillRef idx="1">
-            <a:schemeClr val="accent1"/>
-          </a:fillRef>
-          <a:effectRef idx="0">
-            <a:schemeClr val="accent1"/>
-          </a:effectRef>
-          <a:fontRef idx="minor">
-            <a:schemeClr val="lt1"/>
-          </a:fontRef>
-        </p:style>
-        <p:txBody>
-          <a:bodyPr rtlCol="0" anchor="ctr"/>
-          <a:lstStyle/>
-          <a:p>
-            <a:pPr algn="ctr"/>
-            <a:endParaRPr lang="en-US">
-              <a:ln w="0"/>
-              <a:solidFill>
-                <a:schemeClr val="tx1"/>
-              </a:solidFill>
-              <a:effectLst>
-                <a:outerShdw blurRad="38100" dist="19050" dir="2700000" algn="tl" rotWithShape="0">
-                  <a:schemeClr val="dk1">
-                    <a:alpha val="40000"/>
-                  </a:schemeClr>
-                </a:outerShdw>
-              </a:effectLst>
-            </a:endParaRPr>
-          </a:p>
-        </p:txBody>
-      </p:sp>
-      <p:sp>
-        <p:nvSpPr>
-          <p:cNvPr id="15" name="Rectangle 14">
-            <a:extLst>
-              <a:ext uri="{FF2B5EF4-FFF2-40B4-BE49-F238E27FC236}">
-                <a16:creationId xmlns:a16="http://schemas.microsoft.com/office/drawing/2014/main" id="{788F1A68-DAEC-8C35-0014-46C58CD04C8A}"/>
-              </a:ext>
-            </a:extLst>
-          </p:cNvPr>
-          <p:cNvSpPr/>
-          <p:nvPr/>
-        </p:nvSpPr>
-        <p:spPr>
-          <a:xfrm>
-            <a:off x="9316656" y="216000"/>
-            <a:ext cx="457200" cy="432000"/>
-          </a:xfrm>
-          <a:prstGeom prst="rect">
-            <a:avLst/>
-          </a:prstGeom>
-          <a:noFill/>
-          <a:ln w="38100">
-            <a:solidFill>
-              <a:srgbClr val="FF0000"/>
-            </a:solidFill>
-          </a:ln>
-        </p:spPr>
-        <p:style>
-          <a:lnRef idx="2">
-            <a:schemeClr val="accent1">
-              <a:shade val="15000"/>
-            </a:schemeClr>
-          </a:lnRef>
-          <a:fillRef idx="1">
-            <a:schemeClr val="accent1"/>
-          </a:fillRef>
-          <a:effectRef idx="0">
-            <a:schemeClr val="accent1"/>
-          </a:effectRef>
-          <a:fontRef idx="minor">
-            <a:schemeClr val="lt1"/>
-          </a:fontRef>
-        </p:style>
-        <p:txBody>
-          <a:bodyPr rtlCol="0" anchor="ctr"/>
-          <a:lstStyle/>
-          <a:p>
-            <a:pPr algn="ctr"/>
-            <a:endParaRPr lang="en-US">
-              <a:ln w="0"/>
-              <a:solidFill>
-                <a:schemeClr val="tx1"/>
-              </a:solidFill>
-              <a:effectLst>
-                <a:outerShdw blurRad="38100" dist="19050" dir="2700000" algn="tl" rotWithShape="0">
-                  <a:schemeClr val="dk1">
-                    <a:alpha val="40000"/>
-                  </a:schemeClr>
-                </a:outerShdw>
-              </a:effectLst>
-            </a:endParaRPr>
-          </a:p>
-        </p:txBody>
-      </p:sp>
-      <p:sp>
-        <p:nvSpPr>
-          <p:cNvPr id="17" name="Rectangle 16">
-            <a:extLst>
-              <a:ext uri="{FF2B5EF4-FFF2-40B4-BE49-F238E27FC236}">
-                <a16:creationId xmlns:a16="http://schemas.microsoft.com/office/drawing/2014/main" id="{DC3D1C54-23C5-BAF7-DF50-16DF8B60CF66}"/>
-              </a:ext>
-            </a:extLst>
-          </p:cNvPr>
-          <p:cNvSpPr/>
-          <p:nvPr/>
-        </p:nvSpPr>
-        <p:spPr>
-          <a:xfrm>
-            <a:off x="9848507" y="216000"/>
-            <a:ext cx="286093" cy="432000"/>
-          </a:xfrm>
-          <a:prstGeom prst="rect">
-            <a:avLst/>
-          </a:prstGeom>
-          <a:noFill/>
-          <a:ln w="38100">
-            <a:solidFill>
-              <a:srgbClr val="FF0000"/>
-            </a:solidFill>
-          </a:ln>
-        </p:spPr>
-        <p:style>
-          <a:lnRef idx="2">
-            <a:schemeClr val="accent1">
-              <a:shade val="15000"/>
-            </a:schemeClr>
-          </a:lnRef>
-          <a:fillRef idx="1">
-            <a:schemeClr val="accent1"/>
-          </a:fillRef>
-          <a:effectRef idx="0">
-            <a:schemeClr val="accent1"/>
-          </a:effectRef>
-          <a:fontRef idx="minor">
-            <a:schemeClr val="lt1"/>
-          </a:fontRef>
-        </p:style>
-        <p:txBody>
-          <a:bodyPr rtlCol="0" anchor="ctr"/>
-          <a:lstStyle/>
-          <a:p>
-            <a:pPr algn="ctr"/>
-            <a:endParaRPr lang="en-US">
-              <a:ln w="0"/>
-              <a:solidFill>
-                <a:schemeClr val="tx1"/>
-              </a:solidFill>
-              <a:effectLst>
-                <a:outerShdw blurRad="38100" dist="19050" dir="2700000" algn="tl" rotWithShape="0">
-                  <a:schemeClr val="dk1">
-                    <a:alpha val="40000"/>
-                  </a:schemeClr>
-                </a:outerShdw>
-              </a:effectLst>
-            </a:endParaRPr>
-          </a:p>
-        </p:txBody>
-      </p:sp>
-      <p:sp>
-        <p:nvSpPr>
-          <p:cNvPr id="2" name="Rectangle 1">
-            <a:extLst>
-              <a:ext uri="{FF2B5EF4-FFF2-40B4-BE49-F238E27FC236}">
-                <a16:creationId xmlns:a16="http://schemas.microsoft.com/office/drawing/2014/main" id="{FE3672EF-3DAF-C198-9141-FDF246494426}"/>
-              </a:ext>
-            </a:extLst>
-          </p:cNvPr>
-          <p:cNvSpPr/>
-          <p:nvPr/>
-        </p:nvSpPr>
-        <p:spPr>
-          <a:xfrm>
-            <a:off x="10215520" y="216000"/>
-            <a:ext cx="286213" cy="432000"/>
-          </a:xfrm>
-          <a:prstGeom prst="rect">
-            <a:avLst/>
-          </a:prstGeom>
-          <a:noFill/>
-          <a:ln w="38100">
-            <a:solidFill>
-              <a:srgbClr val="FF0000"/>
-            </a:solidFill>
-          </a:ln>
-        </p:spPr>
-        <p:style>
-          <a:lnRef idx="2">
-            <a:schemeClr val="accent1">
-              <a:shade val="15000"/>
-            </a:schemeClr>
-          </a:lnRef>
-          <a:fillRef idx="1">
-            <a:schemeClr val="accent1"/>
-          </a:fillRef>
-          <a:effectRef idx="0">
-            <a:schemeClr val="accent1"/>
-          </a:effectRef>
-          <a:fontRef idx="minor">
-            <a:schemeClr val="lt1"/>
-          </a:fontRef>
-        </p:style>
-        <p:txBody>
-          <a:bodyPr rtlCol="0" anchor="ctr"/>
-          <a:lstStyle/>
-          <a:p>
-            <a:pPr algn="ctr"/>
-            <a:endParaRPr lang="en-US">
-              <a:ln w="0"/>
-              <a:solidFill>
-                <a:schemeClr val="tx1"/>
-              </a:solidFill>
-              <a:effectLst>
-                <a:outerShdw blurRad="38100" dist="19050" dir="2700000" algn="tl" rotWithShape="0">
-                  <a:schemeClr val="dk1">
-                    <a:alpha val="40000"/>
-                  </a:schemeClr>
-                </a:outerShdw>
-              </a:effectLst>
-            </a:endParaRPr>
-          </a:p>
-        </p:txBody>
-      </p:sp>
-      <p:sp>
-        <p:nvSpPr>
-          <p:cNvPr id="4" name="Rectangle 3">
-            <a:extLst>
-              <a:ext uri="{FF2B5EF4-FFF2-40B4-BE49-F238E27FC236}">
-                <a16:creationId xmlns:a16="http://schemas.microsoft.com/office/drawing/2014/main" id="{55F31252-F204-60C8-FB1F-4DD70CEEED95}"/>
-              </a:ext>
-            </a:extLst>
-          </p:cNvPr>
-          <p:cNvSpPr/>
-          <p:nvPr/>
-        </p:nvSpPr>
-        <p:spPr>
-          <a:xfrm>
-            <a:off x="10596767" y="216000"/>
-            <a:ext cx="286213" cy="432000"/>
-          </a:xfrm>
-          <a:prstGeom prst="rect">
-            <a:avLst/>
-          </a:prstGeom>
-          <a:noFill/>
-          <a:ln w="38100">
-            <a:solidFill>
-              <a:srgbClr val="FF0000"/>
-            </a:solidFill>
-          </a:ln>
-        </p:spPr>
-        <p:style>
-          <a:lnRef idx="2">
-            <a:schemeClr val="accent1">
-              <a:shade val="15000"/>
-            </a:schemeClr>
-          </a:lnRef>
-          <a:fillRef idx="1">
-            <a:schemeClr val="accent1"/>
-          </a:fillRef>
-          <a:effectRef idx="0">
-            <a:schemeClr val="accent1"/>
-          </a:effectRef>
-          <a:fontRef idx="minor">
-            <a:schemeClr val="lt1"/>
-          </a:fontRef>
-        </p:style>
-        <p:txBody>
-          <a:bodyPr rtlCol="0" anchor="ctr"/>
-          <a:lstStyle/>
-          <a:p>
-            <a:pPr algn="ctr"/>
-            <a:endParaRPr lang="en-US">
-              <a:ln w="0"/>
-              <a:solidFill>
-                <a:schemeClr val="tx1"/>
-              </a:solidFill>
-              <a:effectLst>
-                <a:outerShdw blurRad="38100" dist="19050" dir="2700000" algn="tl" rotWithShape="0">
-                  <a:schemeClr val="dk1">
-                    <a:alpha val="40000"/>
-                  </a:schemeClr>
-                </a:outerShdw>
-              </a:effectLst>
-            </a:endParaRPr>
-          </a:p>
-        </p:txBody>
-      </p:sp>
-      <p:sp>
-        <p:nvSpPr>
-          <p:cNvPr id="6" name="TextBox 5">
-            <a:extLst>
-              <a:ext uri="{FF2B5EF4-FFF2-40B4-BE49-F238E27FC236}">
-                <a16:creationId xmlns:a16="http://schemas.microsoft.com/office/drawing/2014/main" id="{EB222A99-1A52-EE89-5996-96FF2E6428F0}"/>
-              </a:ext>
-            </a:extLst>
-          </p:cNvPr>
-          <p:cNvSpPr txBox="1"/>
-          <p:nvPr/>
-        </p:nvSpPr>
-        <p:spPr>
-          <a:xfrm>
-            <a:off x="10512490" y="612000"/>
-            <a:ext cx="308098" cy="369332"/>
-          </a:xfrm>
-          <a:prstGeom prst="rect">
-            <a:avLst/>
-          </a:prstGeom>
-          <a:noFill/>
-        </p:spPr>
-        <p:txBody>
-          <a:bodyPr wrap="square" rtlCol="0">
-            <a:spAutoFit/>
-          </a:bodyPr>
-          <a:lstStyle/>
-          <a:p>
-            <a:r>
-              <a:rPr lang="en-US" dirty="0">
-                <a:solidFill>
-                  <a:srgbClr val="FF0000"/>
-                </a:solidFill>
-              </a:rPr>
-              <a:t>8</a:t>
-            </a:r>
-          </a:p>
-        </p:txBody>
-      </p:sp>
-    </p:spTree>
-    <p:extLst>
-      <p:ext uri="{BB962C8B-B14F-4D97-AF65-F5344CB8AC3E}">
-        <p14:creationId xmlns:p14="http://schemas.microsoft.com/office/powerpoint/2010/main" val="1838129098"/>
-      </p:ext>
-    </p:extLst>
-  </p:cSld>
-  <p:clrMapOvr>
-    <a:masterClrMapping/>
-  </p:clrMapOvr>
-</p:sld>
-</file>
-
-<file path=ppt/slides/slide5.xml><?xml version="1.0" encoding="utf-8"?>
+<file path=ppt/slides/slide15.xml><?xml version="1.0" encoding="utf-8"?>
 <p:sld xmlns:a="http://schemas.openxmlformats.org/drawingml/2006/main" xmlns:r="http://schemas.openxmlformats.org/officeDocument/2006/relationships" xmlns:p="http://schemas.openxmlformats.org/presentationml/2006/main">
   <p:cSld>
     <p:spTree>
@@ -6534,7 +5920,7 @@
 </p:sld>
 </file>
 
-<file path=ppt/slides/slide6.xml><?xml version="1.0" encoding="utf-8"?>
+<file path=ppt/slides/slide16.xml><?xml version="1.0" encoding="utf-8"?>
 <p:sld xmlns:a="http://schemas.openxmlformats.org/drawingml/2006/main" xmlns:r="http://schemas.openxmlformats.org/officeDocument/2006/relationships" xmlns:p="http://schemas.openxmlformats.org/presentationml/2006/main">
   <p:cSld>
     <p:spTree>
@@ -7007,6 +6393,2140 @@
     <p:extLst>
       <p:ext uri="{BB962C8B-B14F-4D97-AF65-F5344CB8AC3E}">
         <p14:creationId xmlns:p14="http://schemas.microsoft.com/office/powerpoint/2010/main" val="2371670190"/>
+      </p:ext>
+    </p:extLst>
+  </p:cSld>
+  <p:clrMapOvr>
+    <a:masterClrMapping/>
+  </p:clrMapOvr>
+</p:sld>
+</file>
+
+<file path=ppt/slides/slide2.xml><?xml version="1.0" encoding="utf-8"?>
+<p:sld xmlns:a="http://schemas.openxmlformats.org/drawingml/2006/main" xmlns:r="http://schemas.openxmlformats.org/officeDocument/2006/relationships" xmlns:p="http://schemas.openxmlformats.org/presentationml/2006/main">
+  <p:cSld>
+    <p:spTree>
+      <p:nvGrpSpPr>
+        <p:cNvPr id="1" name=""/>
+        <p:cNvGrpSpPr/>
+        <p:nvPr/>
+      </p:nvGrpSpPr>
+      <p:grpSpPr>
+        <a:xfrm>
+          <a:off x="0" y="0"/>
+          <a:ext cx="0" cy="0"/>
+          <a:chOff x="0" y="0"/>
+          <a:chExt cx="0" cy="0"/>
+        </a:xfrm>
+      </p:grpSpPr>
+      <p:pic>
+        <p:nvPicPr>
+          <p:cNvPr id="5" name="Picture 4">
+            <a:extLst>
+              <a:ext uri="{FF2B5EF4-FFF2-40B4-BE49-F238E27FC236}">
+                <a16:creationId xmlns:a16="http://schemas.microsoft.com/office/drawing/2014/main" id="{B97F010C-709D-B042-411F-8C6D7807055A}"/>
+              </a:ext>
+            </a:extLst>
+          </p:cNvPr>
+          <p:cNvPicPr>
+            <a:picLocks noChangeAspect="1"/>
+          </p:cNvPicPr>
+          <p:nvPr/>
+        </p:nvPicPr>
+        <p:blipFill>
+          <a:blip r:embed="rId2"/>
+          <a:stretch>
+            <a:fillRect/>
+          </a:stretch>
+        </p:blipFill>
+        <p:spPr>
+          <a:xfrm>
+            <a:off x="461176" y="113837"/>
+            <a:ext cx="11269648" cy="6630325"/>
+          </a:xfrm>
+          <a:prstGeom prst="rect">
+            <a:avLst/>
+          </a:prstGeom>
+        </p:spPr>
+      </p:pic>
+    </p:spTree>
+    <p:extLst>
+      <p:ext uri="{BB962C8B-B14F-4D97-AF65-F5344CB8AC3E}">
+        <p14:creationId xmlns:p14="http://schemas.microsoft.com/office/powerpoint/2010/main" val="837334526"/>
+      </p:ext>
+    </p:extLst>
+  </p:cSld>
+  <p:clrMapOvr>
+    <a:masterClrMapping/>
+  </p:clrMapOvr>
+</p:sld>
+</file>
+
+<file path=ppt/slides/slide3.xml><?xml version="1.0" encoding="utf-8"?>
+<p:sld xmlns:a="http://schemas.openxmlformats.org/drawingml/2006/main" xmlns:r="http://schemas.openxmlformats.org/officeDocument/2006/relationships" xmlns:p="http://schemas.openxmlformats.org/presentationml/2006/main">
+  <p:cSld>
+    <p:spTree>
+      <p:nvGrpSpPr>
+        <p:cNvPr id="1" name="">
+          <a:extLst>
+            <a:ext uri="{FF2B5EF4-FFF2-40B4-BE49-F238E27FC236}">
+              <a16:creationId xmlns:a16="http://schemas.microsoft.com/office/drawing/2014/main" id="{CC9CDA98-D998-91F5-574C-47F56ABECB36}"/>
+            </a:ext>
+          </a:extLst>
+        </p:cNvPr>
+        <p:cNvGrpSpPr/>
+        <p:nvPr/>
+      </p:nvGrpSpPr>
+      <p:grpSpPr>
+        <a:xfrm>
+          <a:off x="0" y="0"/>
+          <a:ext cx="0" cy="0"/>
+          <a:chOff x="0" y="0"/>
+          <a:chExt cx="0" cy="0"/>
+        </a:xfrm>
+      </p:grpSpPr>
+      <p:sp>
+        <p:nvSpPr>
+          <p:cNvPr id="2" name="Title 1">
+            <a:extLst>
+              <a:ext uri="{FF2B5EF4-FFF2-40B4-BE49-F238E27FC236}">
+                <a16:creationId xmlns:a16="http://schemas.microsoft.com/office/drawing/2014/main" id="{A71A57C0-842D-C71F-F8BD-D1B4C551C078}"/>
+              </a:ext>
+            </a:extLst>
+          </p:cNvPr>
+          <p:cNvSpPr>
+            <a:spLocks noGrp="1"/>
+          </p:cNvSpPr>
+          <p:nvPr>
+            <p:ph type="title"/>
+          </p:nvPr>
+        </p:nvSpPr>
+        <p:spPr/>
+        <p:txBody>
+          <a:bodyPr/>
+          <a:lstStyle/>
+          <a:p>
+            <a:r>
+              <a:rPr lang="en-US" dirty="0"/>
+              <a:t>Login Page Image</a:t>
+            </a:r>
+          </a:p>
+        </p:txBody>
+      </p:sp>
+      <p:sp>
+        <p:nvSpPr>
+          <p:cNvPr id="3" name="Content Placeholder 2">
+            <a:extLst>
+              <a:ext uri="{FF2B5EF4-FFF2-40B4-BE49-F238E27FC236}">
+                <a16:creationId xmlns:a16="http://schemas.microsoft.com/office/drawing/2014/main" id="{798A6EAA-9187-426B-CD4A-A875F433C0DD}"/>
+              </a:ext>
+            </a:extLst>
+          </p:cNvPr>
+          <p:cNvSpPr>
+            <a:spLocks noGrp="1"/>
+          </p:cNvSpPr>
+          <p:nvPr>
+            <p:ph idx="1"/>
+          </p:nvPr>
+        </p:nvSpPr>
+        <p:spPr/>
+        <p:txBody>
+          <a:bodyPr/>
+          <a:lstStyle/>
+          <a:p>
+            <a:r>
+              <a:rPr lang="en-US" dirty="0"/>
+              <a:t>Unmarked:  /docs/studio/assets/user/login-page.jpg</a:t>
+            </a:r>
+          </a:p>
+        </p:txBody>
+      </p:sp>
+    </p:spTree>
+    <p:extLst>
+      <p:ext uri="{BB962C8B-B14F-4D97-AF65-F5344CB8AC3E}">
+        <p14:creationId xmlns:p14="http://schemas.microsoft.com/office/powerpoint/2010/main" val="4126708747"/>
+      </p:ext>
+    </p:extLst>
+  </p:cSld>
+  <p:clrMapOvr>
+    <a:masterClrMapping/>
+  </p:clrMapOvr>
+</p:sld>
+</file>
+
+<file path=ppt/slides/slide4.xml><?xml version="1.0" encoding="utf-8"?>
+<p:sld xmlns:a="http://schemas.openxmlformats.org/drawingml/2006/main" xmlns:r="http://schemas.openxmlformats.org/officeDocument/2006/relationships" xmlns:p="http://schemas.openxmlformats.org/presentationml/2006/main">
+  <p:cSld>
+    <p:spTree>
+      <p:nvGrpSpPr>
+        <p:cNvPr id="1" name=""/>
+        <p:cNvGrpSpPr/>
+        <p:nvPr/>
+      </p:nvGrpSpPr>
+      <p:grpSpPr>
+        <a:xfrm>
+          <a:off x="0" y="0"/>
+          <a:ext cx="0" cy="0"/>
+          <a:chOff x="0" y="0"/>
+          <a:chExt cx="0" cy="0"/>
+        </a:xfrm>
+      </p:grpSpPr>
+      <p:pic>
+        <p:nvPicPr>
+          <p:cNvPr id="5" name="Picture 4">
+            <a:extLst>
+              <a:ext uri="{FF2B5EF4-FFF2-40B4-BE49-F238E27FC236}">
+                <a16:creationId xmlns:a16="http://schemas.microsoft.com/office/drawing/2014/main" id="{EE3CF5A9-3CE0-2AF4-7555-88C5EA31DB16}"/>
+              </a:ext>
+            </a:extLst>
+          </p:cNvPr>
+          <p:cNvPicPr>
+            <a:picLocks noChangeAspect="1"/>
+          </p:cNvPicPr>
+          <p:nvPr/>
+        </p:nvPicPr>
+        <p:blipFill>
+          <a:blip r:embed="rId2"/>
+          <a:srcRect l="8031" t="4167" r="8375" b="5139"/>
+          <a:stretch>
+            <a:fillRect/>
+          </a:stretch>
+        </p:blipFill>
+        <p:spPr>
+          <a:xfrm>
+            <a:off x="3771899" y="285750"/>
+            <a:ext cx="4629151" cy="6219825"/>
+          </a:xfrm>
+          <a:prstGeom prst="rect">
+            <a:avLst/>
+          </a:prstGeom>
+        </p:spPr>
+      </p:pic>
+      <p:pic>
+        <p:nvPicPr>
+          <p:cNvPr id="7" name="Picture 6" descr="A screenshot of a login form&#10;&#10;AI-generated content may be incorrect.">
+            <a:extLst>
+              <a:ext uri="{FF2B5EF4-FFF2-40B4-BE49-F238E27FC236}">
+                <a16:creationId xmlns:a16="http://schemas.microsoft.com/office/drawing/2014/main" id="{A91B77A1-216D-BE63-2E29-DB5B203973D7}"/>
+              </a:ext>
+            </a:extLst>
+          </p:cNvPr>
+          <p:cNvPicPr>
+            <a:picLocks noChangeAspect="1"/>
+          </p:cNvPicPr>
+          <p:nvPr/>
+        </p:nvPicPr>
+        <p:blipFill>
+          <a:blip r:embed="rId3">
+            <a:extLst>
+              <a:ext uri="{28A0092B-C50C-407E-A947-70E740481C1C}">
+                <a14:useLocalDpi xmlns:a14="http://schemas.microsoft.com/office/drawing/2010/main" val="0"/>
+              </a:ext>
+            </a:extLst>
+          </a:blip>
+          <a:stretch>
+            <a:fillRect/>
+          </a:stretch>
+        </p:blipFill>
+        <p:spPr>
+          <a:xfrm>
+            <a:off x="3480735" y="0"/>
+            <a:ext cx="5230530" cy="6858000"/>
+          </a:xfrm>
+          <a:prstGeom prst="rect">
+            <a:avLst/>
+          </a:prstGeom>
+        </p:spPr>
+      </p:pic>
+    </p:spTree>
+    <p:extLst>
+      <p:ext uri="{BB962C8B-B14F-4D97-AF65-F5344CB8AC3E}">
+        <p14:creationId xmlns:p14="http://schemas.microsoft.com/office/powerpoint/2010/main" val="3144287896"/>
+      </p:ext>
+    </p:extLst>
+  </p:cSld>
+  <p:clrMapOvr>
+    <a:masterClrMapping/>
+  </p:clrMapOvr>
+</p:sld>
+</file>
+
+<file path=ppt/slides/slide5.xml><?xml version="1.0" encoding="utf-8"?>
+<p:sld xmlns:a="http://schemas.openxmlformats.org/drawingml/2006/main" xmlns:r="http://schemas.openxmlformats.org/officeDocument/2006/relationships" xmlns:p="http://schemas.openxmlformats.org/presentationml/2006/main">
+  <p:cSld>
+    <p:spTree>
+      <p:nvGrpSpPr>
+        <p:cNvPr id="1" name=""/>
+        <p:cNvGrpSpPr/>
+        <p:nvPr/>
+      </p:nvGrpSpPr>
+      <p:grpSpPr>
+        <a:xfrm>
+          <a:off x="0" y="0"/>
+          <a:ext cx="0" cy="0"/>
+          <a:chOff x="0" y="0"/>
+          <a:chExt cx="0" cy="0"/>
+        </a:xfrm>
+      </p:grpSpPr>
+      <p:sp>
+        <p:nvSpPr>
+          <p:cNvPr id="2" name="Title 1">
+            <a:extLst>
+              <a:ext uri="{FF2B5EF4-FFF2-40B4-BE49-F238E27FC236}">
+                <a16:creationId xmlns:a16="http://schemas.microsoft.com/office/drawing/2014/main" id="{16BDF30B-6797-CA80-5FF9-1A95CBDF6F67}"/>
+              </a:ext>
+            </a:extLst>
+          </p:cNvPr>
+          <p:cNvSpPr>
+            <a:spLocks noGrp="1"/>
+          </p:cNvSpPr>
+          <p:nvPr>
+            <p:ph type="title"/>
+          </p:nvPr>
+        </p:nvSpPr>
+        <p:spPr/>
+        <p:txBody>
+          <a:bodyPr/>
+          <a:lstStyle/>
+          <a:p>
+            <a:r>
+              <a:rPr lang="en-US" dirty="0"/>
+              <a:t>Home Page Image</a:t>
+            </a:r>
+          </a:p>
+        </p:txBody>
+      </p:sp>
+      <p:sp>
+        <p:nvSpPr>
+          <p:cNvPr id="3" name="Content Placeholder 2">
+            <a:extLst>
+              <a:ext uri="{FF2B5EF4-FFF2-40B4-BE49-F238E27FC236}">
+                <a16:creationId xmlns:a16="http://schemas.microsoft.com/office/drawing/2014/main" id="{39B1F5AD-648D-9504-BDB3-13C31619395B}"/>
+              </a:ext>
+            </a:extLst>
+          </p:cNvPr>
+          <p:cNvSpPr>
+            <a:spLocks noGrp="1"/>
+          </p:cNvSpPr>
+          <p:nvPr>
+            <p:ph idx="1"/>
+          </p:nvPr>
+        </p:nvSpPr>
+        <p:spPr/>
+        <p:txBody>
+          <a:bodyPr/>
+          <a:lstStyle/>
+          <a:p>
+            <a:r>
+              <a:rPr lang="en-US" dirty="0"/>
+              <a:t>Unmarked:  /docs/studio/assets/user/home-page.png</a:t>
+            </a:r>
+          </a:p>
+          <a:p>
+            <a:r>
+              <a:rPr lang="en-US" dirty="0"/>
+              <a:t>1005 x 660 pixels</a:t>
+            </a:r>
+          </a:p>
+          <a:p>
+            <a:r>
+              <a:rPr lang="en-US" dirty="0"/>
+              <a:t>3 variants</a:t>
+            </a:r>
+          </a:p>
+        </p:txBody>
+      </p:sp>
+    </p:spTree>
+    <p:extLst>
+      <p:ext uri="{BB962C8B-B14F-4D97-AF65-F5344CB8AC3E}">
+        <p14:creationId xmlns:p14="http://schemas.microsoft.com/office/powerpoint/2010/main" val="732937030"/>
+      </p:ext>
+    </p:extLst>
+  </p:cSld>
+  <p:clrMapOvr>
+    <a:masterClrMapping/>
+  </p:clrMapOvr>
+</p:sld>
+</file>
+
+<file path=ppt/slides/slide6.xml><?xml version="1.0" encoding="utf-8"?>
+<p:sld xmlns:a="http://schemas.openxmlformats.org/drawingml/2006/main" xmlns:r="http://schemas.openxmlformats.org/officeDocument/2006/relationships" xmlns:p="http://schemas.openxmlformats.org/presentationml/2006/main">
+  <p:cSld>
+    <p:spTree>
+      <p:nvGrpSpPr>
+        <p:cNvPr id="1" name=""/>
+        <p:cNvGrpSpPr/>
+        <p:nvPr/>
+      </p:nvGrpSpPr>
+      <p:grpSpPr>
+        <a:xfrm>
+          <a:off x="0" y="0"/>
+          <a:ext cx="0" cy="0"/>
+          <a:chOff x="0" y="0"/>
+          <a:chExt cx="0" cy="0"/>
+        </a:xfrm>
+      </p:grpSpPr>
+      <p:pic>
+        <p:nvPicPr>
+          <p:cNvPr id="3" name="Picture 2">
+            <a:extLst>
+              <a:ext uri="{FF2B5EF4-FFF2-40B4-BE49-F238E27FC236}">
+                <a16:creationId xmlns:a16="http://schemas.microsoft.com/office/drawing/2014/main" id="{AE95041C-0E5F-3A58-656D-CFCFA449933C}"/>
+              </a:ext>
+            </a:extLst>
+          </p:cNvPr>
+          <p:cNvPicPr>
+            <a:picLocks noChangeAspect="1"/>
+          </p:cNvPicPr>
+          <p:nvPr/>
+        </p:nvPicPr>
+        <p:blipFill>
+          <a:blip r:embed="rId3"/>
+          <a:srcRect l="119"/>
+          <a:stretch>
+            <a:fillRect/>
+          </a:stretch>
+        </p:blipFill>
+        <p:spPr>
+          <a:xfrm>
+            <a:off x="1107890" y="0"/>
+            <a:ext cx="9988122" cy="6858000"/>
+          </a:xfrm>
+          <a:prstGeom prst="rect">
+            <a:avLst/>
+          </a:prstGeom>
+        </p:spPr>
+      </p:pic>
+      <p:sp>
+        <p:nvSpPr>
+          <p:cNvPr id="7" name="Rectangle 6">
+            <a:extLst>
+              <a:ext uri="{FF2B5EF4-FFF2-40B4-BE49-F238E27FC236}">
+                <a16:creationId xmlns:a16="http://schemas.microsoft.com/office/drawing/2014/main" id="{7A08FA56-6667-2FEB-DFC0-5795598FD922}"/>
+              </a:ext>
+            </a:extLst>
+          </p:cNvPr>
+          <p:cNvSpPr/>
+          <p:nvPr/>
+        </p:nvSpPr>
+        <p:spPr>
+          <a:xfrm>
+            <a:off x="1095987" y="-9435"/>
+            <a:ext cx="10000023" cy="369332"/>
+          </a:xfrm>
+          <a:prstGeom prst="rect">
+            <a:avLst/>
+          </a:prstGeom>
+          <a:noFill/>
+          <a:ln w="38100">
+            <a:solidFill>
+              <a:srgbClr val="FF0000"/>
+            </a:solidFill>
+          </a:ln>
+        </p:spPr>
+        <p:style>
+          <a:lnRef idx="2">
+            <a:schemeClr val="accent1">
+              <a:shade val="15000"/>
+            </a:schemeClr>
+          </a:lnRef>
+          <a:fillRef idx="1">
+            <a:schemeClr val="accent1"/>
+          </a:fillRef>
+          <a:effectRef idx="0">
+            <a:schemeClr val="accent1"/>
+          </a:effectRef>
+          <a:fontRef idx="minor">
+            <a:schemeClr val="lt1"/>
+          </a:fontRef>
+        </p:style>
+        <p:txBody>
+          <a:bodyPr rtlCol="0" anchor="ctr"/>
+          <a:lstStyle/>
+          <a:p>
+            <a:pPr algn="ctr"/>
+            <a:endParaRPr lang="en-US">
+              <a:ln w="0"/>
+              <a:solidFill>
+                <a:schemeClr val="tx1"/>
+              </a:solidFill>
+              <a:effectLst>
+                <a:outerShdw blurRad="38100" dist="19050" dir="2700000" algn="tl" rotWithShape="0">
+                  <a:schemeClr val="dk1">
+                    <a:alpha val="40000"/>
+                  </a:schemeClr>
+                </a:outerShdw>
+              </a:effectLst>
+            </a:endParaRPr>
+          </a:p>
+        </p:txBody>
+      </p:sp>
+      <p:sp>
+        <p:nvSpPr>
+          <p:cNvPr id="8" name="TextBox 7">
+            <a:extLst>
+              <a:ext uri="{FF2B5EF4-FFF2-40B4-BE49-F238E27FC236}">
+                <a16:creationId xmlns:a16="http://schemas.microsoft.com/office/drawing/2014/main" id="{9B1E6C77-DB95-5CB9-F5BE-10B04E4B3331}"/>
+              </a:ext>
+            </a:extLst>
+          </p:cNvPr>
+          <p:cNvSpPr txBox="1"/>
+          <p:nvPr/>
+        </p:nvSpPr>
+        <p:spPr>
+          <a:xfrm>
+            <a:off x="799792" y="16586"/>
+            <a:ext cx="308098" cy="369332"/>
+          </a:xfrm>
+          <a:prstGeom prst="rect">
+            <a:avLst/>
+          </a:prstGeom>
+          <a:noFill/>
+        </p:spPr>
+        <p:txBody>
+          <a:bodyPr wrap="none" rtlCol="0">
+            <a:spAutoFit/>
+          </a:bodyPr>
+          <a:lstStyle/>
+          <a:p>
+            <a:r>
+              <a:rPr lang="en-US" dirty="0">
+                <a:solidFill>
+                  <a:srgbClr val="FF0000"/>
+                </a:solidFill>
+              </a:rPr>
+              <a:t>1</a:t>
+            </a:r>
+          </a:p>
+        </p:txBody>
+      </p:sp>
+      <p:sp>
+        <p:nvSpPr>
+          <p:cNvPr id="9" name="Rectangle 8">
+            <a:extLst>
+              <a:ext uri="{FF2B5EF4-FFF2-40B4-BE49-F238E27FC236}">
+                <a16:creationId xmlns:a16="http://schemas.microsoft.com/office/drawing/2014/main" id="{6D48391C-EA04-C850-11E2-9DD29AEEAAE8}"/>
+              </a:ext>
+            </a:extLst>
+          </p:cNvPr>
+          <p:cNvSpPr/>
+          <p:nvPr/>
+        </p:nvSpPr>
+        <p:spPr>
+          <a:xfrm>
+            <a:off x="4119856" y="-54543"/>
+            <a:ext cx="1743615" cy="535310"/>
+          </a:xfrm>
+          <a:prstGeom prst="rect">
+            <a:avLst/>
+          </a:prstGeom>
+          <a:noFill/>
+          <a:ln w="38100">
+            <a:solidFill>
+              <a:srgbClr val="FF0000"/>
+            </a:solidFill>
+          </a:ln>
+        </p:spPr>
+        <p:style>
+          <a:lnRef idx="2">
+            <a:schemeClr val="accent1">
+              <a:shade val="15000"/>
+            </a:schemeClr>
+          </a:lnRef>
+          <a:fillRef idx="1">
+            <a:schemeClr val="accent1"/>
+          </a:fillRef>
+          <a:effectRef idx="0">
+            <a:schemeClr val="accent1"/>
+          </a:effectRef>
+          <a:fontRef idx="minor">
+            <a:schemeClr val="lt1"/>
+          </a:fontRef>
+        </p:style>
+        <p:txBody>
+          <a:bodyPr rtlCol="0" anchor="ctr"/>
+          <a:lstStyle/>
+          <a:p>
+            <a:pPr algn="ctr"/>
+            <a:endParaRPr lang="en-US">
+              <a:ln w="0"/>
+              <a:solidFill>
+                <a:schemeClr val="tx1"/>
+              </a:solidFill>
+              <a:effectLst>
+                <a:outerShdw blurRad="38100" dist="19050" dir="2700000" algn="tl" rotWithShape="0">
+                  <a:schemeClr val="dk1">
+                    <a:alpha val="40000"/>
+                  </a:schemeClr>
+                </a:outerShdw>
+              </a:effectLst>
+            </a:endParaRPr>
+          </a:p>
+        </p:txBody>
+      </p:sp>
+      <p:sp>
+        <p:nvSpPr>
+          <p:cNvPr id="10" name="TextBox 9">
+            <a:extLst>
+              <a:ext uri="{FF2B5EF4-FFF2-40B4-BE49-F238E27FC236}">
+                <a16:creationId xmlns:a16="http://schemas.microsoft.com/office/drawing/2014/main" id="{79E39D9C-5B4D-15B1-CE5E-940082C00152}"/>
+              </a:ext>
+            </a:extLst>
+          </p:cNvPr>
+          <p:cNvSpPr txBox="1"/>
+          <p:nvPr/>
+        </p:nvSpPr>
+        <p:spPr>
+          <a:xfrm>
+            <a:off x="3811759" y="-9435"/>
+            <a:ext cx="308098" cy="369332"/>
+          </a:xfrm>
+          <a:prstGeom prst="rect">
+            <a:avLst/>
+          </a:prstGeom>
+          <a:noFill/>
+        </p:spPr>
+        <p:txBody>
+          <a:bodyPr wrap="none" rtlCol="0">
+            <a:spAutoFit/>
+          </a:bodyPr>
+          <a:lstStyle/>
+          <a:p>
+            <a:r>
+              <a:rPr lang="en-US" dirty="0">
+                <a:solidFill>
+                  <a:srgbClr val="FF0000"/>
+                </a:solidFill>
+              </a:rPr>
+              <a:t>2</a:t>
+            </a:r>
+          </a:p>
+        </p:txBody>
+      </p:sp>
+      <p:sp>
+        <p:nvSpPr>
+          <p:cNvPr id="11" name="Rectangle 10">
+            <a:extLst>
+              <a:ext uri="{FF2B5EF4-FFF2-40B4-BE49-F238E27FC236}">
+                <a16:creationId xmlns:a16="http://schemas.microsoft.com/office/drawing/2014/main" id="{2833DB43-D41E-B980-2962-A29C8DC3C52A}"/>
+              </a:ext>
+            </a:extLst>
+          </p:cNvPr>
+          <p:cNvSpPr/>
+          <p:nvPr/>
+        </p:nvSpPr>
+        <p:spPr>
+          <a:xfrm>
+            <a:off x="1381869" y="590143"/>
+            <a:ext cx="5292308" cy="805023"/>
+          </a:xfrm>
+          <a:prstGeom prst="rect">
+            <a:avLst/>
+          </a:prstGeom>
+          <a:noFill/>
+          <a:ln w="38100">
+            <a:solidFill>
+              <a:srgbClr val="FF0000"/>
+            </a:solidFill>
+          </a:ln>
+        </p:spPr>
+        <p:style>
+          <a:lnRef idx="2">
+            <a:schemeClr val="accent1">
+              <a:shade val="15000"/>
+            </a:schemeClr>
+          </a:lnRef>
+          <a:fillRef idx="1">
+            <a:schemeClr val="accent1"/>
+          </a:fillRef>
+          <a:effectRef idx="0">
+            <a:schemeClr val="accent1"/>
+          </a:effectRef>
+          <a:fontRef idx="minor">
+            <a:schemeClr val="lt1"/>
+          </a:fontRef>
+        </p:style>
+        <p:txBody>
+          <a:bodyPr rtlCol="0" anchor="ctr"/>
+          <a:lstStyle/>
+          <a:p>
+            <a:pPr algn="ctr"/>
+            <a:endParaRPr lang="en-US">
+              <a:ln w="0"/>
+              <a:solidFill>
+                <a:schemeClr val="tx1"/>
+              </a:solidFill>
+              <a:effectLst>
+                <a:outerShdw blurRad="38100" dist="19050" dir="2700000" algn="tl" rotWithShape="0">
+                  <a:schemeClr val="dk1">
+                    <a:alpha val="40000"/>
+                  </a:schemeClr>
+                </a:outerShdw>
+              </a:effectLst>
+            </a:endParaRPr>
+          </a:p>
+        </p:txBody>
+      </p:sp>
+      <p:sp>
+        <p:nvSpPr>
+          <p:cNvPr id="12" name="TextBox 11">
+            <a:extLst>
+              <a:ext uri="{FF2B5EF4-FFF2-40B4-BE49-F238E27FC236}">
+                <a16:creationId xmlns:a16="http://schemas.microsoft.com/office/drawing/2014/main" id="{FC04C220-DD23-CC83-B1D2-AB1922EBBA7F}"/>
+              </a:ext>
+            </a:extLst>
+          </p:cNvPr>
+          <p:cNvSpPr txBox="1"/>
+          <p:nvPr/>
+        </p:nvSpPr>
+        <p:spPr>
+          <a:xfrm>
+            <a:off x="799792" y="702462"/>
+            <a:ext cx="308098" cy="369332"/>
+          </a:xfrm>
+          <a:prstGeom prst="rect">
+            <a:avLst/>
+          </a:prstGeom>
+          <a:noFill/>
+        </p:spPr>
+        <p:txBody>
+          <a:bodyPr wrap="none" rtlCol="0">
+            <a:spAutoFit/>
+          </a:bodyPr>
+          <a:lstStyle/>
+          <a:p>
+            <a:r>
+              <a:rPr lang="en-US" dirty="0">
+                <a:solidFill>
+                  <a:srgbClr val="FF0000"/>
+                </a:solidFill>
+              </a:rPr>
+              <a:t>3</a:t>
+            </a:r>
+          </a:p>
+        </p:txBody>
+      </p:sp>
+      <p:sp>
+        <p:nvSpPr>
+          <p:cNvPr id="13" name="Rectangle 12">
+            <a:extLst>
+              <a:ext uri="{FF2B5EF4-FFF2-40B4-BE49-F238E27FC236}">
+                <a16:creationId xmlns:a16="http://schemas.microsoft.com/office/drawing/2014/main" id="{C108EFD0-0B82-6469-1709-FA5655D787C6}"/>
+              </a:ext>
+            </a:extLst>
+          </p:cNvPr>
+          <p:cNvSpPr/>
+          <p:nvPr/>
+        </p:nvSpPr>
+        <p:spPr>
+          <a:xfrm>
+            <a:off x="1399439" y="1489212"/>
+            <a:ext cx="5274738" cy="4987002"/>
+          </a:xfrm>
+          <a:prstGeom prst="rect">
+            <a:avLst/>
+          </a:prstGeom>
+          <a:noFill/>
+          <a:ln w="38100">
+            <a:solidFill>
+              <a:srgbClr val="FF0000"/>
+            </a:solidFill>
+          </a:ln>
+        </p:spPr>
+        <p:style>
+          <a:lnRef idx="2">
+            <a:schemeClr val="accent1">
+              <a:shade val="15000"/>
+            </a:schemeClr>
+          </a:lnRef>
+          <a:fillRef idx="1">
+            <a:schemeClr val="accent1"/>
+          </a:fillRef>
+          <a:effectRef idx="0">
+            <a:schemeClr val="accent1"/>
+          </a:effectRef>
+          <a:fontRef idx="minor">
+            <a:schemeClr val="lt1"/>
+          </a:fontRef>
+        </p:style>
+        <p:txBody>
+          <a:bodyPr rtlCol="0" anchor="ctr"/>
+          <a:lstStyle/>
+          <a:p>
+            <a:pPr algn="ctr"/>
+            <a:endParaRPr lang="en-US">
+              <a:ln w="0"/>
+              <a:solidFill>
+                <a:schemeClr val="tx1"/>
+              </a:solidFill>
+              <a:effectLst>
+                <a:outerShdw blurRad="38100" dist="19050" dir="2700000" algn="tl" rotWithShape="0">
+                  <a:schemeClr val="dk1">
+                    <a:alpha val="40000"/>
+                  </a:schemeClr>
+                </a:outerShdw>
+              </a:effectLst>
+            </a:endParaRPr>
+          </a:p>
+        </p:txBody>
+      </p:sp>
+      <p:sp>
+        <p:nvSpPr>
+          <p:cNvPr id="14" name="TextBox 13">
+            <a:extLst>
+              <a:ext uri="{FF2B5EF4-FFF2-40B4-BE49-F238E27FC236}">
+                <a16:creationId xmlns:a16="http://schemas.microsoft.com/office/drawing/2014/main" id="{A846B7CF-E7D2-BC5C-2705-E663D974A7E2}"/>
+              </a:ext>
+            </a:extLst>
+          </p:cNvPr>
+          <p:cNvSpPr txBox="1"/>
+          <p:nvPr/>
+        </p:nvSpPr>
+        <p:spPr>
+          <a:xfrm>
+            <a:off x="793841" y="1489212"/>
+            <a:ext cx="308098" cy="369332"/>
+          </a:xfrm>
+          <a:prstGeom prst="rect">
+            <a:avLst/>
+          </a:prstGeom>
+          <a:noFill/>
+        </p:spPr>
+        <p:txBody>
+          <a:bodyPr wrap="none" rtlCol="0">
+            <a:spAutoFit/>
+          </a:bodyPr>
+          <a:lstStyle/>
+          <a:p>
+            <a:r>
+              <a:rPr lang="en-US" dirty="0">
+                <a:solidFill>
+                  <a:srgbClr val="FF0000"/>
+                </a:solidFill>
+              </a:rPr>
+              <a:t>4</a:t>
+            </a:r>
+          </a:p>
+        </p:txBody>
+      </p:sp>
+      <p:sp>
+        <p:nvSpPr>
+          <p:cNvPr id="15" name="Rectangle 14">
+            <a:extLst>
+              <a:ext uri="{FF2B5EF4-FFF2-40B4-BE49-F238E27FC236}">
+                <a16:creationId xmlns:a16="http://schemas.microsoft.com/office/drawing/2014/main" id="{12D14BB5-5053-B952-61E5-BD8A6FC3A4AD}"/>
+              </a:ext>
+            </a:extLst>
+          </p:cNvPr>
+          <p:cNvSpPr/>
+          <p:nvPr/>
+        </p:nvSpPr>
+        <p:spPr>
+          <a:xfrm>
+            <a:off x="6835250" y="590143"/>
+            <a:ext cx="4019302" cy="1391044"/>
+          </a:xfrm>
+          <a:prstGeom prst="rect">
+            <a:avLst/>
+          </a:prstGeom>
+          <a:noFill/>
+          <a:ln w="38100">
+            <a:solidFill>
+              <a:srgbClr val="FF0000"/>
+            </a:solidFill>
+          </a:ln>
+        </p:spPr>
+        <p:style>
+          <a:lnRef idx="2">
+            <a:schemeClr val="accent1">
+              <a:shade val="15000"/>
+            </a:schemeClr>
+          </a:lnRef>
+          <a:fillRef idx="1">
+            <a:schemeClr val="accent1"/>
+          </a:fillRef>
+          <a:effectRef idx="0">
+            <a:schemeClr val="accent1"/>
+          </a:effectRef>
+          <a:fontRef idx="minor">
+            <a:schemeClr val="lt1"/>
+          </a:fontRef>
+        </p:style>
+        <p:txBody>
+          <a:bodyPr rtlCol="0" anchor="ctr"/>
+          <a:lstStyle/>
+          <a:p>
+            <a:pPr algn="ctr"/>
+            <a:endParaRPr lang="en-US">
+              <a:ln w="0"/>
+              <a:solidFill>
+                <a:schemeClr val="tx1"/>
+              </a:solidFill>
+              <a:effectLst>
+                <a:outerShdw blurRad="38100" dist="19050" dir="2700000" algn="tl" rotWithShape="0">
+                  <a:schemeClr val="dk1">
+                    <a:alpha val="40000"/>
+                  </a:schemeClr>
+                </a:outerShdw>
+              </a:effectLst>
+            </a:endParaRPr>
+          </a:p>
+        </p:txBody>
+      </p:sp>
+      <p:sp>
+        <p:nvSpPr>
+          <p:cNvPr id="16" name="TextBox 15">
+            <a:extLst>
+              <a:ext uri="{FF2B5EF4-FFF2-40B4-BE49-F238E27FC236}">
+                <a16:creationId xmlns:a16="http://schemas.microsoft.com/office/drawing/2014/main" id="{98610F23-443B-34BB-F719-A7433A6FF245}"/>
+              </a:ext>
+            </a:extLst>
+          </p:cNvPr>
+          <p:cNvSpPr txBox="1"/>
+          <p:nvPr/>
+        </p:nvSpPr>
+        <p:spPr>
+          <a:xfrm>
+            <a:off x="10787912" y="480767"/>
+            <a:ext cx="308098" cy="369332"/>
+          </a:xfrm>
+          <a:prstGeom prst="rect">
+            <a:avLst/>
+          </a:prstGeom>
+          <a:noFill/>
+        </p:spPr>
+        <p:txBody>
+          <a:bodyPr wrap="none" rtlCol="0">
+            <a:spAutoFit/>
+          </a:bodyPr>
+          <a:lstStyle/>
+          <a:p>
+            <a:r>
+              <a:rPr lang="en-US" dirty="0">
+                <a:solidFill>
+                  <a:srgbClr val="FF0000"/>
+                </a:solidFill>
+              </a:rPr>
+              <a:t>5</a:t>
+            </a:r>
+          </a:p>
+        </p:txBody>
+      </p:sp>
+      <p:sp>
+        <p:nvSpPr>
+          <p:cNvPr id="17" name="Rectangle 16">
+            <a:extLst>
+              <a:ext uri="{FF2B5EF4-FFF2-40B4-BE49-F238E27FC236}">
+                <a16:creationId xmlns:a16="http://schemas.microsoft.com/office/drawing/2014/main" id="{5710D559-00D9-D4B5-840E-0929DD1D3752}"/>
+              </a:ext>
+            </a:extLst>
+          </p:cNvPr>
+          <p:cNvSpPr/>
+          <p:nvPr/>
+        </p:nvSpPr>
+        <p:spPr>
+          <a:xfrm>
+            <a:off x="6835250" y="2044924"/>
+            <a:ext cx="4019302" cy="4813076"/>
+          </a:xfrm>
+          <a:prstGeom prst="rect">
+            <a:avLst/>
+          </a:prstGeom>
+          <a:noFill/>
+          <a:ln w="38100">
+            <a:solidFill>
+              <a:srgbClr val="FF0000"/>
+            </a:solidFill>
+          </a:ln>
+        </p:spPr>
+        <p:style>
+          <a:lnRef idx="2">
+            <a:schemeClr val="accent1">
+              <a:shade val="15000"/>
+            </a:schemeClr>
+          </a:lnRef>
+          <a:fillRef idx="1">
+            <a:schemeClr val="accent1"/>
+          </a:fillRef>
+          <a:effectRef idx="0">
+            <a:schemeClr val="accent1"/>
+          </a:effectRef>
+          <a:fontRef idx="minor">
+            <a:schemeClr val="lt1"/>
+          </a:fontRef>
+        </p:style>
+        <p:txBody>
+          <a:bodyPr rtlCol="0" anchor="ctr"/>
+          <a:lstStyle/>
+          <a:p>
+            <a:pPr algn="ctr"/>
+            <a:endParaRPr lang="en-US">
+              <a:ln w="0"/>
+              <a:solidFill>
+                <a:schemeClr val="tx1"/>
+              </a:solidFill>
+              <a:effectLst>
+                <a:outerShdw blurRad="38100" dist="19050" dir="2700000" algn="tl" rotWithShape="0">
+                  <a:schemeClr val="dk1">
+                    <a:alpha val="40000"/>
+                  </a:schemeClr>
+                </a:outerShdw>
+              </a:effectLst>
+            </a:endParaRPr>
+          </a:p>
+        </p:txBody>
+      </p:sp>
+      <p:sp>
+        <p:nvSpPr>
+          <p:cNvPr id="18" name="TextBox 17">
+            <a:extLst>
+              <a:ext uri="{FF2B5EF4-FFF2-40B4-BE49-F238E27FC236}">
+                <a16:creationId xmlns:a16="http://schemas.microsoft.com/office/drawing/2014/main" id="{DDAEC382-88AF-0048-E5CD-7007074237EA}"/>
+              </a:ext>
+            </a:extLst>
+          </p:cNvPr>
+          <p:cNvSpPr txBox="1"/>
+          <p:nvPr/>
+        </p:nvSpPr>
+        <p:spPr>
+          <a:xfrm>
+            <a:off x="10787912" y="1990622"/>
+            <a:ext cx="308098" cy="369332"/>
+          </a:xfrm>
+          <a:prstGeom prst="rect">
+            <a:avLst/>
+          </a:prstGeom>
+          <a:noFill/>
+        </p:spPr>
+        <p:txBody>
+          <a:bodyPr wrap="none" rtlCol="0">
+            <a:spAutoFit/>
+          </a:bodyPr>
+          <a:lstStyle/>
+          <a:p>
+            <a:r>
+              <a:rPr lang="en-US" dirty="0">
+                <a:solidFill>
+                  <a:srgbClr val="FF0000"/>
+                </a:solidFill>
+              </a:rPr>
+              <a:t>6</a:t>
+            </a:r>
+          </a:p>
+        </p:txBody>
+      </p:sp>
+    </p:spTree>
+    <p:extLst>
+      <p:ext uri="{BB962C8B-B14F-4D97-AF65-F5344CB8AC3E}">
+        <p14:creationId xmlns:p14="http://schemas.microsoft.com/office/powerpoint/2010/main" val="2030273751"/>
+      </p:ext>
+    </p:extLst>
+  </p:cSld>
+  <p:clrMapOvr>
+    <a:masterClrMapping/>
+  </p:clrMapOvr>
+</p:sld>
+</file>
+
+<file path=ppt/slides/slide7.xml><?xml version="1.0" encoding="utf-8"?>
+<p:sld xmlns:a="http://schemas.openxmlformats.org/drawingml/2006/main" xmlns:r="http://schemas.openxmlformats.org/officeDocument/2006/relationships" xmlns:p="http://schemas.openxmlformats.org/presentationml/2006/main">
+  <p:cSld>
+    <p:spTree>
+      <p:nvGrpSpPr>
+        <p:cNvPr id="1" name="">
+          <a:extLst>
+            <a:ext uri="{FF2B5EF4-FFF2-40B4-BE49-F238E27FC236}">
+              <a16:creationId xmlns:a16="http://schemas.microsoft.com/office/drawing/2014/main" id="{1C7C15F3-1C36-3169-7045-1C0AB65E9E14}"/>
+            </a:ext>
+          </a:extLst>
+        </p:cNvPr>
+        <p:cNvGrpSpPr/>
+        <p:nvPr/>
+      </p:nvGrpSpPr>
+      <p:grpSpPr>
+        <a:xfrm>
+          <a:off x="0" y="0"/>
+          <a:ext cx="0" cy="0"/>
+          <a:chOff x="0" y="0"/>
+          <a:chExt cx="0" cy="0"/>
+        </a:xfrm>
+      </p:grpSpPr>
+      <p:pic>
+        <p:nvPicPr>
+          <p:cNvPr id="2" name="Picture 1">
+            <a:extLst>
+              <a:ext uri="{FF2B5EF4-FFF2-40B4-BE49-F238E27FC236}">
+                <a16:creationId xmlns:a16="http://schemas.microsoft.com/office/drawing/2014/main" id="{D8FB3FAB-8491-3B12-8040-9BE2007B40A2}"/>
+              </a:ext>
+            </a:extLst>
+          </p:cNvPr>
+          <p:cNvPicPr>
+            <a:picLocks noChangeAspect="1"/>
+          </p:cNvPicPr>
+          <p:nvPr/>
+        </p:nvPicPr>
+        <p:blipFill>
+          <a:blip r:embed="rId3"/>
+          <a:srcRect l="119"/>
+          <a:stretch>
+            <a:fillRect/>
+          </a:stretch>
+        </p:blipFill>
+        <p:spPr>
+          <a:xfrm>
+            <a:off x="1107890" y="0"/>
+            <a:ext cx="9988122" cy="6858000"/>
+          </a:xfrm>
+          <a:prstGeom prst="rect">
+            <a:avLst/>
+          </a:prstGeom>
+        </p:spPr>
+      </p:pic>
+      <p:sp>
+        <p:nvSpPr>
+          <p:cNvPr id="9" name="Rectangle 8">
+            <a:extLst>
+              <a:ext uri="{FF2B5EF4-FFF2-40B4-BE49-F238E27FC236}">
+                <a16:creationId xmlns:a16="http://schemas.microsoft.com/office/drawing/2014/main" id="{0ACD48EA-BFF4-77F4-FA55-A99720CB1B88}"/>
+              </a:ext>
+            </a:extLst>
+          </p:cNvPr>
+          <p:cNvSpPr/>
+          <p:nvPr/>
+        </p:nvSpPr>
+        <p:spPr>
+          <a:xfrm>
+            <a:off x="4126258" y="1"/>
+            <a:ext cx="1737214" cy="395926"/>
+          </a:xfrm>
+          <a:prstGeom prst="rect">
+            <a:avLst/>
+          </a:prstGeom>
+          <a:noFill/>
+          <a:ln w="38100">
+            <a:solidFill>
+              <a:srgbClr val="FF0000"/>
+            </a:solidFill>
+          </a:ln>
+        </p:spPr>
+        <p:style>
+          <a:lnRef idx="2">
+            <a:schemeClr val="accent1">
+              <a:shade val="15000"/>
+            </a:schemeClr>
+          </a:lnRef>
+          <a:fillRef idx="1">
+            <a:schemeClr val="accent1"/>
+          </a:fillRef>
+          <a:effectRef idx="0">
+            <a:schemeClr val="accent1"/>
+          </a:effectRef>
+          <a:fontRef idx="minor">
+            <a:schemeClr val="lt1"/>
+          </a:fontRef>
+        </p:style>
+        <p:txBody>
+          <a:bodyPr rtlCol="0" anchor="ctr"/>
+          <a:lstStyle/>
+          <a:p>
+            <a:pPr algn="ctr"/>
+            <a:endParaRPr lang="en-US">
+              <a:ln w="0"/>
+              <a:solidFill>
+                <a:schemeClr val="tx1"/>
+              </a:solidFill>
+              <a:effectLst>
+                <a:outerShdw blurRad="38100" dist="19050" dir="2700000" algn="tl" rotWithShape="0">
+                  <a:schemeClr val="dk1">
+                    <a:alpha val="40000"/>
+                  </a:schemeClr>
+                </a:outerShdw>
+              </a:effectLst>
+            </a:endParaRPr>
+          </a:p>
+        </p:txBody>
+      </p:sp>
+    </p:spTree>
+    <p:extLst>
+      <p:ext uri="{BB962C8B-B14F-4D97-AF65-F5344CB8AC3E}">
+        <p14:creationId xmlns:p14="http://schemas.microsoft.com/office/powerpoint/2010/main" val="2427920272"/>
+      </p:ext>
+    </p:extLst>
+  </p:cSld>
+  <p:clrMapOvr>
+    <a:masterClrMapping/>
+  </p:clrMapOvr>
+</p:sld>
+</file>
+
+<file path=ppt/slides/slide8.xml><?xml version="1.0" encoding="utf-8"?>
+<p:sld xmlns:a="http://schemas.openxmlformats.org/drawingml/2006/main" xmlns:r="http://schemas.openxmlformats.org/officeDocument/2006/relationships" xmlns:p="http://schemas.openxmlformats.org/presentationml/2006/main">
+  <p:cSld>
+    <p:spTree>
+      <p:nvGrpSpPr>
+        <p:cNvPr id="1" name="">
+          <a:extLst>
+            <a:ext uri="{FF2B5EF4-FFF2-40B4-BE49-F238E27FC236}">
+              <a16:creationId xmlns:a16="http://schemas.microsoft.com/office/drawing/2014/main" id="{4699E48C-9048-EDE2-981B-D5B27D232C60}"/>
+            </a:ext>
+          </a:extLst>
+        </p:cNvPr>
+        <p:cNvGrpSpPr/>
+        <p:nvPr/>
+      </p:nvGrpSpPr>
+      <p:grpSpPr>
+        <a:xfrm>
+          <a:off x="0" y="0"/>
+          <a:ext cx="0" cy="0"/>
+          <a:chOff x="0" y="0"/>
+          <a:chExt cx="0" cy="0"/>
+        </a:xfrm>
+      </p:grpSpPr>
+      <p:pic>
+        <p:nvPicPr>
+          <p:cNvPr id="21" name="Picture 20">
+            <a:extLst>
+              <a:ext uri="{FF2B5EF4-FFF2-40B4-BE49-F238E27FC236}">
+                <a16:creationId xmlns:a16="http://schemas.microsoft.com/office/drawing/2014/main" id="{55CE22A6-1A7D-F349-98C5-C377173000C9}"/>
+              </a:ext>
+            </a:extLst>
+          </p:cNvPr>
+          <p:cNvPicPr>
+            <a:picLocks noChangeAspect="1"/>
+          </p:cNvPicPr>
+          <p:nvPr/>
+        </p:nvPicPr>
+        <p:blipFill>
+          <a:blip r:embed="rId3"/>
+          <a:srcRect l="119" b="94615"/>
+          <a:stretch>
+            <a:fillRect/>
+          </a:stretch>
+        </p:blipFill>
+        <p:spPr>
+          <a:xfrm>
+            <a:off x="1107890" y="0"/>
+            <a:ext cx="9988122" cy="369332"/>
+          </a:xfrm>
+          <a:prstGeom prst="rect">
+            <a:avLst/>
+          </a:prstGeom>
+        </p:spPr>
+      </p:pic>
+      <p:sp>
+        <p:nvSpPr>
+          <p:cNvPr id="8" name="TextBox 7">
+            <a:extLst>
+              <a:ext uri="{FF2B5EF4-FFF2-40B4-BE49-F238E27FC236}">
+                <a16:creationId xmlns:a16="http://schemas.microsoft.com/office/drawing/2014/main" id="{1E107447-00AF-0794-5BDB-B5C886C40847}"/>
+              </a:ext>
+            </a:extLst>
+          </p:cNvPr>
+          <p:cNvSpPr txBox="1"/>
+          <p:nvPr/>
+        </p:nvSpPr>
+        <p:spPr>
+          <a:xfrm>
+            <a:off x="1134419" y="369332"/>
+            <a:ext cx="308098" cy="369332"/>
+          </a:xfrm>
+          <a:prstGeom prst="rect">
+            <a:avLst/>
+          </a:prstGeom>
+          <a:noFill/>
+        </p:spPr>
+        <p:txBody>
+          <a:bodyPr wrap="none" rtlCol="0">
+            <a:spAutoFit/>
+          </a:bodyPr>
+          <a:lstStyle/>
+          <a:p>
+            <a:r>
+              <a:rPr lang="en-US" dirty="0">
+                <a:solidFill>
+                  <a:srgbClr val="FF0000"/>
+                </a:solidFill>
+              </a:rPr>
+              <a:t>1</a:t>
+            </a:r>
+          </a:p>
+        </p:txBody>
+      </p:sp>
+      <p:sp>
+        <p:nvSpPr>
+          <p:cNvPr id="10" name="TextBox 9">
+            <a:extLst>
+              <a:ext uri="{FF2B5EF4-FFF2-40B4-BE49-F238E27FC236}">
+                <a16:creationId xmlns:a16="http://schemas.microsoft.com/office/drawing/2014/main" id="{167DA61D-8CB4-5D76-7A06-103433A298DE}"/>
+              </a:ext>
+            </a:extLst>
+          </p:cNvPr>
+          <p:cNvSpPr txBox="1"/>
+          <p:nvPr/>
+        </p:nvSpPr>
+        <p:spPr>
+          <a:xfrm>
+            <a:off x="1888884" y="369332"/>
+            <a:ext cx="308098" cy="369332"/>
+          </a:xfrm>
+          <a:prstGeom prst="rect">
+            <a:avLst/>
+          </a:prstGeom>
+          <a:noFill/>
+        </p:spPr>
+        <p:txBody>
+          <a:bodyPr wrap="none" rtlCol="0">
+            <a:spAutoFit/>
+          </a:bodyPr>
+          <a:lstStyle/>
+          <a:p>
+            <a:r>
+              <a:rPr lang="en-US" dirty="0">
+                <a:solidFill>
+                  <a:srgbClr val="FF0000"/>
+                </a:solidFill>
+              </a:rPr>
+              <a:t>2</a:t>
+            </a:r>
+          </a:p>
+        </p:txBody>
+      </p:sp>
+      <p:sp>
+        <p:nvSpPr>
+          <p:cNvPr id="12" name="TextBox 11">
+            <a:extLst>
+              <a:ext uri="{FF2B5EF4-FFF2-40B4-BE49-F238E27FC236}">
+                <a16:creationId xmlns:a16="http://schemas.microsoft.com/office/drawing/2014/main" id="{60A86629-EEE5-FC0A-0F80-BB58BCCCBBAC}"/>
+              </a:ext>
+            </a:extLst>
+          </p:cNvPr>
+          <p:cNvSpPr txBox="1"/>
+          <p:nvPr/>
+        </p:nvSpPr>
+        <p:spPr>
+          <a:xfrm>
+            <a:off x="4024320" y="355334"/>
+            <a:ext cx="308098" cy="369332"/>
+          </a:xfrm>
+          <a:prstGeom prst="rect">
+            <a:avLst/>
+          </a:prstGeom>
+          <a:noFill/>
+        </p:spPr>
+        <p:txBody>
+          <a:bodyPr wrap="none" rtlCol="0">
+            <a:spAutoFit/>
+          </a:bodyPr>
+          <a:lstStyle/>
+          <a:p>
+            <a:r>
+              <a:rPr lang="en-US" dirty="0">
+                <a:solidFill>
+                  <a:srgbClr val="FF0000"/>
+                </a:solidFill>
+              </a:rPr>
+              <a:t>3</a:t>
+            </a:r>
+          </a:p>
+        </p:txBody>
+      </p:sp>
+      <p:sp>
+        <p:nvSpPr>
+          <p:cNvPr id="14" name="TextBox 13">
+            <a:extLst>
+              <a:ext uri="{FF2B5EF4-FFF2-40B4-BE49-F238E27FC236}">
+                <a16:creationId xmlns:a16="http://schemas.microsoft.com/office/drawing/2014/main" id="{AF8F806A-6581-ADA4-02E1-7E8FF39629F0}"/>
+              </a:ext>
+            </a:extLst>
+          </p:cNvPr>
+          <p:cNvSpPr txBox="1"/>
+          <p:nvPr/>
+        </p:nvSpPr>
+        <p:spPr>
+          <a:xfrm>
+            <a:off x="7579047" y="355334"/>
+            <a:ext cx="308098" cy="369332"/>
+          </a:xfrm>
+          <a:prstGeom prst="rect">
+            <a:avLst/>
+          </a:prstGeom>
+          <a:noFill/>
+        </p:spPr>
+        <p:txBody>
+          <a:bodyPr wrap="none" rtlCol="0">
+            <a:spAutoFit/>
+          </a:bodyPr>
+          <a:lstStyle/>
+          <a:p>
+            <a:r>
+              <a:rPr lang="en-US" dirty="0">
+                <a:solidFill>
+                  <a:srgbClr val="FF0000"/>
+                </a:solidFill>
+              </a:rPr>
+              <a:t>4</a:t>
+            </a:r>
+          </a:p>
+        </p:txBody>
+      </p:sp>
+      <p:sp>
+        <p:nvSpPr>
+          <p:cNvPr id="16" name="TextBox 15">
+            <a:extLst>
+              <a:ext uri="{FF2B5EF4-FFF2-40B4-BE49-F238E27FC236}">
+                <a16:creationId xmlns:a16="http://schemas.microsoft.com/office/drawing/2014/main" id="{BE2F7F57-2BC2-C81B-B04C-65FF5E1E8AEF}"/>
+              </a:ext>
+            </a:extLst>
+          </p:cNvPr>
+          <p:cNvSpPr txBox="1"/>
+          <p:nvPr/>
+        </p:nvSpPr>
+        <p:spPr>
+          <a:xfrm>
+            <a:off x="9213579" y="355334"/>
+            <a:ext cx="308098" cy="369332"/>
+          </a:xfrm>
+          <a:prstGeom prst="rect">
+            <a:avLst/>
+          </a:prstGeom>
+          <a:noFill/>
+        </p:spPr>
+        <p:txBody>
+          <a:bodyPr wrap="none" rtlCol="0">
+            <a:spAutoFit/>
+          </a:bodyPr>
+          <a:lstStyle/>
+          <a:p>
+            <a:r>
+              <a:rPr lang="en-US" dirty="0">
+                <a:solidFill>
+                  <a:srgbClr val="FF0000"/>
+                </a:solidFill>
+              </a:rPr>
+              <a:t>5</a:t>
+            </a:r>
+          </a:p>
+        </p:txBody>
+      </p:sp>
+      <p:sp>
+        <p:nvSpPr>
+          <p:cNvPr id="18" name="TextBox 17">
+            <a:extLst>
+              <a:ext uri="{FF2B5EF4-FFF2-40B4-BE49-F238E27FC236}">
+                <a16:creationId xmlns:a16="http://schemas.microsoft.com/office/drawing/2014/main" id="{5DDFC490-0EB6-E706-0A7A-D4107B4CBEF6}"/>
+              </a:ext>
+            </a:extLst>
+          </p:cNvPr>
+          <p:cNvSpPr txBox="1"/>
+          <p:nvPr/>
+        </p:nvSpPr>
+        <p:spPr>
+          <a:xfrm>
+            <a:off x="9787287" y="369332"/>
+            <a:ext cx="308098" cy="369332"/>
+          </a:xfrm>
+          <a:prstGeom prst="rect">
+            <a:avLst/>
+          </a:prstGeom>
+          <a:noFill/>
+        </p:spPr>
+        <p:txBody>
+          <a:bodyPr wrap="square" rtlCol="0">
+            <a:spAutoFit/>
+          </a:bodyPr>
+          <a:lstStyle/>
+          <a:p>
+            <a:r>
+              <a:rPr lang="en-US" dirty="0">
+                <a:solidFill>
+                  <a:srgbClr val="FF0000"/>
+                </a:solidFill>
+              </a:rPr>
+              <a:t>6</a:t>
+            </a:r>
+          </a:p>
+        </p:txBody>
+      </p:sp>
+      <p:sp>
+        <p:nvSpPr>
+          <p:cNvPr id="3" name="TextBox 2">
+            <a:extLst>
+              <a:ext uri="{FF2B5EF4-FFF2-40B4-BE49-F238E27FC236}">
+                <a16:creationId xmlns:a16="http://schemas.microsoft.com/office/drawing/2014/main" id="{9A8F4913-9D14-11CE-7CD0-FDE51C54D856}"/>
+              </a:ext>
+            </a:extLst>
+          </p:cNvPr>
+          <p:cNvSpPr txBox="1"/>
+          <p:nvPr/>
+        </p:nvSpPr>
+        <p:spPr>
+          <a:xfrm>
+            <a:off x="10239352" y="369332"/>
+            <a:ext cx="308098" cy="369332"/>
+          </a:xfrm>
+          <a:prstGeom prst="rect">
+            <a:avLst/>
+          </a:prstGeom>
+          <a:noFill/>
+        </p:spPr>
+        <p:txBody>
+          <a:bodyPr wrap="square" rtlCol="0">
+            <a:spAutoFit/>
+          </a:bodyPr>
+          <a:lstStyle/>
+          <a:p>
+            <a:r>
+              <a:rPr lang="en-US" dirty="0">
+                <a:solidFill>
+                  <a:srgbClr val="FF0000"/>
+                </a:solidFill>
+              </a:rPr>
+              <a:t>7</a:t>
+            </a:r>
+          </a:p>
+        </p:txBody>
+      </p:sp>
+      <p:sp>
+        <p:nvSpPr>
+          <p:cNvPr id="7" name="Rectangle 6">
+            <a:extLst>
+              <a:ext uri="{FF2B5EF4-FFF2-40B4-BE49-F238E27FC236}">
+                <a16:creationId xmlns:a16="http://schemas.microsoft.com/office/drawing/2014/main" id="{1154C8EF-2181-C5EB-0505-FA6C78C42E85}"/>
+              </a:ext>
+            </a:extLst>
+          </p:cNvPr>
+          <p:cNvSpPr/>
+          <p:nvPr/>
+        </p:nvSpPr>
+        <p:spPr>
+          <a:xfrm>
+            <a:off x="1238048" y="-31334"/>
+            <a:ext cx="508172" cy="432000"/>
+          </a:xfrm>
+          <a:prstGeom prst="rect">
+            <a:avLst/>
+          </a:prstGeom>
+          <a:noFill/>
+          <a:ln w="38100">
+            <a:solidFill>
+              <a:srgbClr val="FF0000"/>
+            </a:solidFill>
+          </a:ln>
+        </p:spPr>
+        <p:style>
+          <a:lnRef idx="2">
+            <a:schemeClr val="accent1">
+              <a:shade val="15000"/>
+            </a:schemeClr>
+          </a:lnRef>
+          <a:fillRef idx="1">
+            <a:schemeClr val="accent1"/>
+          </a:fillRef>
+          <a:effectRef idx="0">
+            <a:schemeClr val="accent1"/>
+          </a:effectRef>
+          <a:fontRef idx="minor">
+            <a:schemeClr val="lt1"/>
+          </a:fontRef>
+        </p:style>
+        <p:txBody>
+          <a:bodyPr rtlCol="0" anchor="ctr"/>
+          <a:lstStyle/>
+          <a:p>
+            <a:pPr algn="ctr"/>
+            <a:endParaRPr lang="en-US">
+              <a:ln w="0"/>
+              <a:solidFill>
+                <a:schemeClr val="tx1"/>
+              </a:solidFill>
+              <a:effectLst>
+                <a:outerShdw blurRad="38100" dist="19050" dir="2700000" algn="tl" rotWithShape="0">
+                  <a:schemeClr val="dk1">
+                    <a:alpha val="40000"/>
+                  </a:schemeClr>
+                </a:outerShdw>
+              </a:effectLst>
+            </a:endParaRPr>
+          </a:p>
+        </p:txBody>
+      </p:sp>
+      <p:sp>
+        <p:nvSpPr>
+          <p:cNvPr id="9" name="Rectangle 8">
+            <a:extLst>
+              <a:ext uri="{FF2B5EF4-FFF2-40B4-BE49-F238E27FC236}">
+                <a16:creationId xmlns:a16="http://schemas.microsoft.com/office/drawing/2014/main" id="{BB20B77C-AB5A-03CB-D8DA-1A5E8F64A150}"/>
+              </a:ext>
+            </a:extLst>
+          </p:cNvPr>
+          <p:cNvSpPr/>
+          <p:nvPr/>
+        </p:nvSpPr>
+        <p:spPr>
+          <a:xfrm>
+            <a:off x="1983918" y="-31334"/>
+            <a:ext cx="434225" cy="442031"/>
+          </a:xfrm>
+          <a:prstGeom prst="rect">
+            <a:avLst/>
+          </a:prstGeom>
+          <a:noFill/>
+          <a:ln w="38100">
+            <a:solidFill>
+              <a:srgbClr val="FF0000"/>
+            </a:solidFill>
+          </a:ln>
+        </p:spPr>
+        <p:style>
+          <a:lnRef idx="2">
+            <a:schemeClr val="accent1">
+              <a:shade val="15000"/>
+            </a:schemeClr>
+          </a:lnRef>
+          <a:fillRef idx="1">
+            <a:schemeClr val="accent1"/>
+          </a:fillRef>
+          <a:effectRef idx="0">
+            <a:schemeClr val="accent1"/>
+          </a:effectRef>
+          <a:fontRef idx="minor">
+            <a:schemeClr val="lt1"/>
+          </a:fontRef>
+        </p:style>
+        <p:txBody>
+          <a:bodyPr rtlCol="0" anchor="ctr"/>
+          <a:lstStyle/>
+          <a:p>
+            <a:pPr algn="ctr"/>
+            <a:endParaRPr lang="en-US" dirty="0">
+              <a:ln w="0"/>
+              <a:solidFill>
+                <a:schemeClr val="tx1"/>
+              </a:solidFill>
+              <a:effectLst>
+                <a:outerShdw blurRad="38100" dist="19050" dir="2700000" algn="tl" rotWithShape="0">
+                  <a:schemeClr val="dk1">
+                    <a:alpha val="40000"/>
+                  </a:schemeClr>
+                </a:outerShdw>
+              </a:effectLst>
+            </a:endParaRPr>
+          </a:p>
+        </p:txBody>
+      </p:sp>
+      <p:sp>
+        <p:nvSpPr>
+          <p:cNvPr id="11" name="Rectangle 10">
+            <a:extLst>
+              <a:ext uri="{FF2B5EF4-FFF2-40B4-BE49-F238E27FC236}">
+                <a16:creationId xmlns:a16="http://schemas.microsoft.com/office/drawing/2014/main" id="{0A6D7683-FE00-C1C6-EE58-D18D58B85268}"/>
+              </a:ext>
+            </a:extLst>
+          </p:cNvPr>
+          <p:cNvSpPr/>
+          <p:nvPr/>
+        </p:nvSpPr>
+        <p:spPr>
+          <a:xfrm>
+            <a:off x="4119354" y="-31334"/>
+            <a:ext cx="1758482" cy="432000"/>
+          </a:xfrm>
+          <a:prstGeom prst="rect">
+            <a:avLst/>
+          </a:prstGeom>
+          <a:noFill/>
+          <a:ln w="38100">
+            <a:solidFill>
+              <a:srgbClr val="FF0000"/>
+            </a:solidFill>
+          </a:ln>
+        </p:spPr>
+        <p:style>
+          <a:lnRef idx="2">
+            <a:schemeClr val="accent1">
+              <a:shade val="15000"/>
+            </a:schemeClr>
+          </a:lnRef>
+          <a:fillRef idx="1">
+            <a:schemeClr val="accent1"/>
+          </a:fillRef>
+          <a:effectRef idx="0">
+            <a:schemeClr val="accent1"/>
+          </a:effectRef>
+          <a:fontRef idx="minor">
+            <a:schemeClr val="lt1"/>
+          </a:fontRef>
+        </p:style>
+        <p:txBody>
+          <a:bodyPr rtlCol="0" anchor="ctr"/>
+          <a:lstStyle/>
+          <a:p>
+            <a:pPr algn="ctr"/>
+            <a:endParaRPr lang="en-US">
+              <a:ln w="0"/>
+              <a:solidFill>
+                <a:schemeClr val="tx1"/>
+              </a:solidFill>
+              <a:effectLst>
+                <a:outerShdw blurRad="38100" dist="19050" dir="2700000" algn="tl" rotWithShape="0">
+                  <a:schemeClr val="dk1">
+                    <a:alpha val="40000"/>
+                  </a:schemeClr>
+                </a:outerShdw>
+              </a:effectLst>
+            </a:endParaRPr>
+          </a:p>
+        </p:txBody>
+      </p:sp>
+      <p:sp>
+        <p:nvSpPr>
+          <p:cNvPr id="13" name="Rectangle 12">
+            <a:extLst>
+              <a:ext uri="{FF2B5EF4-FFF2-40B4-BE49-F238E27FC236}">
+                <a16:creationId xmlns:a16="http://schemas.microsoft.com/office/drawing/2014/main" id="{87F319DB-E90A-F9AB-1273-9B6163824C75}"/>
+              </a:ext>
+            </a:extLst>
+          </p:cNvPr>
+          <p:cNvSpPr/>
+          <p:nvPr/>
+        </p:nvSpPr>
+        <p:spPr>
+          <a:xfrm>
+            <a:off x="7701699" y="-31334"/>
+            <a:ext cx="1430960" cy="432000"/>
+          </a:xfrm>
+          <a:prstGeom prst="rect">
+            <a:avLst/>
+          </a:prstGeom>
+          <a:noFill/>
+          <a:ln w="38100">
+            <a:solidFill>
+              <a:srgbClr val="FF0000"/>
+            </a:solidFill>
+          </a:ln>
+        </p:spPr>
+        <p:style>
+          <a:lnRef idx="2">
+            <a:schemeClr val="accent1">
+              <a:shade val="15000"/>
+            </a:schemeClr>
+          </a:lnRef>
+          <a:fillRef idx="1">
+            <a:schemeClr val="accent1"/>
+          </a:fillRef>
+          <a:effectRef idx="0">
+            <a:schemeClr val="accent1"/>
+          </a:effectRef>
+          <a:fontRef idx="minor">
+            <a:schemeClr val="lt1"/>
+          </a:fontRef>
+        </p:style>
+        <p:txBody>
+          <a:bodyPr rtlCol="0" anchor="ctr"/>
+          <a:lstStyle/>
+          <a:p>
+            <a:pPr algn="ctr"/>
+            <a:endParaRPr lang="en-US">
+              <a:ln w="0"/>
+              <a:solidFill>
+                <a:schemeClr val="tx1"/>
+              </a:solidFill>
+              <a:effectLst>
+                <a:outerShdw blurRad="38100" dist="19050" dir="2700000" algn="tl" rotWithShape="0">
+                  <a:schemeClr val="dk1">
+                    <a:alpha val="40000"/>
+                  </a:schemeClr>
+                </a:outerShdw>
+              </a:effectLst>
+            </a:endParaRPr>
+          </a:p>
+        </p:txBody>
+      </p:sp>
+      <p:sp>
+        <p:nvSpPr>
+          <p:cNvPr id="15" name="Rectangle 14">
+            <a:extLst>
+              <a:ext uri="{FF2B5EF4-FFF2-40B4-BE49-F238E27FC236}">
+                <a16:creationId xmlns:a16="http://schemas.microsoft.com/office/drawing/2014/main" id="{788F1A68-DAEC-8C35-0014-46C58CD04C8A}"/>
+              </a:ext>
+            </a:extLst>
+          </p:cNvPr>
+          <p:cNvSpPr/>
+          <p:nvPr/>
+        </p:nvSpPr>
+        <p:spPr>
+          <a:xfrm>
+            <a:off x="9296273" y="-31334"/>
+            <a:ext cx="471314" cy="432000"/>
+          </a:xfrm>
+          <a:prstGeom prst="rect">
+            <a:avLst/>
+          </a:prstGeom>
+          <a:noFill/>
+          <a:ln w="38100">
+            <a:solidFill>
+              <a:srgbClr val="FF0000"/>
+            </a:solidFill>
+          </a:ln>
+        </p:spPr>
+        <p:style>
+          <a:lnRef idx="2">
+            <a:schemeClr val="accent1">
+              <a:shade val="15000"/>
+            </a:schemeClr>
+          </a:lnRef>
+          <a:fillRef idx="1">
+            <a:schemeClr val="accent1"/>
+          </a:fillRef>
+          <a:effectRef idx="0">
+            <a:schemeClr val="accent1"/>
+          </a:effectRef>
+          <a:fontRef idx="minor">
+            <a:schemeClr val="lt1"/>
+          </a:fontRef>
+        </p:style>
+        <p:txBody>
+          <a:bodyPr rtlCol="0" anchor="ctr"/>
+          <a:lstStyle/>
+          <a:p>
+            <a:pPr algn="ctr"/>
+            <a:endParaRPr lang="en-US">
+              <a:ln w="0"/>
+              <a:solidFill>
+                <a:schemeClr val="tx1"/>
+              </a:solidFill>
+              <a:effectLst>
+                <a:outerShdw blurRad="38100" dist="19050" dir="2700000" algn="tl" rotWithShape="0">
+                  <a:schemeClr val="dk1">
+                    <a:alpha val="40000"/>
+                  </a:schemeClr>
+                </a:outerShdw>
+              </a:effectLst>
+            </a:endParaRPr>
+          </a:p>
+        </p:txBody>
+      </p:sp>
+      <p:sp>
+        <p:nvSpPr>
+          <p:cNvPr id="17" name="Rectangle 16">
+            <a:extLst>
+              <a:ext uri="{FF2B5EF4-FFF2-40B4-BE49-F238E27FC236}">
+                <a16:creationId xmlns:a16="http://schemas.microsoft.com/office/drawing/2014/main" id="{DC3D1C54-23C5-BAF7-DF50-16DF8B60CF66}"/>
+              </a:ext>
+            </a:extLst>
+          </p:cNvPr>
+          <p:cNvSpPr/>
+          <p:nvPr/>
+        </p:nvSpPr>
+        <p:spPr>
+          <a:xfrm>
+            <a:off x="9895817" y="-31334"/>
+            <a:ext cx="286093" cy="432000"/>
+          </a:xfrm>
+          <a:prstGeom prst="rect">
+            <a:avLst/>
+          </a:prstGeom>
+          <a:noFill/>
+          <a:ln w="38100">
+            <a:solidFill>
+              <a:srgbClr val="FF0000"/>
+            </a:solidFill>
+          </a:ln>
+        </p:spPr>
+        <p:style>
+          <a:lnRef idx="2">
+            <a:schemeClr val="accent1">
+              <a:shade val="15000"/>
+            </a:schemeClr>
+          </a:lnRef>
+          <a:fillRef idx="1">
+            <a:schemeClr val="accent1"/>
+          </a:fillRef>
+          <a:effectRef idx="0">
+            <a:schemeClr val="accent1"/>
+          </a:effectRef>
+          <a:fontRef idx="minor">
+            <a:schemeClr val="lt1"/>
+          </a:fontRef>
+        </p:style>
+        <p:txBody>
+          <a:bodyPr rtlCol="0" anchor="ctr"/>
+          <a:lstStyle/>
+          <a:p>
+            <a:pPr algn="ctr"/>
+            <a:endParaRPr lang="en-US">
+              <a:ln w="0"/>
+              <a:solidFill>
+                <a:schemeClr val="tx1"/>
+              </a:solidFill>
+              <a:effectLst>
+                <a:outerShdw blurRad="38100" dist="19050" dir="2700000" algn="tl" rotWithShape="0">
+                  <a:schemeClr val="dk1">
+                    <a:alpha val="40000"/>
+                  </a:schemeClr>
+                </a:outerShdw>
+              </a:effectLst>
+            </a:endParaRPr>
+          </a:p>
+        </p:txBody>
+      </p:sp>
+      <p:sp>
+        <p:nvSpPr>
+          <p:cNvPr id="2" name="Rectangle 1">
+            <a:extLst>
+              <a:ext uri="{FF2B5EF4-FFF2-40B4-BE49-F238E27FC236}">
+                <a16:creationId xmlns:a16="http://schemas.microsoft.com/office/drawing/2014/main" id="{FE3672EF-3DAF-C198-9141-FDF246494426}"/>
+              </a:ext>
+            </a:extLst>
+          </p:cNvPr>
+          <p:cNvSpPr/>
+          <p:nvPr/>
+        </p:nvSpPr>
+        <p:spPr>
+          <a:xfrm>
+            <a:off x="10342086" y="-31334"/>
+            <a:ext cx="286213" cy="432000"/>
+          </a:xfrm>
+          <a:prstGeom prst="rect">
+            <a:avLst/>
+          </a:prstGeom>
+          <a:noFill/>
+          <a:ln w="38100">
+            <a:solidFill>
+              <a:srgbClr val="FF0000"/>
+            </a:solidFill>
+          </a:ln>
+        </p:spPr>
+        <p:style>
+          <a:lnRef idx="2">
+            <a:schemeClr val="accent1">
+              <a:shade val="15000"/>
+            </a:schemeClr>
+          </a:lnRef>
+          <a:fillRef idx="1">
+            <a:schemeClr val="accent1"/>
+          </a:fillRef>
+          <a:effectRef idx="0">
+            <a:schemeClr val="accent1"/>
+          </a:effectRef>
+          <a:fontRef idx="minor">
+            <a:schemeClr val="lt1"/>
+          </a:fontRef>
+        </p:style>
+        <p:txBody>
+          <a:bodyPr rtlCol="0" anchor="ctr"/>
+          <a:lstStyle/>
+          <a:p>
+            <a:pPr algn="ctr"/>
+            <a:endParaRPr lang="en-US">
+              <a:ln w="0"/>
+              <a:solidFill>
+                <a:schemeClr val="tx1"/>
+              </a:solidFill>
+              <a:effectLst>
+                <a:outerShdw blurRad="38100" dist="19050" dir="2700000" algn="tl" rotWithShape="0">
+                  <a:schemeClr val="dk1">
+                    <a:alpha val="40000"/>
+                  </a:schemeClr>
+                </a:outerShdw>
+              </a:effectLst>
+            </a:endParaRPr>
+          </a:p>
+        </p:txBody>
+      </p:sp>
+      <p:sp>
+        <p:nvSpPr>
+          <p:cNvPr id="4" name="Rectangle 3">
+            <a:extLst>
+              <a:ext uri="{FF2B5EF4-FFF2-40B4-BE49-F238E27FC236}">
+                <a16:creationId xmlns:a16="http://schemas.microsoft.com/office/drawing/2014/main" id="{55F31252-F204-60C8-FB1F-4DD70CEEED95}"/>
+              </a:ext>
+            </a:extLst>
+          </p:cNvPr>
+          <p:cNvSpPr/>
+          <p:nvPr/>
+        </p:nvSpPr>
+        <p:spPr>
+          <a:xfrm>
+            <a:off x="10788476" y="-31334"/>
+            <a:ext cx="286213" cy="432000"/>
+          </a:xfrm>
+          <a:prstGeom prst="rect">
+            <a:avLst/>
+          </a:prstGeom>
+          <a:noFill/>
+          <a:ln w="38100">
+            <a:solidFill>
+              <a:srgbClr val="FF0000"/>
+            </a:solidFill>
+          </a:ln>
+        </p:spPr>
+        <p:style>
+          <a:lnRef idx="2">
+            <a:schemeClr val="accent1">
+              <a:shade val="15000"/>
+            </a:schemeClr>
+          </a:lnRef>
+          <a:fillRef idx="1">
+            <a:schemeClr val="accent1"/>
+          </a:fillRef>
+          <a:effectRef idx="0">
+            <a:schemeClr val="accent1"/>
+          </a:effectRef>
+          <a:fontRef idx="minor">
+            <a:schemeClr val="lt1"/>
+          </a:fontRef>
+        </p:style>
+        <p:txBody>
+          <a:bodyPr rtlCol="0" anchor="ctr"/>
+          <a:lstStyle/>
+          <a:p>
+            <a:pPr algn="ctr"/>
+            <a:endParaRPr lang="en-US">
+              <a:ln w="0"/>
+              <a:solidFill>
+                <a:schemeClr val="tx1"/>
+              </a:solidFill>
+              <a:effectLst>
+                <a:outerShdw blurRad="38100" dist="19050" dir="2700000" algn="tl" rotWithShape="0">
+                  <a:schemeClr val="dk1">
+                    <a:alpha val="40000"/>
+                  </a:schemeClr>
+                </a:outerShdw>
+              </a:effectLst>
+            </a:endParaRPr>
+          </a:p>
+        </p:txBody>
+      </p:sp>
+      <p:sp>
+        <p:nvSpPr>
+          <p:cNvPr id="6" name="TextBox 5">
+            <a:extLst>
+              <a:ext uri="{FF2B5EF4-FFF2-40B4-BE49-F238E27FC236}">
+                <a16:creationId xmlns:a16="http://schemas.microsoft.com/office/drawing/2014/main" id="{EB222A99-1A52-EE89-5996-96FF2E6428F0}"/>
+              </a:ext>
+            </a:extLst>
+          </p:cNvPr>
+          <p:cNvSpPr txBox="1"/>
+          <p:nvPr/>
+        </p:nvSpPr>
+        <p:spPr>
+          <a:xfrm>
+            <a:off x="10681207" y="369332"/>
+            <a:ext cx="308098" cy="369332"/>
+          </a:xfrm>
+          <a:prstGeom prst="rect">
+            <a:avLst/>
+          </a:prstGeom>
+          <a:noFill/>
+        </p:spPr>
+        <p:txBody>
+          <a:bodyPr wrap="square" rtlCol="0">
+            <a:spAutoFit/>
+          </a:bodyPr>
+          <a:lstStyle/>
+          <a:p>
+            <a:r>
+              <a:rPr lang="en-US" dirty="0">
+                <a:solidFill>
+                  <a:srgbClr val="FF0000"/>
+                </a:solidFill>
+              </a:rPr>
+              <a:t>8</a:t>
+            </a:r>
+          </a:p>
+        </p:txBody>
+      </p:sp>
+    </p:spTree>
+    <p:extLst>
+      <p:ext uri="{BB962C8B-B14F-4D97-AF65-F5344CB8AC3E}">
+        <p14:creationId xmlns:p14="http://schemas.microsoft.com/office/powerpoint/2010/main" val="1838129098"/>
+      </p:ext>
+    </p:extLst>
+  </p:cSld>
+  <p:clrMapOvr>
+    <a:masterClrMapping/>
+  </p:clrMapOvr>
+</p:sld>
+</file>
+
+<file path=ppt/slides/slide9.xml><?xml version="1.0" encoding="utf-8"?>
+<p:sld xmlns:a="http://schemas.openxmlformats.org/drawingml/2006/main" xmlns:r="http://schemas.openxmlformats.org/officeDocument/2006/relationships" xmlns:p="http://schemas.openxmlformats.org/presentationml/2006/main">
+  <p:cSld>
+    <p:spTree>
+      <p:nvGrpSpPr>
+        <p:cNvPr id="1" name=""/>
+        <p:cNvGrpSpPr/>
+        <p:nvPr/>
+      </p:nvGrpSpPr>
+      <p:grpSpPr>
+        <a:xfrm>
+          <a:off x="0" y="0"/>
+          <a:ext cx="0" cy="0"/>
+          <a:chOff x="0" y="0"/>
+          <a:chExt cx="0" cy="0"/>
+        </a:xfrm>
+      </p:grpSpPr>
+      <p:sp>
+        <p:nvSpPr>
+          <p:cNvPr id="2" name="Title 1">
+            <a:extLst>
+              <a:ext uri="{FF2B5EF4-FFF2-40B4-BE49-F238E27FC236}">
+                <a16:creationId xmlns:a16="http://schemas.microsoft.com/office/drawing/2014/main" id="{568B5E8A-2D36-7A5E-240E-098C63E4B3EA}"/>
+              </a:ext>
+            </a:extLst>
+          </p:cNvPr>
+          <p:cNvSpPr>
+            <a:spLocks noGrp="1"/>
+          </p:cNvSpPr>
+          <p:nvPr>
+            <p:ph type="title"/>
+          </p:nvPr>
+        </p:nvSpPr>
+        <p:spPr/>
+        <p:txBody>
+          <a:bodyPr/>
+          <a:lstStyle/>
+          <a:p>
+            <a:r>
+              <a:rPr lang="en-US" dirty="0"/>
+              <a:t>Projects Page Image	</a:t>
+            </a:r>
+          </a:p>
+        </p:txBody>
+      </p:sp>
+      <p:sp>
+        <p:nvSpPr>
+          <p:cNvPr id="3" name="Content Placeholder 2">
+            <a:extLst>
+              <a:ext uri="{FF2B5EF4-FFF2-40B4-BE49-F238E27FC236}">
+                <a16:creationId xmlns:a16="http://schemas.microsoft.com/office/drawing/2014/main" id="{4FE17AAA-CBA6-29CC-1DC3-631B80968653}"/>
+              </a:ext>
+            </a:extLst>
+          </p:cNvPr>
+          <p:cNvSpPr>
+            <a:spLocks noGrp="1"/>
+          </p:cNvSpPr>
+          <p:nvPr>
+            <p:ph idx="1"/>
+          </p:nvPr>
+        </p:nvSpPr>
+        <p:spPr/>
+        <p:txBody>
+          <a:bodyPr/>
+          <a:lstStyle/>
+          <a:p>
+            <a:r>
+              <a:rPr lang="en-US" dirty="0"/>
+              <a:t>Unmarked: None</a:t>
+            </a:r>
+          </a:p>
+        </p:txBody>
+      </p:sp>
+    </p:spTree>
+    <p:extLst>
+      <p:ext uri="{BB962C8B-B14F-4D97-AF65-F5344CB8AC3E}">
+        <p14:creationId xmlns:p14="http://schemas.microsoft.com/office/powerpoint/2010/main" val="2704037288"/>
       </p:ext>
     </p:extLst>
   </p:cSld>

</xml_diff>

<commit_message>
[DE-2265]: Simplified quickstart guide to the tourist workflow where the users copy a public dataset 'Coffee Cup' and uses this dataset for training and validation. Added explore dataset which shows what each section and attributes of the dataset card means and how to see the images and annotations inside the dataset.
Signed-off-by: johns <john.s@au-zone.com>
</commit_message>
<xml_diff>
--- a/images_with_layers.pptx
+++ b/images_with_layers.pptx
@@ -5,7 +5,7 @@
     <p:sldMasterId id="2147483648" r:id="rId1"/>
   </p:sldMasterIdLst>
   <p:notesMasterIdLst>
-    <p:notesMasterId r:id="rId18"/>
+    <p:notesMasterId r:id="rId23"/>
   </p:notesMasterIdLst>
   <p:sldIdLst>
     <p:sldId id="264" r:id="rId2"/>
@@ -22,8 +22,13 @@
     <p:sldId id="271" r:id="rId13"/>
     <p:sldId id="272" r:id="rId14"/>
     <p:sldId id="273" r:id="rId15"/>
-    <p:sldId id="262" r:id="rId16"/>
-    <p:sldId id="260" r:id="rId17"/>
+    <p:sldId id="274" r:id="rId16"/>
+    <p:sldId id="277" r:id="rId17"/>
+    <p:sldId id="275" r:id="rId18"/>
+    <p:sldId id="278" r:id="rId19"/>
+    <p:sldId id="279" r:id="rId20"/>
+    <p:sldId id="262" r:id="rId21"/>
+    <p:sldId id="260" r:id="rId22"/>
   </p:sldIdLst>
   <p:sldSz cx="12192000" cy="6858000"/>
   <p:notesSz cx="6858000" cy="9144000"/>
@@ -161,6 +166,19 @@
           <p14:sldIdLst>
             <p14:sldId id="272"/>
             <p14:sldId id="273"/>
+            <p14:sldId id="274"/>
+          </p14:sldIdLst>
+        </p14:section>
+        <p14:section name="Sample Project Datasets" id="{2E77D04D-14D4-4BED-9FA7-C99A3C7899CF}">
+          <p14:sldIdLst>
+            <p14:sldId id="277"/>
+            <p14:sldId id="275"/>
+          </p14:sldIdLst>
+        </p14:section>
+        <p14:section name="Copy Datasets" id="{D6A12F74-0150-4F00-988C-D9D4A6A78534}">
+          <p14:sldIdLst>
+            <p14:sldId id="278"/>
+            <p14:sldId id="279"/>
           </p14:sldIdLst>
         </p14:section>
         <p14:section name="Dataset Gallery" id="{69866AF7-968C-4F26-9ECA-AA64F6FFB6E8}">
@@ -670,7 +688,7 @@
           <a:p>
             <a:fld id="{E487E608-D9C6-4B3C-A9A4-BEAD08ECA06D}" type="datetimeFigureOut">
               <a:rPr lang="en-US" smtClean="0"/>
-              <a:t>11/17/2025</a:t>
+              <a:t>11/26/2025</a:t>
             </a:fld>
             <a:endParaRPr lang="en-US"/>
           </a:p>
@@ -1557,7 +1575,7 @@
             </a:pPr>
             <a:r>
               <a:rPr lang="en-US" dirty="0"/>
-              <a:t>Marked: docs/</a:t>
+              <a:t>Marked: /docs/</a:t>
             </a:r>
             <a:r>
               <a:rPr lang="en-US" sz="1200" b="0" u="sng" kern="1200" dirty="0">
@@ -1685,7 +1703,7 @@
             </a:pPr>
             <a:r>
               <a:rPr lang="en-US" dirty="0"/>
-              <a:t>Marked: </a:t>
+              <a:t>Marked: /docs</a:t>
             </a:r>
             <a:r>
               <a:rPr lang="en-US" sz="1200" b="0" u="sng" kern="1200" dirty="0">
@@ -1791,9 +1809,253 @@
           <a:bodyPr/>
           <a:lstStyle/>
           <a:p>
+            <a:pPr marL="0" marR="0" lvl="0" indent="0" algn="l" defTabSz="914400" rtl="0" eaLnBrk="1" fontAlgn="auto" latinLnBrk="0" hangingPunct="1">
+              <a:lnSpc>
+                <a:spcPct val="100000"/>
+              </a:lnSpc>
+              <a:spcBef>
+                <a:spcPts val="0"/>
+              </a:spcBef>
+              <a:spcAft>
+                <a:spcPts val="0"/>
+              </a:spcAft>
+              <a:buClrTx/>
+              <a:buSzTx/>
+              <a:buFontTx/>
+              <a:buNone/>
+              <a:tabLst/>
+              <a:defRPr/>
+            </a:pPr>
             <a:r>
               <a:rPr lang="en-US" dirty="0"/>
-              <a:t>Marked:  </a:t>
+              <a:t>Marked: /docs</a:t>
+            </a:r>
+            <a:r>
+              <a:rPr lang="en-US" sz="1200" b="0" u="sng" kern="1200" dirty="0">
+                <a:solidFill>
+                  <a:schemeClr val="tx1"/>
+                </a:solidFill>
+                <a:effectLst/>
+                <a:latin typeface="+mn-lt"/>
+                <a:ea typeface="+mn-ea"/>
+                <a:cs typeface="+mn-cs"/>
+              </a:rPr>
+              <a:t>/studio/assets/projects/sample-datasets-button.jpg</a:t>
+            </a:r>
+            <a:endParaRPr lang="en-US" sz="1200" b="0" kern="1200" dirty="0">
+              <a:solidFill>
+                <a:schemeClr val="tx1"/>
+              </a:solidFill>
+              <a:effectLst/>
+              <a:latin typeface="+mn-lt"/>
+              <a:ea typeface="+mn-ea"/>
+              <a:cs typeface="+mn-cs"/>
+            </a:endParaRPr>
+          </a:p>
+        </p:txBody>
+      </p:sp>
+      <p:sp>
+        <p:nvSpPr>
+          <p:cNvPr id="4" name="Slide Number Placeholder 3"/>
+          <p:cNvSpPr>
+            <a:spLocks noGrp="1"/>
+          </p:cNvSpPr>
+          <p:nvPr>
+            <p:ph type="sldNum" sz="quarter" idx="5"/>
+          </p:nvPr>
+        </p:nvSpPr>
+        <p:spPr/>
+        <p:txBody>
+          <a:bodyPr/>
+          <a:lstStyle/>
+          <a:p>
+            <a:fld id="{874397DF-5812-45E4-B5F0-BF2AEB9BFE48}" type="slidenum">
+              <a:rPr lang="en-US" smtClean="0"/>
+              <a:t>15</a:t>
+            </a:fld>
+            <a:endParaRPr lang="en-US"/>
+          </a:p>
+        </p:txBody>
+      </p:sp>
+    </p:spTree>
+    <p:extLst>
+      <p:ext uri="{BB962C8B-B14F-4D97-AF65-F5344CB8AC3E}">
+        <p14:creationId xmlns:p14="http://schemas.microsoft.com/office/powerpoint/2010/main" val="2261502406"/>
+      </p:ext>
+    </p:extLst>
+  </p:cSld>
+  <p:clrMapOvr>
+    <a:masterClrMapping/>
+  </p:clrMapOvr>
+</p:notes>
+</file>
+
+<file path=ppt/notesSlides/notesSlide8.xml><?xml version="1.0" encoding="utf-8"?>
+<p:notes xmlns:a="http://schemas.openxmlformats.org/drawingml/2006/main" xmlns:r="http://schemas.openxmlformats.org/officeDocument/2006/relationships" xmlns:p="http://schemas.openxmlformats.org/presentationml/2006/main">
+  <p:cSld>
+    <p:spTree>
+      <p:nvGrpSpPr>
+        <p:cNvPr id="1" name=""/>
+        <p:cNvGrpSpPr/>
+        <p:nvPr/>
+      </p:nvGrpSpPr>
+      <p:grpSpPr>
+        <a:xfrm>
+          <a:off x="0" y="0"/>
+          <a:ext cx="0" cy="0"/>
+          <a:chOff x="0" y="0"/>
+          <a:chExt cx="0" cy="0"/>
+        </a:xfrm>
+      </p:grpSpPr>
+      <p:sp>
+        <p:nvSpPr>
+          <p:cNvPr id="2" name="Slide Image Placeholder 1"/>
+          <p:cNvSpPr>
+            <a:spLocks noGrp="1" noRot="1" noChangeAspect="1"/>
+          </p:cNvSpPr>
+          <p:nvPr>
+            <p:ph type="sldImg"/>
+          </p:nvPr>
+        </p:nvSpPr>
+        <p:spPr/>
+      </p:sp>
+      <p:sp>
+        <p:nvSpPr>
+          <p:cNvPr id="3" name="Notes Placeholder 2"/>
+          <p:cNvSpPr>
+            <a:spLocks noGrp="1"/>
+          </p:cNvSpPr>
+          <p:nvPr>
+            <p:ph type="body" idx="1"/>
+          </p:nvPr>
+        </p:nvSpPr>
+        <p:spPr/>
+        <p:txBody>
+          <a:bodyPr/>
+          <a:lstStyle/>
+          <a:p>
+            <a:pPr marL="0" marR="0" lvl="0" indent="0" algn="l" defTabSz="914400" rtl="0" eaLnBrk="1" fontAlgn="auto" latinLnBrk="0" hangingPunct="1">
+              <a:lnSpc>
+                <a:spcPct val="100000"/>
+              </a:lnSpc>
+              <a:spcBef>
+                <a:spcPts val="0"/>
+              </a:spcBef>
+              <a:spcAft>
+                <a:spcPts val="0"/>
+              </a:spcAft>
+              <a:buClrTx/>
+              <a:buSzTx/>
+              <a:buFontTx/>
+              <a:buNone/>
+              <a:tabLst/>
+              <a:defRPr/>
+            </a:pPr>
+            <a:r>
+              <a:rPr lang="en-CA" dirty="0"/>
+              <a:t>Marked: </a:t>
+            </a:r>
+            <a:r>
+              <a:rPr lang="en-US" sz="1200" b="0" kern="1200" dirty="0">
+                <a:solidFill>
+                  <a:schemeClr val="tx1"/>
+                </a:solidFill>
+                <a:effectLst/>
+                <a:latin typeface="+mn-lt"/>
+                <a:ea typeface="+mn-ea"/>
+                <a:cs typeface="+mn-cs"/>
+              </a:rPr>
+              <a:t>/docs/datasets/assets/management/copy-dataset-option.jpg</a:t>
+            </a:r>
+          </a:p>
+          <a:p>
+            <a:endParaRPr lang="en-US" dirty="0"/>
+          </a:p>
+        </p:txBody>
+      </p:sp>
+      <p:sp>
+        <p:nvSpPr>
+          <p:cNvPr id="4" name="Slide Number Placeholder 3"/>
+          <p:cNvSpPr>
+            <a:spLocks noGrp="1"/>
+          </p:cNvSpPr>
+          <p:nvPr>
+            <p:ph type="sldNum" sz="quarter" idx="5"/>
+          </p:nvPr>
+        </p:nvSpPr>
+        <p:spPr/>
+        <p:txBody>
+          <a:bodyPr/>
+          <a:lstStyle/>
+          <a:p>
+            <a:fld id="{874397DF-5812-45E4-B5F0-BF2AEB9BFE48}" type="slidenum">
+              <a:rPr lang="en-US" smtClean="0"/>
+              <a:t>17</a:t>
+            </a:fld>
+            <a:endParaRPr lang="en-US"/>
+          </a:p>
+        </p:txBody>
+      </p:sp>
+    </p:spTree>
+    <p:extLst>
+      <p:ext uri="{BB962C8B-B14F-4D97-AF65-F5344CB8AC3E}">
+        <p14:creationId xmlns:p14="http://schemas.microsoft.com/office/powerpoint/2010/main" val="3564482302"/>
+      </p:ext>
+    </p:extLst>
+  </p:cSld>
+  <p:clrMapOvr>
+    <a:masterClrMapping/>
+  </p:clrMapOvr>
+</p:notes>
+</file>
+
+<file path=ppt/notesSlides/notesSlide9.xml><?xml version="1.0" encoding="utf-8"?>
+<p:notes xmlns:a="http://schemas.openxmlformats.org/drawingml/2006/main" xmlns:r="http://schemas.openxmlformats.org/officeDocument/2006/relationships" xmlns:p="http://schemas.openxmlformats.org/presentationml/2006/main">
+  <p:cSld>
+    <p:spTree>
+      <p:nvGrpSpPr>
+        <p:cNvPr id="1" name=""/>
+        <p:cNvGrpSpPr/>
+        <p:nvPr/>
+      </p:nvGrpSpPr>
+      <p:grpSpPr>
+        <a:xfrm>
+          <a:off x="0" y="0"/>
+          <a:ext cx="0" cy="0"/>
+          <a:chOff x="0" y="0"/>
+          <a:chExt cx="0" cy="0"/>
+        </a:xfrm>
+      </p:grpSpPr>
+      <p:sp>
+        <p:nvSpPr>
+          <p:cNvPr id="2" name="Slide Image Placeholder 1"/>
+          <p:cNvSpPr>
+            <a:spLocks noGrp="1" noRot="1" noChangeAspect="1"/>
+          </p:cNvSpPr>
+          <p:nvPr>
+            <p:ph type="sldImg"/>
+          </p:nvPr>
+        </p:nvSpPr>
+        <p:spPr/>
+      </p:sp>
+      <p:sp>
+        <p:nvSpPr>
+          <p:cNvPr id="3" name="Notes Placeholder 2"/>
+          <p:cNvSpPr>
+            <a:spLocks noGrp="1"/>
+          </p:cNvSpPr>
+          <p:nvPr>
+            <p:ph type="body" idx="1"/>
+          </p:nvPr>
+        </p:nvSpPr>
+        <p:spPr/>
+        <p:txBody>
+          <a:bodyPr/>
+          <a:lstStyle/>
+          <a:p>
+            <a:r>
+              <a:rPr lang="en-US" dirty="0"/>
+              <a:t>Marked:  /</a:t>
             </a:r>
             <a:r>
               <a:rPr lang="en-US" sz="1200" b="0" i="0" kern="1200" dirty="0">
@@ -1828,7 +2090,7 @@
           <a:p>
             <a:fld id="{874397DF-5812-45E4-B5F0-BF2AEB9BFE48}" type="slidenum">
               <a:rPr lang="en-US" smtClean="0"/>
-              <a:t>16</a:t>
+              <a:t>21</a:t>
             </a:fld>
             <a:endParaRPr lang="en-US"/>
           </a:p>
@@ -1994,7 +2256,7 @@
           <a:p>
             <a:fld id="{D241CDF3-A1FB-4215-9C3B-B36887AAFAD2}" type="datetimeFigureOut">
               <a:rPr lang="en-US" smtClean="0"/>
-              <a:t>11/17/2025</a:t>
+              <a:t>11/26/2025</a:t>
             </a:fld>
             <a:endParaRPr lang="en-US"/>
           </a:p>
@@ -2192,7 +2454,7 @@
           <a:p>
             <a:fld id="{D241CDF3-A1FB-4215-9C3B-B36887AAFAD2}" type="datetimeFigureOut">
               <a:rPr lang="en-US" smtClean="0"/>
-              <a:t>11/17/2025</a:t>
+              <a:t>11/26/2025</a:t>
             </a:fld>
             <a:endParaRPr lang="en-US"/>
           </a:p>
@@ -2400,7 +2662,7 @@
           <a:p>
             <a:fld id="{D241CDF3-A1FB-4215-9C3B-B36887AAFAD2}" type="datetimeFigureOut">
               <a:rPr lang="en-US" smtClean="0"/>
-              <a:t>11/17/2025</a:t>
+              <a:t>11/26/2025</a:t>
             </a:fld>
             <a:endParaRPr lang="en-US"/>
           </a:p>
@@ -2598,7 +2860,7 @@
           <a:p>
             <a:fld id="{D241CDF3-A1FB-4215-9C3B-B36887AAFAD2}" type="datetimeFigureOut">
               <a:rPr lang="en-US" smtClean="0"/>
-              <a:t>11/17/2025</a:t>
+              <a:t>11/26/2025</a:t>
             </a:fld>
             <a:endParaRPr lang="en-US"/>
           </a:p>
@@ -2873,7 +3135,7 @@
           <a:p>
             <a:fld id="{D241CDF3-A1FB-4215-9C3B-B36887AAFAD2}" type="datetimeFigureOut">
               <a:rPr lang="en-US" smtClean="0"/>
-              <a:t>11/17/2025</a:t>
+              <a:t>11/26/2025</a:t>
             </a:fld>
             <a:endParaRPr lang="en-US"/>
           </a:p>
@@ -3138,7 +3400,7 @@
           <a:p>
             <a:fld id="{D241CDF3-A1FB-4215-9C3B-B36887AAFAD2}" type="datetimeFigureOut">
               <a:rPr lang="en-US" smtClean="0"/>
-              <a:t>11/17/2025</a:t>
+              <a:t>11/26/2025</a:t>
             </a:fld>
             <a:endParaRPr lang="en-US"/>
           </a:p>
@@ -3550,7 +3812,7 @@
           <a:p>
             <a:fld id="{D241CDF3-A1FB-4215-9C3B-B36887AAFAD2}" type="datetimeFigureOut">
               <a:rPr lang="en-US" smtClean="0"/>
-              <a:t>11/17/2025</a:t>
+              <a:t>11/26/2025</a:t>
             </a:fld>
             <a:endParaRPr lang="en-US"/>
           </a:p>
@@ -3691,7 +3953,7 @@
           <a:p>
             <a:fld id="{D241CDF3-A1FB-4215-9C3B-B36887AAFAD2}" type="datetimeFigureOut">
               <a:rPr lang="en-US" smtClean="0"/>
-              <a:t>11/17/2025</a:t>
+              <a:t>11/26/2025</a:t>
             </a:fld>
             <a:endParaRPr lang="en-US"/>
           </a:p>
@@ -3804,7 +4066,7 @@
           <a:p>
             <a:fld id="{D241CDF3-A1FB-4215-9C3B-B36887AAFAD2}" type="datetimeFigureOut">
               <a:rPr lang="en-US" smtClean="0"/>
-              <a:t>11/17/2025</a:t>
+              <a:t>11/26/2025</a:t>
             </a:fld>
             <a:endParaRPr lang="en-US"/>
           </a:p>
@@ -4115,7 +4377,7 @@
           <a:p>
             <a:fld id="{D241CDF3-A1FB-4215-9C3B-B36887AAFAD2}" type="datetimeFigureOut">
               <a:rPr lang="en-US" smtClean="0"/>
-              <a:t>11/17/2025</a:t>
+              <a:t>11/26/2025</a:t>
             </a:fld>
             <a:endParaRPr lang="en-US"/>
           </a:p>
@@ -4403,7 +4665,7 @@
           <a:p>
             <a:fld id="{D241CDF3-A1FB-4215-9C3B-B36887AAFAD2}" type="datetimeFigureOut">
               <a:rPr lang="en-US" smtClean="0"/>
-              <a:t>11/17/2025</a:t>
+              <a:t>11/26/2025</a:t>
             </a:fld>
             <a:endParaRPr lang="en-US"/>
           </a:p>
@@ -4644,7 +4906,7 @@
           <a:p>
             <a:fld id="{D241CDF3-A1FB-4215-9C3B-B36887AAFAD2}" type="datetimeFigureOut">
               <a:rPr lang="en-US" smtClean="0"/>
-              <a:t>11/17/2025</a:t>
+              <a:t>11/26/2025</a:t>
             </a:fld>
             <a:endParaRPr lang="en-US"/>
           </a:p>
@@ -5827,6 +6089,630 @@
   <p:cSld>
     <p:spTree>
       <p:nvGrpSpPr>
+        <p:cNvPr id="1" name=""/>
+        <p:cNvGrpSpPr/>
+        <p:nvPr/>
+      </p:nvGrpSpPr>
+      <p:grpSpPr>
+        <a:xfrm>
+          <a:off x="0" y="0"/>
+          <a:ext cx="0" cy="0"/>
+          <a:chOff x="0" y="0"/>
+          <a:chExt cx="0" cy="0"/>
+        </a:xfrm>
+      </p:grpSpPr>
+      <p:pic>
+        <p:nvPicPr>
+          <p:cNvPr id="4" name="Picture 3">
+            <a:extLst>
+              <a:ext uri="{FF2B5EF4-FFF2-40B4-BE49-F238E27FC236}">
+                <a16:creationId xmlns:a16="http://schemas.microsoft.com/office/drawing/2014/main" id="{BC15DFB5-2838-BF1E-3183-F8B1D1D3BC70}"/>
+              </a:ext>
+            </a:extLst>
+          </p:cNvPr>
+          <p:cNvPicPr>
+            <a:picLocks noChangeAspect="1"/>
+          </p:cNvPicPr>
+          <p:nvPr/>
+        </p:nvPicPr>
+        <p:blipFill>
+          <a:blip r:embed="rId3"/>
+          <a:stretch>
+            <a:fillRect/>
+          </a:stretch>
+        </p:blipFill>
+        <p:spPr>
+          <a:xfrm>
+            <a:off x="0" y="320444"/>
+            <a:ext cx="12192000" cy="6217112"/>
+          </a:xfrm>
+          <a:prstGeom prst="rect">
+            <a:avLst/>
+          </a:prstGeom>
+        </p:spPr>
+      </p:pic>
+      <p:sp>
+        <p:nvSpPr>
+          <p:cNvPr id="5" name="Rectangle 4">
+            <a:extLst>
+              <a:ext uri="{FF2B5EF4-FFF2-40B4-BE49-F238E27FC236}">
+                <a16:creationId xmlns:a16="http://schemas.microsoft.com/office/drawing/2014/main" id="{FDD68D19-65A5-C778-846D-E65A39B372E6}"/>
+              </a:ext>
+            </a:extLst>
+          </p:cNvPr>
+          <p:cNvSpPr/>
+          <p:nvPr/>
+        </p:nvSpPr>
+        <p:spPr>
+          <a:xfrm>
+            <a:off x="216816" y="2780907"/>
+            <a:ext cx="3723588" cy="575036"/>
+          </a:xfrm>
+          <a:prstGeom prst="rect">
+            <a:avLst/>
+          </a:prstGeom>
+          <a:noFill/>
+          <a:ln w="38100">
+            <a:solidFill>
+              <a:srgbClr val="FF0000"/>
+            </a:solidFill>
+          </a:ln>
+        </p:spPr>
+        <p:style>
+          <a:lnRef idx="2">
+            <a:schemeClr val="accent1">
+              <a:shade val="15000"/>
+            </a:schemeClr>
+          </a:lnRef>
+          <a:fillRef idx="1">
+            <a:schemeClr val="accent1"/>
+          </a:fillRef>
+          <a:effectRef idx="0">
+            <a:schemeClr val="accent1"/>
+          </a:effectRef>
+          <a:fontRef idx="minor">
+            <a:schemeClr val="lt1"/>
+          </a:fontRef>
+        </p:style>
+        <p:txBody>
+          <a:bodyPr rtlCol="0" anchor="ctr"/>
+          <a:lstStyle/>
+          <a:p>
+            <a:pPr algn="ctr"/>
+            <a:endParaRPr lang="en-US">
+              <a:ln w="0"/>
+              <a:solidFill>
+                <a:schemeClr val="tx1"/>
+              </a:solidFill>
+              <a:effectLst>
+                <a:outerShdw blurRad="38100" dist="19050" dir="2700000" algn="tl" rotWithShape="0">
+                  <a:schemeClr val="dk1">
+                    <a:alpha val="40000"/>
+                  </a:schemeClr>
+                </a:outerShdw>
+              </a:effectLst>
+            </a:endParaRPr>
+          </a:p>
+        </p:txBody>
+      </p:sp>
+    </p:spTree>
+    <p:extLst>
+      <p:ext uri="{BB962C8B-B14F-4D97-AF65-F5344CB8AC3E}">
+        <p14:creationId xmlns:p14="http://schemas.microsoft.com/office/powerpoint/2010/main" val="442216524"/>
+      </p:ext>
+    </p:extLst>
+  </p:cSld>
+  <p:clrMapOvr>
+    <a:masterClrMapping/>
+  </p:clrMapOvr>
+</p:sld>
+</file>
+
+<file path=ppt/slides/slide16.xml><?xml version="1.0" encoding="utf-8"?>
+<p:sld xmlns:a="http://schemas.openxmlformats.org/drawingml/2006/main" xmlns:r="http://schemas.openxmlformats.org/officeDocument/2006/relationships" xmlns:p="http://schemas.openxmlformats.org/presentationml/2006/main">
+  <p:cSld>
+    <p:spTree>
+      <p:nvGrpSpPr>
+        <p:cNvPr id="1" name="">
+          <a:extLst>
+            <a:ext uri="{FF2B5EF4-FFF2-40B4-BE49-F238E27FC236}">
+              <a16:creationId xmlns:a16="http://schemas.microsoft.com/office/drawing/2014/main" id="{809CFEE6-0B41-B5AC-A8BC-93751CD53AB3}"/>
+            </a:ext>
+          </a:extLst>
+        </p:cNvPr>
+        <p:cNvGrpSpPr/>
+        <p:nvPr/>
+      </p:nvGrpSpPr>
+      <p:grpSpPr>
+        <a:xfrm>
+          <a:off x="0" y="0"/>
+          <a:ext cx="0" cy="0"/>
+          <a:chOff x="0" y="0"/>
+          <a:chExt cx="0" cy="0"/>
+        </a:xfrm>
+      </p:grpSpPr>
+      <p:sp>
+        <p:nvSpPr>
+          <p:cNvPr id="2" name="Title 1">
+            <a:extLst>
+              <a:ext uri="{FF2B5EF4-FFF2-40B4-BE49-F238E27FC236}">
+                <a16:creationId xmlns:a16="http://schemas.microsoft.com/office/drawing/2014/main" id="{2BF9E2B4-73F0-8F6C-A386-473C27424135}"/>
+              </a:ext>
+            </a:extLst>
+          </p:cNvPr>
+          <p:cNvSpPr>
+            <a:spLocks noGrp="1"/>
+          </p:cNvSpPr>
+          <p:nvPr>
+            <p:ph type="title"/>
+          </p:nvPr>
+        </p:nvSpPr>
+        <p:spPr/>
+        <p:txBody>
+          <a:bodyPr/>
+          <a:lstStyle/>
+          <a:p>
+            <a:r>
+              <a:rPr lang="en-CA" dirty="0"/>
+              <a:t>Sample Project Datasets</a:t>
+            </a:r>
+            <a:endParaRPr lang="en-US" dirty="0"/>
+          </a:p>
+        </p:txBody>
+      </p:sp>
+      <p:sp>
+        <p:nvSpPr>
+          <p:cNvPr id="3" name="Content Placeholder 2">
+            <a:extLst>
+              <a:ext uri="{FF2B5EF4-FFF2-40B4-BE49-F238E27FC236}">
+                <a16:creationId xmlns:a16="http://schemas.microsoft.com/office/drawing/2014/main" id="{9E1A8AAA-9794-E667-0B36-53D3F4BA4D0D}"/>
+              </a:ext>
+            </a:extLst>
+          </p:cNvPr>
+          <p:cNvSpPr>
+            <a:spLocks noGrp="1"/>
+          </p:cNvSpPr>
+          <p:nvPr>
+            <p:ph idx="1"/>
+          </p:nvPr>
+        </p:nvSpPr>
+        <p:spPr/>
+        <p:txBody>
+          <a:bodyPr/>
+          <a:lstStyle/>
+          <a:p>
+            <a:r>
+              <a:rPr lang="en-US" dirty="0"/>
+              <a:t>Unmarked: None</a:t>
+            </a:r>
+          </a:p>
+        </p:txBody>
+      </p:sp>
+    </p:spTree>
+    <p:extLst>
+      <p:ext uri="{BB962C8B-B14F-4D97-AF65-F5344CB8AC3E}">
+        <p14:creationId xmlns:p14="http://schemas.microsoft.com/office/powerpoint/2010/main" val="3360056513"/>
+      </p:ext>
+    </p:extLst>
+  </p:cSld>
+  <p:clrMapOvr>
+    <a:masterClrMapping/>
+  </p:clrMapOvr>
+</p:sld>
+</file>
+
+<file path=ppt/slides/slide17.xml><?xml version="1.0" encoding="utf-8"?>
+<p:sld xmlns:a="http://schemas.openxmlformats.org/drawingml/2006/main" xmlns:r="http://schemas.openxmlformats.org/officeDocument/2006/relationships" xmlns:p="http://schemas.openxmlformats.org/presentationml/2006/main">
+  <p:cSld>
+    <p:spTree>
+      <p:nvGrpSpPr>
+        <p:cNvPr id="1" name=""/>
+        <p:cNvGrpSpPr/>
+        <p:nvPr/>
+      </p:nvGrpSpPr>
+      <p:grpSpPr>
+        <a:xfrm>
+          <a:off x="0" y="0"/>
+          <a:ext cx="0" cy="0"/>
+          <a:chOff x="0" y="0"/>
+          <a:chExt cx="0" cy="0"/>
+        </a:xfrm>
+      </p:grpSpPr>
+      <p:pic>
+        <p:nvPicPr>
+          <p:cNvPr id="5" name="Picture 4">
+            <a:extLst>
+              <a:ext uri="{FF2B5EF4-FFF2-40B4-BE49-F238E27FC236}">
+                <a16:creationId xmlns:a16="http://schemas.microsoft.com/office/drawing/2014/main" id="{815569EA-B53F-91BA-E3B4-87EE7BED1899}"/>
+              </a:ext>
+            </a:extLst>
+          </p:cNvPr>
+          <p:cNvPicPr>
+            <a:picLocks noChangeAspect="1"/>
+          </p:cNvPicPr>
+          <p:nvPr/>
+        </p:nvPicPr>
+        <p:blipFill>
+          <a:blip r:embed="rId3"/>
+          <a:stretch>
+            <a:fillRect/>
+          </a:stretch>
+        </p:blipFill>
+        <p:spPr>
+          <a:xfrm>
+            <a:off x="0" y="145849"/>
+            <a:ext cx="12192000" cy="6566301"/>
+          </a:xfrm>
+          <a:prstGeom prst="rect">
+            <a:avLst/>
+          </a:prstGeom>
+        </p:spPr>
+      </p:pic>
+      <p:sp>
+        <p:nvSpPr>
+          <p:cNvPr id="6" name="Rectangle 5">
+            <a:extLst>
+              <a:ext uri="{FF2B5EF4-FFF2-40B4-BE49-F238E27FC236}">
+                <a16:creationId xmlns:a16="http://schemas.microsoft.com/office/drawing/2014/main" id="{1F8D9B77-C704-652C-0CDB-B7FFA8AA2E83}"/>
+              </a:ext>
+            </a:extLst>
+          </p:cNvPr>
+          <p:cNvSpPr/>
+          <p:nvPr/>
+        </p:nvSpPr>
+        <p:spPr>
+          <a:xfrm>
+            <a:off x="3695308" y="2658359"/>
+            <a:ext cx="1357460" cy="377072"/>
+          </a:xfrm>
+          <a:prstGeom prst="rect">
+            <a:avLst/>
+          </a:prstGeom>
+          <a:noFill/>
+          <a:ln w="38100">
+            <a:solidFill>
+              <a:srgbClr val="FF0000"/>
+            </a:solidFill>
+          </a:ln>
+        </p:spPr>
+        <p:style>
+          <a:lnRef idx="2">
+            <a:schemeClr val="accent1">
+              <a:shade val="15000"/>
+            </a:schemeClr>
+          </a:lnRef>
+          <a:fillRef idx="1">
+            <a:schemeClr val="accent1"/>
+          </a:fillRef>
+          <a:effectRef idx="0">
+            <a:schemeClr val="accent1"/>
+          </a:effectRef>
+          <a:fontRef idx="minor">
+            <a:schemeClr val="lt1"/>
+          </a:fontRef>
+        </p:style>
+        <p:txBody>
+          <a:bodyPr rtlCol="0" anchor="ctr"/>
+          <a:lstStyle/>
+          <a:p>
+            <a:pPr algn="ctr"/>
+            <a:endParaRPr lang="en-US">
+              <a:ln w="0"/>
+              <a:solidFill>
+                <a:schemeClr val="tx1"/>
+              </a:solidFill>
+              <a:effectLst>
+                <a:outerShdw blurRad="38100" dist="19050" dir="2700000" algn="tl" rotWithShape="0">
+                  <a:schemeClr val="dk1">
+                    <a:alpha val="40000"/>
+                  </a:schemeClr>
+                </a:outerShdw>
+              </a:effectLst>
+            </a:endParaRPr>
+          </a:p>
+        </p:txBody>
+      </p:sp>
+    </p:spTree>
+    <p:extLst>
+      <p:ext uri="{BB962C8B-B14F-4D97-AF65-F5344CB8AC3E}">
+        <p14:creationId xmlns:p14="http://schemas.microsoft.com/office/powerpoint/2010/main" val="3653338779"/>
+      </p:ext>
+    </p:extLst>
+  </p:cSld>
+  <p:clrMapOvr>
+    <a:masterClrMapping/>
+  </p:clrMapOvr>
+</p:sld>
+</file>
+
+<file path=ppt/slides/slide18.xml><?xml version="1.0" encoding="utf-8"?>
+<p:sld xmlns:a="http://schemas.openxmlformats.org/drawingml/2006/main" xmlns:r="http://schemas.openxmlformats.org/officeDocument/2006/relationships" xmlns:p="http://schemas.openxmlformats.org/presentationml/2006/main">
+  <p:cSld>
+    <p:spTree>
+      <p:nvGrpSpPr>
+        <p:cNvPr id="1" name="">
+          <a:extLst>
+            <a:ext uri="{FF2B5EF4-FFF2-40B4-BE49-F238E27FC236}">
+              <a16:creationId xmlns:a16="http://schemas.microsoft.com/office/drawing/2014/main" id="{11B0CEE4-C842-147F-93DD-EE4B8EEA0F79}"/>
+            </a:ext>
+          </a:extLst>
+        </p:cNvPr>
+        <p:cNvGrpSpPr/>
+        <p:nvPr/>
+      </p:nvGrpSpPr>
+      <p:grpSpPr>
+        <a:xfrm>
+          <a:off x="0" y="0"/>
+          <a:ext cx="0" cy="0"/>
+          <a:chOff x="0" y="0"/>
+          <a:chExt cx="0" cy="0"/>
+        </a:xfrm>
+      </p:grpSpPr>
+      <p:sp>
+        <p:nvSpPr>
+          <p:cNvPr id="2" name="Title 1">
+            <a:extLst>
+              <a:ext uri="{FF2B5EF4-FFF2-40B4-BE49-F238E27FC236}">
+                <a16:creationId xmlns:a16="http://schemas.microsoft.com/office/drawing/2014/main" id="{555DF414-8003-021F-80E1-998F60EBA808}"/>
+              </a:ext>
+            </a:extLst>
+          </p:cNvPr>
+          <p:cNvSpPr>
+            <a:spLocks noGrp="1"/>
+          </p:cNvSpPr>
+          <p:nvPr>
+            <p:ph type="title"/>
+          </p:nvPr>
+        </p:nvSpPr>
+        <p:spPr/>
+        <p:txBody>
+          <a:bodyPr/>
+          <a:lstStyle/>
+          <a:p>
+            <a:r>
+              <a:rPr lang="en-CA" dirty="0"/>
+              <a:t>Copy Datasets</a:t>
+            </a:r>
+            <a:endParaRPr lang="en-US" dirty="0"/>
+          </a:p>
+        </p:txBody>
+      </p:sp>
+      <p:sp>
+        <p:nvSpPr>
+          <p:cNvPr id="3" name="Content Placeholder 2">
+            <a:extLst>
+              <a:ext uri="{FF2B5EF4-FFF2-40B4-BE49-F238E27FC236}">
+                <a16:creationId xmlns:a16="http://schemas.microsoft.com/office/drawing/2014/main" id="{3E4DE596-7C33-AA10-AB88-B649FA1EA5EE}"/>
+              </a:ext>
+            </a:extLst>
+          </p:cNvPr>
+          <p:cNvSpPr>
+            <a:spLocks noGrp="1"/>
+          </p:cNvSpPr>
+          <p:nvPr>
+            <p:ph idx="1"/>
+          </p:nvPr>
+        </p:nvSpPr>
+        <p:spPr/>
+        <p:txBody>
+          <a:bodyPr/>
+          <a:lstStyle/>
+          <a:p>
+            <a:r>
+              <a:rPr lang="en-US" dirty="0"/>
+              <a:t>Unmarked: None</a:t>
+            </a:r>
+          </a:p>
+        </p:txBody>
+      </p:sp>
+    </p:spTree>
+    <p:extLst>
+      <p:ext uri="{BB962C8B-B14F-4D97-AF65-F5344CB8AC3E}">
+        <p14:creationId xmlns:p14="http://schemas.microsoft.com/office/powerpoint/2010/main" val="3769516698"/>
+      </p:ext>
+    </p:extLst>
+  </p:cSld>
+  <p:clrMapOvr>
+    <a:masterClrMapping/>
+  </p:clrMapOvr>
+</p:sld>
+</file>
+
+<file path=ppt/slides/slide19.xml><?xml version="1.0" encoding="utf-8"?>
+<p:sld xmlns:a="http://schemas.openxmlformats.org/drawingml/2006/main" xmlns:r="http://schemas.openxmlformats.org/officeDocument/2006/relationships" xmlns:p="http://schemas.openxmlformats.org/presentationml/2006/main">
+  <p:cSld>
+    <p:spTree>
+      <p:nvGrpSpPr>
+        <p:cNvPr id="1" name=""/>
+        <p:cNvGrpSpPr/>
+        <p:nvPr/>
+      </p:nvGrpSpPr>
+      <p:grpSpPr>
+        <a:xfrm>
+          <a:off x="0" y="0"/>
+          <a:ext cx="0" cy="0"/>
+          <a:chOff x="0" y="0"/>
+          <a:chExt cx="0" cy="0"/>
+        </a:xfrm>
+      </p:grpSpPr>
+      <p:pic>
+        <p:nvPicPr>
+          <p:cNvPr id="5" name="Picture 4" descr="A screenshot of a computer&#10;&#10;AI-generated content may be incorrect.">
+            <a:extLst>
+              <a:ext uri="{FF2B5EF4-FFF2-40B4-BE49-F238E27FC236}">
+                <a16:creationId xmlns:a16="http://schemas.microsoft.com/office/drawing/2014/main" id="{B77F799D-8C4C-C678-3DA7-9A9EA024C7AF}"/>
+              </a:ext>
+            </a:extLst>
+          </p:cNvPr>
+          <p:cNvPicPr>
+            <a:picLocks noChangeAspect="1"/>
+          </p:cNvPicPr>
+          <p:nvPr/>
+        </p:nvPicPr>
+        <p:blipFill>
+          <a:blip r:embed="rId2">
+            <a:extLst>
+              <a:ext uri="{28A0092B-C50C-407E-A947-70E740481C1C}">
+                <a14:useLocalDpi xmlns:a14="http://schemas.microsoft.com/office/drawing/2010/main" val="0"/>
+              </a:ext>
+            </a:extLst>
+          </a:blip>
+          <a:stretch>
+            <a:fillRect/>
+          </a:stretch>
+        </p:blipFill>
+        <p:spPr>
+          <a:xfrm>
+            <a:off x="2066925" y="1295400"/>
+            <a:ext cx="8058150" cy="4267200"/>
+          </a:xfrm>
+          <a:prstGeom prst="rect">
+            <a:avLst/>
+          </a:prstGeom>
+        </p:spPr>
+      </p:pic>
+      <p:sp>
+        <p:nvSpPr>
+          <p:cNvPr id="6" name="Rectangle 5">
+            <a:extLst>
+              <a:ext uri="{FF2B5EF4-FFF2-40B4-BE49-F238E27FC236}">
+                <a16:creationId xmlns:a16="http://schemas.microsoft.com/office/drawing/2014/main" id="{31C033E4-ED0E-9E53-4D9F-9A89B0ADCAF5}"/>
+              </a:ext>
+            </a:extLst>
+          </p:cNvPr>
+          <p:cNvSpPr/>
+          <p:nvPr/>
+        </p:nvSpPr>
+        <p:spPr>
+          <a:xfrm>
+            <a:off x="9040305" y="5118755"/>
+            <a:ext cx="688157" cy="377072"/>
+          </a:xfrm>
+          <a:prstGeom prst="rect">
+            <a:avLst/>
+          </a:prstGeom>
+          <a:noFill/>
+          <a:ln w="38100">
+            <a:solidFill>
+              <a:srgbClr val="FF0000"/>
+            </a:solidFill>
+          </a:ln>
+        </p:spPr>
+        <p:style>
+          <a:lnRef idx="2">
+            <a:schemeClr val="accent1">
+              <a:shade val="15000"/>
+            </a:schemeClr>
+          </a:lnRef>
+          <a:fillRef idx="1">
+            <a:schemeClr val="accent1"/>
+          </a:fillRef>
+          <a:effectRef idx="0">
+            <a:schemeClr val="accent1"/>
+          </a:effectRef>
+          <a:fontRef idx="minor">
+            <a:schemeClr val="lt1"/>
+          </a:fontRef>
+        </p:style>
+        <p:txBody>
+          <a:bodyPr rtlCol="0" anchor="ctr"/>
+          <a:lstStyle/>
+          <a:p>
+            <a:pPr algn="ctr"/>
+            <a:endParaRPr lang="en-US">
+              <a:ln w="0"/>
+              <a:solidFill>
+                <a:schemeClr val="tx1"/>
+              </a:solidFill>
+              <a:effectLst>
+                <a:outerShdw blurRad="38100" dist="19050" dir="2700000" algn="tl" rotWithShape="0">
+                  <a:schemeClr val="dk1">
+                    <a:alpha val="40000"/>
+                  </a:schemeClr>
+                </a:outerShdw>
+              </a:effectLst>
+            </a:endParaRPr>
+          </a:p>
+        </p:txBody>
+      </p:sp>
+    </p:spTree>
+    <p:extLst>
+      <p:ext uri="{BB962C8B-B14F-4D97-AF65-F5344CB8AC3E}">
+        <p14:creationId xmlns:p14="http://schemas.microsoft.com/office/powerpoint/2010/main" val="804904445"/>
+      </p:ext>
+    </p:extLst>
+  </p:cSld>
+  <p:clrMapOvr>
+    <a:masterClrMapping/>
+  </p:clrMapOvr>
+</p:sld>
+</file>
+
+<file path=ppt/slides/slide2.xml><?xml version="1.0" encoding="utf-8"?>
+<p:sld xmlns:a="http://schemas.openxmlformats.org/drawingml/2006/main" xmlns:r="http://schemas.openxmlformats.org/officeDocument/2006/relationships" xmlns:p="http://schemas.openxmlformats.org/presentationml/2006/main">
+  <p:cSld>
+    <p:spTree>
+      <p:nvGrpSpPr>
+        <p:cNvPr id="1" name=""/>
+        <p:cNvGrpSpPr/>
+        <p:nvPr/>
+      </p:nvGrpSpPr>
+      <p:grpSpPr>
+        <a:xfrm>
+          <a:off x="0" y="0"/>
+          <a:ext cx="0" cy="0"/>
+          <a:chOff x="0" y="0"/>
+          <a:chExt cx="0" cy="0"/>
+        </a:xfrm>
+      </p:grpSpPr>
+      <p:pic>
+        <p:nvPicPr>
+          <p:cNvPr id="5" name="Picture 4">
+            <a:extLst>
+              <a:ext uri="{FF2B5EF4-FFF2-40B4-BE49-F238E27FC236}">
+                <a16:creationId xmlns:a16="http://schemas.microsoft.com/office/drawing/2014/main" id="{B97F010C-709D-B042-411F-8C6D7807055A}"/>
+              </a:ext>
+            </a:extLst>
+          </p:cNvPr>
+          <p:cNvPicPr>
+            <a:picLocks noChangeAspect="1"/>
+          </p:cNvPicPr>
+          <p:nvPr/>
+        </p:nvPicPr>
+        <p:blipFill>
+          <a:blip r:embed="rId2"/>
+          <a:stretch>
+            <a:fillRect/>
+          </a:stretch>
+        </p:blipFill>
+        <p:spPr>
+          <a:xfrm>
+            <a:off x="461176" y="113837"/>
+            <a:ext cx="11269648" cy="6630325"/>
+          </a:xfrm>
+          <a:prstGeom prst="rect">
+            <a:avLst/>
+          </a:prstGeom>
+        </p:spPr>
+      </p:pic>
+    </p:spTree>
+    <p:extLst>
+      <p:ext uri="{BB962C8B-B14F-4D97-AF65-F5344CB8AC3E}">
+        <p14:creationId xmlns:p14="http://schemas.microsoft.com/office/powerpoint/2010/main" val="837334526"/>
+      </p:ext>
+    </p:extLst>
+  </p:cSld>
+  <p:clrMapOvr>
+    <a:masterClrMapping/>
+  </p:clrMapOvr>
+</p:sld>
+</file>
+
+<file path=ppt/slides/slide20.xml><?xml version="1.0" encoding="utf-8"?>
+<p:sld xmlns:a="http://schemas.openxmlformats.org/drawingml/2006/main" xmlns:r="http://schemas.openxmlformats.org/officeDocument/2006/relationships" xmlns:p="http://schemas.openxmlformats.org/presentationml/2006/main">
+  <p:cSld>
+    <p:spTree>
+      <p:nvGrpSpPr>
         <p:cNvPr id="1" name="">
           <a:extLst>
             <a:ext uri="{FF2B5EF4-FFF2-40B4-BE49-F238E27FC236}">
@@ -5920,7 +6806,7 @@
 </p:sld>
 </file>
 
-<file path=ppt/slides/slide16.xml><?xml version="1.0" encoding="utf-8"?>
+<file path=ppt/slides/slide21.xml><?xml version="1.0" encoding="utf-8"?>
 <p:sld xmlns:a="http://schemas.openxmlformats.org/drawingml/2006/main" xmlns:r="http://schemas.openxmlformats.org/officeDocument/2006/relationships" xmlns:p="http://schemas.openxmlformats.org/presentationml/2006/main">
   <p:cSld>
     <p:spTree>
@@ -6393,66 +7279,6 @@
     <p:extLst>
       <p:ext uri="{BB962C8B-B14F-4D97-AF65-F5344CB8AC3E}">
         <p14:creationId xmlns:p14="http://schemas.microsoft.com/office/powerpoint/2010/main" val="2371670190"/>
-      </p:ext>
-    </p:extLst>
-  </p:cSld>
-  <p:clrMapOvr>
-    <a:masterClrMapping/>
-  </p:clrMapOvr>
-</p:sld>
-</file>
-
-<file path=ppt/slides/slide2.xml><?xml version="1.0" encoding="utf-8"?>
-<p:sld xmlns:a="http://schemas.openxmlformats.org/drawingml/2006/main" xmlns:r="http://schemas.openxmlformats.org/officeDocument/2006/relationships" xmlns:p="http://schemas.openxmlformats.org/presentationml/2006/main">
-  <p:cSld>
-    <p:spTree>
-      <p:nvGrpSpPr>
-        <p:cNvPr id="1" name=""/>
-        <p:cNvGrpSpPr/>
-        <p:nvPr/>
-      </p:nvGrpSpPr>
-      <p:grpSpPr>
-        <a:xfrm>
-          <a:off x="0" y="0"/>
-          <a:ext cx="0" cy="0"/>
-          <a:chOff x="0" y="0"/>
-          <a:chExt cx="0" cy="0"/>
-        </a:xfrm>
-      </p:grpSpPr>
-      <p:pic>
-        <p:nvPicPr>
-          <p:cNvPr id="5" name="Picture 4">
-            <a:extLst>
-              <a:ext uri="{FF2B5EF4-FFF2-40B4-BE49-F238E27FC236}">
-                <a16:creationId xmlns:a16="http://schemas.microsoft.com/office/drawing/2014/main" id="{B97F010C-709D-B042-411F-8C6D7807055A}"/>
-              </a:ext>
-            </a:extLst>
-          </p:cNvPr>
-          <p:cNvPicPr>
-            <a:picLocks noChangeAspect="1"/>
-          </p:cNvPicPr>
-          <p:nvPr/>
-        </p:nvPicPr>
-        <p:blipFill>
-          <a:blip r:embed="rId2"/>
-          <a:stretch>
-            <a:fillRect/>
-          </a:stretch>
-        </p:blipFill>
-        <p:spPr>
-          <a:xfrm>
-            <a:off x="461176" y="113837"/>
-            <a:ext cx="11269648" cy="6630325"/>
-          </a:xfrm>
-          <a:prstGeom prst="rect">
-            <a:avLst/>
-          </a:prstGeom>
-        </p:spPr>
-      </p:pic>
-    </p:spTree>
-    <p:extLst>
-      <p:ext uri="{BB962C8B-B14F-4D97-AF65-F5344CB8AC3E}">
-        <p14:creationId xmlns:p14="http://schemas.microsoft.com/office/powerpoint/2010/main" val="837334526"/>
       </p:ext>
     </p:extLst>
   </p:cSld>

</xml_diff>

<commit_message>
EDGEAI-544: Maivin quickstart implementations
- Added copy dataset content from the discrete docs
- Added tag dataset instructions that proceeds after copy dataset in the Getting Started and the Platform quickstarts
- Added instructions for training models
- Started adding instructions for validation (WIP)
- Many of the screenshots are quick out of date due to the recent changes in EdgeFirst Studio (WIP)

Signed-off-by: John Santos <john.s@au-zone.com>
</commit_message>
<xml_diff>
--- a/images_with_layers.pptx
+++ b/images_with_layers.pptx
@@ -5,7 +5,7 @@
     <p:sldMasterId id="2147483648" r:id="rId1"/>
   </p:sldMasterIdLst>
   <p:notesMasterIdLst>
-    <p:notesMasterId r:id="rId23"/>
+    <p:notesMasterId r:id="rId26"/>
   </p:notesMasterIdLst>
   <p:sldIdLst>
     <p:sldId id="264" r:id="rId2"/>
@@ -27,8 +27,11 @@
     <p:sldId id="275" r:id="rId18"/>
     <p:sldId id="278" r:id="rId19"/>
     <p:sldId id="279" r:id="rId20"/>
-    <p:sldId id="262" r:id="rId21"/>
-    <p:sldId id="260" r:id="rId22"/>
+    <p:sldId id="280" r:id="rId21"/>
+    <p:sldId id="281" r:id="rId22"/>
+    <p:sldId id="282" r:id="rId23"/>
+    <p:sldId id="262" r:id="rId24"/>
+    <p:sldId id="260" r:id="rId25"/>
   </p:sldIdLst>
   <p:sldSz cx="12192000" cy="6858000"/>
   <p:notesSz cx="6858000" cy="9144000"/>
@@ -179,6 +182,13 @@
           <p14:sldIdLst>
             <p14:sldId id="278"/>
             <p14:sldId id="279"/>
+          </p14:sldIdLst>
+        </p14:section>
+        <p14:section name="Dataset History" id="{A3A0C823-0623-4EE2-B68E-8D6D6B7F2198}">
+          <p14:sldIdLst>
+            <p14:sldId id="280"/>
+            <p14:sldId id="281"/>
+            <p14:sldId id="282"/>
           </p14:sldIdLst>
         </p14:section>
         <p14:section name="Dataset Gallery" id="{69866AF7-968C-4F26-9ECA-AA64F6FFB6E8}">
@@ -688,7 +698,7 @@
           <a:p>
             <a:fld id="{E487E608-D9C6-4B3C-A9A4-BEAD08ECA06D}" type="datetimeFigureOut">
               <a:rPr lang="en-US" smtClean="0"/>
-              <a:t>11/26/2025</a:t>
+              <a:t>3/19/2026</a:t>
             </a:fld>
             <a:endParaRPr lang="en-US"/>
           </a:p>
@@ -2090,7 +2100,7 @@
           <a:p>
             <a:fld id="{874397DF-5812-45E4-B5F0-BF2AEB9BFE48}" type="slidenum">
               <a:rPr lang="en-US" smtClean="0"/>
-              <a:t>21</a:t>
+              <a:t>24</a:t>
             </a:fld>
             <a:endParaRPr lang="en-US"/>
           </a:p>
@@ -2256,7 +2266,7 @@
           <a:p>
             <a:fld id="{D241CDF3-A1FB-4215-9C3B-B36887AAFAD2}" type="datetimeFigureOut">
               <a:rPr lang="en-US" smtClean="0"/>
-              <a:t>11/26/2025</a:t>
+              <a:t>3/19/2026</a:t>
             </a:fld>
             <a:endParaRPr lang="en-US"/>
           </a:p>
@@ -2454,7 +2464,7 @@
           <a:p>
             <a:fld id="{D241CDF3-A1FB-4215-9C3B-B36887AAFAD2}" type="datetimeFigureOut">
               <a:rPr lang="en-US" smtClean="0"/>
-              <a:t>11/26/2025</a:t>
+              <a:t>3/19/2026</a:t>
             </a:fld>
             <a:endParaRPr lang="en-US"/>
           </a:p>
@@ -2662,7 +2672,7 @@
           <a:p>
             <a:fld id="{D241CDF3-A1FB-4215-9C3B-B36887AAFAD2}" type="datetimeFigureOut">
               <a:rPr lang="en-US" smtClean="0"/>
-              <a:t>11/26/2025</a:t>
+              <a:t>3/19/2026</a:t>
             </a:fld>
             <a:endParaRPr lang="en-US"/>
           </a:p>
@@ -2860,7 +2870,7 @@
           <a:p>
             <a:fld id="{D241CDF3-A1FB-4215-9C3B-B36887AAFAD2}" type="datetimeFigureOut">
               <a:rPr lang="en-US" smtClean="0"/>
-              <a:t>11/26/2025</a:t>
+              <a:t>3/19/2026</a:t>
             </a:fld>
             <a:endParaRPr lang="en-US"/>
           </a:p>
@@ -3135,7 +3145,7 @@
           <a:p>
             <a:fld id="{D241CDF3-A1FB-4215-9C3B-B36887AAFAD2}" type="datetimeFigureOut">
               <a:rPr lang="en-US" smtClean="0"/>
-              <a:t>11/26/2025</a:t>
+              <a:t>3/19/2026</a:t>
             </a:fld>
             <a:endParaRPr lang="en-US"/>
           </a:p>
@@ -3400,7 +3410,7 @@
           <a:p>
             <a:fld id="{D241CDF3-A1FB-4215-9C3B-B36887AAFAD2}" type="datetimeFigureOut">
               <a:rPr lang="en-US" smtClean="0"/>
-              <a:t>11/26/2025</a:t>
+              <a:t>3/19/2026</a:t>
             </a:fld>
             <a:endParaRPr lang="en-US"/>
           </a:p>
@@ -3812,7 +3822,7 @@
           <a:p>
             <a:fld id="{D241CDF3-A1FB-4215-9C3B-B36887AAFAD2}" type="datetimeFigureOut">
               <a:rPr lang="en-US" smtClean="0"/>
-              <a:t>11/26/2025</a:t>
+              <a:t>3/19/2026</a:t>
             </a:fld>
             <a:endParaRPr lang="en-US"/>
           </a:p>
@@ -3953,7 +3963,7 @@
           <a:p>
             <a:fld id="{D241CDF3-A1FB-4215-9C3B-B36887AAFAD2}" type="datetimeFigureOut">
               <a:rPr lang="en-US" smtClean="0"/>
-              <a:t>11/26/2025</a:t>
+              <a:t>3/19/2026</a:t>
             </a:fld>
             <a:endParaRPr lang="en-US"/>
           </a:p>
@@ -4066,7 +4076,7 @@
           <a:p>
             <a:fld id="{D241CDF3-A1FB-4215-9C3B-B36887AAFAD2}" type="datetimeFigureOut">
               <a:rPr lang="en-US" smtClean="0"/>
-              <a:t>11/26/2025</a:t>
+              <a:t>3/19/2026</a:t>
             </a:fld>
             <a:endParaRPr lang="en-US"/>
           </a:p>
@@ -4377,7 +4387,7 @@
           <a:p>
             <a:fld id="{D241CDF3-A1FB-4215-9C3B-B36887AAFAD2}" type="datetimeFigureOut">
               <a:rPr lang="en-US" smtClean="0"/>
-              <a:t>11/26/2025</a:t>
+              <a:t>3/19/2026</a:t>
             </a:fld>
             <a:endParaRPr lang="en-US"/>
           </a:p>
@@ -4665,7 +4675,7 @@
           <a:p>
             <a:fld id="{D241CDF3-A1FB-4215-9C3B-B36887AAFAD2}" type="datetimeFigureOut">
               <a:rPr lang="en-US" smtClean="0"/>
-              <a:t>11/26/2025</a:t>
+              <a:t>3/19/2026</a:t>
             </a:fld>
             <a:endParaRPr lang="en-US"/>
           </a:p>
@@ -4906,7 +4916,7 @@
           <a:p>
             <a:fld id="{D241CDF3-A1FB-4215-9C3B-B36887AAFAD2}" type="datetimeFigureOut">
               <a:rPr lang="en-US" smtClean="0"/>
-              <a:t>11/26/2025</a:t>
+              <a:t>3/19/2026</a:t>
             </a:fld>
             <a:endParaRPr lang="en-US"/>
           </a:p>
@@ -6713,6 +6723,340 @@
   <p:cSld>
     <p:spTree>
       <p:nvGrpSpPr>
+        <p:cNvPr id="1" name=""/>
+        <p:cNvGrpSpPr/>
+        <p:nvPr/>
+      </p:nvGrpSpPr>
+      <p:grpSpPr>
+        <a:xfrm>
+          <a:off x="0" y="0"/>
+          <a:ext cx="0" cy="0"/>
+          <a:chOff x="0" y="0"/>
+          <a:chExt cx="0" cy="0"/>
+        </a:xfrm>
+      </p:grpSpPr>
+      <p:sp>
+        <p:nvSpPr>
+          <p:cNvPr id="2" name="Title 1">
+            <a:extLst>
+              <a:ext uri="{FF2B5EF4-FFF2-40B4-BE49-F238E27FC236}">
+                <a16:creationId xmlns:a16="http://schemas.microsoft.com/office/drawing/2014/main" id="{4677D5C4-9CC6-8AF6-DD54-4EF6AFF9CBA6}"/>
+              </a:ext>
+            </a:extLst>
+          </p:cNvPr>
+          <p:cNvSpPr>
+            <a:spLocks noGrp="1"/>
+          </p:cNvSpPr>
+          <p:nvPr>
+            <p:ph type="title"/>
+          </p:nvPr>
+        </p:nvSpPr>
+        <p:spPr/>
+        <p:txBody>
+          <a:bodyPr/>
+          <a:lstStyle/>
+          <a:p>
+            <a:r>
+              <a:rPr lang="en-US" dirty="0"/>
+              <a:t>Dataset History</a:t>
+            </a:r>
+          </a:p>
+        </p:txBody>
+      </p:sp>
+      <p:sp>
+        <p:nvSpPr>
+          <p:cNvPr id="3" name="Content Placeholder 2">
+            <a:extLst>
+              <a:ext uri="{FF2B5EF4-FFF2-40B4-BE49-F238E27FC236}">
+                <a16:creationId xmlns:a16="http://schemas.microsoft.com/office/drawing/2014/main" id="{7853F840-CD8B-1F82-7DF8-F9F3BB1A7118}"/>
+              </a:ext>
+            </a:extLst>
+          </p:cNvPr>
+          <p:cNvSpPr>
+            <a:spLocks noGrp="1"/>
+          </p:cNvSpPr>
+          <p:nvPr>
+            <p:ph idx="1"/>
+          </p:nvPr>
+        </p:nvSpPr>
+        <p:spPr/>
+        <p:txBody>
+          <a:bodyPr/>
+          <a:lstStyle/>
+          <a:p>
+            <a:r>
+              <a:rPr lang="en-US" dirty="0"/>
+              <a:t>Unmarked: None</a:t>
+            </a:r>
+          </a:p>
+        </p:txBody>
+      </p:sp>
+    </p:spTree>
+    <p:extLst>
+      <p:ext uri="{BB962C8B-B14F-4D97-AF65-F5344CB8AC3E}">
+        <p14:creationId xmlns:p14="http://schemas.microsoft.com/office/powerpoint/2010/main" val="1418877214"/>
+      </p:ext>
+    </p:extLst>
+  </p:cSld>
+  <p:clrMapOvr>
+    <a:masterClrMapping/>
+  </p:clrMapOvr>
+</p:sld>
+</file>
+
+<file path=ppt/slides/slide21.xml><?xml version="1.0" encoding="utf-8"?>
+<p:sld xmlns:a="http://schemas.openxmlformats.org/drawingml/2006/main" xmlns:r="http://schemas.openxmlformats.org/officeDocument/2006/relationships" xmlns:p="http://schemas.openxmlformats.org/presentationml/2006/main">
+  <p:cSld>
+    <p:spTree>
+      <p:nvGrpSpPr>
+        <p:cNvPr id="1" name=""/>
+        <p:cNvGrpSpPr/>
+        <p:nvPr/>
+      </p:nvGrpSpPr>
+      <p:grpSpPr>
+        <a:xfrm>
+          <a:off x="0" y="0"/>
+          <a:ext cx="0" cy="0"/>
+          <a:chOff x="0" y="0"/>
+          <a:chExt cx="0" cy="0"/>
+        </a:xfrm>
+      </p:grpSpPr>
+      <p:pic>
+        <p:nvPicPr>
+          <p:cNvPr id="5" name="Picture 4">
+            <a:extLst>
+              <a:ext uri="{FF2B5EF4-FFF2-40B4-BE49-F238E27FC236}">
+                <a16:creationId xmlns:a16="http://schemas.microsoft.com/office/drawing/2014/main" id="{20B84CB2-3872-F5A4-BA84-6FB27BE1CBC3}"/>
+              </a:ext>
+            </a:extLst>
+          </p:cNvPr>
+          <p:cNvPicPr>
+            <a:picLocks noChangeAspect="1"/>
+          </p:cNvPicPr>
+          <p:nvPr/>
+        </p:nvPicPr>
+        <p:blipFill>
+          <a:blip r:embed="rId2"/>
+          <a:stretch>
+            <a:fillRect/>
+          </a:stretch>
+        </p:blipFill>
+        <p:spPr>
+          <a:xfrm>
+            <a:off x="0" y="1546225"/>
+            <a:ext cx="12192000" cy="3765550"/>
+          </a:xfrm>
+          <a:prstGeom prst="rect">
+            <a:avLst/>
+          </a:prstGeom>
+        </p:spPr>
+      </p:pic>
+      <p:sp>
+        <p:nvSpPr>
+          <p:cNvPr id="6" name="Rectangle 5">
+            <a:extLst>
+              <a:ext uri="{FF2B5EF4-FFF2-40B4-BE49-F238E27FC236}">
+                <a16:creationId xmlns:a16="http://schemas.microsoft.com/office/drawing/2014/main" id="{EB711F0D-348B-44FC-7B67-D2B920A1BD40}"/>
+              </a:ext>
+            </a:extLst>
+          </p:cNvPr>
+          <p:cNvSpPr/>
+          <p:nvPr/>
+        </p:nvSpPr>
+        <p:spPr>
+          <a:xfrm>
+            <a:off x="11569148" y="3240464"/>
+            <a:ext cx="345922" cy="317745"/>
+          </a:xfrm>
+          <a:prstGeom prst="rect">
+            <a:avLst/>
+          </a:prstGeom>
+          <a:noFill/>
+          <a:ln w="38100">
+            <a:solidFill>
+              <a:srgbClr val="FF0000"/>
+            </a:solidFill>
+          </a:ln>
+        </p:spPr>
+        <p:style>
+          <a:lnRef idx="2">
+            <a:schemeClr val="accent1">
+              <a:shade val="15000"/>
+            </a:schemeClr>
+          </a:lnRef>
+          <a:fillRef idx="1">
+            <a:schemeClr val="accent1"/>
+          </a:fillRef>
+          <a:effectRef idx="0">
+            <a:schemeClr val="accent1"/>
+          </a:effectRef>
+          <a:fontRef idx="minor">
+            <a:schemeClr val="lt1"/>
+          </a:fontRef>
+        </p:style>
+        <p:txBody>
+          <a:bodyPr rtlCol="0" anchor="ctr"/>
+          <a:lstStyle/>
+          <a:p>
+            <a:pPr algn="ctr"/>
+            <a:endParaRPr lang="en-US">
+              <a:ln w="0"/>
+              <a:solidFill>
+                <a:schemeClr val="tx1"/>
+              </a:solidFill>
+              <a:effectLst>
+                <a:outerShdw blurRad="38100" dist="19050" dir="2700000" algn="tl" rotWithShape="0">
+                  <a:schemeClr val="dk1">
+                    <a:alpha val="40000"/>
+                  </a:schemeClr>
+                </a:outerShdw>
+              </a:effectLst>
+            </a:endParaRPr>
+          </a:p>
+        </p:txBody>
+      </p:sp>
+    </p:spTree>
+    <p:extLst>
+      <p:ext uri="{BB962C8B-B14F-4D97-AF65-F5344CB8AC3E}">
+        <p14:creationId xmlns:p14="http://schemas.microsoft.com/office/powerpoint/2010/main" val="112309044"/>
+      </p:ext>
+    </p:extLst>
+  </p:cSld>
+  <p:clrMapOvr>
+    <a:masterClrMapping/>
+  </p:clrMapOvr>
+</p:sld>
+</file>
+
+<file path=ppt/slides/slide22.xml><?xml version="1.0" encoding="utf-8"?>
+<p:sld xmlns:a="http://schemas.openxmlformats.org/drawingml/2006/main" xmlns:r="http://schemas.openxmlformats.org/officeDocument/2006/relationships" xmlns:p="http://schemas.openxmlformats.org/presentationml/2006/main">
+  <p:cSld>
+    <p:spTree>
+      <p:nvGrpSpPr>
+        <p:cNvPr id="1" name=""/>
+        <p:cNvGrpSpPr/>
+        <p:nvPr/>
+      </p:nvGrpSpPr>
+      <p:grpSpPr>
+        <a:xfrm>
+          <a:off x="0" y="0"/>
+          <a:ext cx="0" cy="0"/>
+          <a:chOff x="0" y="0"/>
+          <a:chExt cx="0" cy="0"/>
+        </a:xfrm>
+      </p:grpSpPr>
+      <p:pic>
+        <p:nvPicPr>
+          <p:cNvPr id="5" name="Picture 4">
+            <a:extLst>
+              <a:ext uri="{FF2B5EF4-FFF2-40B4-BE49-F238E27FC236}">
+                <a16:creationId xmlns:a16="http://schemas.microsoft.com/office/drawing/2014/main" id="{A26D9574-9C18-855F-3E4D-833597A68E46}"/>
+              </a:ext>
+            </a:extLst>
+          </p:cNvPr>
+          <p:cNvPicPr>
+            <a:picLocks noChangeAspect="1"/>
+          </p:cNvPicPr>
+          <p:nvPr/>
+        </p:nvPicPr>
+        <p:blipFill>
+          <a:blip r:embed="rId2"/>
+          <a:stretch>
+            <a:fillRect/>
+          </a:stretch>
+        </p:blipFill>
+        <p:spPr>
+          <a:xfrm>
+            <a:off x="3128548" y="1109339"/>
+            <a:ext cx="5934903" cy="4639322"/>
+          </a:xfrm>
+          <a:prstGeom prst="rect">
+            <a:avLst/>
+          </a:prstGeom>
+        </p:spPr>
+      </p:pic>
+      <p:sp>
+        <p:nvSpPr>
+          <p:cNvPr id="6" name="Rectangle 5">
+            <a:extLst>
+              <a:ext uri="{FF2B5EF4-FFF2-40B4-BE49-F238E27FC236}">
+                <a16:creationId xmlns:a16="http://schemas.microsoft.com/office/drawing/2014/main" id="{6045A54F-0EDF-9B04-A80C-05D95E748D22}"/>
+              </a:ext>
+            </a:extLst>
+          </p:cNvPr>
+          <p:cNvSpPr/>
+          <p:nvPr/>
+        </p:nvSpPr>
+        <p:spPr>
+          <a:xfrm>
+            <a:off x="7613373" y="5109020"/>
+            <a:ext cx="1272209" cy="496650"/>
+          </a:xfrm>
+          <a:prstGeom prst="rect">
+            <a:avLst/>
+          </a:prstGeom>
+          <a:noFill/>
+          <a:ln w="38100">
+            <a:solidFill>
+              <a:srgbClr val="FF0000"/>
+            </a:solidFill>
+          </a:ln>
+        </p:spPr>
+        <p:style>
+          <a:lnRef idx="2">
+            <a:schemeClr val="accent1">
+              <a:shade val="15000"/>
+            </a:schemeClr>
+          </a:lnRef>
+          <a:fillRef idx="1">
+            <a:schemeClr val="accent1"/>
+          </a:fillRef>
+          <a:effectRef idx="0">
+            <a:schemeClr val="accent1"/>
+          </a:effectRef>
+          <a:fontRef idx="minor">
+            <a:schemeClr val="lt1"/>
+          </a:fontRef>
+        </p:style>
+        <p:txBody>
+          <a:bodyPr rtlCol="0" anchor="ctr"/>
+          <a:lstStyle/>
+          <a:p>
+            <a:pPr algn="ctr"/>
+            <a:endParaRPr lang="en-US">
+              <a:ln w="0"/>
+              <a:solidFill>
+                <a:schemeClr val="tx1"/>
+              </a:solidFill>
+              <a:effectLst>
+                <a:outerShdw blurRad="38100" dist="19050" dir="2700000" algn="tl" rotWithShape="0">
+                  <a:schemeClr val="dk1">
+                    <a:alpha val="40000"/>
+                  </a:schemeClr>
+                </a:outerShdw>
+              </a:effectLst>
+            </a:endParaRPr>
+          </a:p>
+        </p:txBody>
+      </p:sp>
+    </p:spTree>
+    <p:extLst>
+      <p:ext uri="{BB962C8B-B14F-4D97-AF65-F5344CB8AC3E}">
+        <p14:creationId xmlns:p14="http://schemas.microsoft.com/office/powerpoint/2010/main" val="222030758"/>
+      </p:ext>
+    </p:extLst>
+  </p:cSld>
+  <p:clrMapOvr>
+    <a:masterClrMapping/>
+  </p:clrMapOvr>
+</p:sld>
+</file>
+
+<file path=ppt/slides/slide23.xml><?xml version="1.0" encoding="utf-8"?>
+<p:sld xmlns:a="http://schemas.openxmlformats.org/drawingml/2006/main" xmlns:r="http://schemas.openxmlformats.org/officeDocument/2006/relationships" xmlns:p="http://schemas.openxmlformats.org/presentationml/2006/main">
+  <p:cSld>
+    <p:spTree>
+      <p:nvGrpSpPr>
         <p:cNvPr id="1" name="">
           <a:extLst>
             <a:ext uri="{FF2B5EF4-FFF2-40B4-BE49-F238E27FC236}">
@@ -6806,7 +7150,7 @@
 </p:sld>
 </file>
 
-<file path=ppt/slides/slide21.xml><?xml version="1.0" encoding="utf-8"?>
+<file path=ppt/slides/slide24.xml><?xml version="1.0" encoding="utf-8"?>
 <p:sld xmlns:a="http://schemas.openxmlformats.org/drawingml/2006/main" xmlns:r="http://schemas.openxmlformats.org/officeDocument/2006/relationships" xmlns:p="http://schemas.openxmlformats.org/presentationml/2006/main">
   <p:cSld>
     <p:spTree>

</xml_diff>